<commit_message>
Show students how to open the Week 4 Colab notebook
</commit_message>
<xml_diff>
--- a/week-04-foundations-cloud/slides/week-04-colab-workshop.pptx
+++ b/week-04-foundations-cloud/slides/week-04-colab-workshop.pptx
@@ -2,29 +2,29 @@
 <file path=ppt/presentation.xml><?xml version="1.0" encoding="utf-8"?>
 <p:presentation xmlns:p="http://schemas.openxmlformats.org/presentationml/2006/main">
   <p:sldMasterIdLst>
-    <p:sldMasterId xmlns:r="http://schemas.openxmlformats.org/officeDocument/2006/relationships" id="2147483648" r:id="Rce395e822ba748c6"/>
+    <p:sldMasterId xmlns:r="http://schemas.openxmlformats.org/officeDocument/2006/relationships" id="2147483648" r:id="Ra3e80308e5a746fe"/>
   </p:sldMasterIdLst>
   <p:notesMasterIdLst>
-    <p:notesMasterId xmlns:r="http://schemas.openxmlformats.org/officeDocument/2006/relationships" r:id="R0b998d4dd67d4777"/>
+    <p:notesMasterId xmlns:r="http://schemas.openxmlformats.org/officeDocument/2006/relationships" r:id="R99dd66aa380b4756"/>
   </p:notesMasterIdLst>
   <p:sldIdLst>
-    <p:sldId xmlns:r="http://schemas.openxmlformats.org/officeDocument/2006/relationships" id="256" r:id="R39c9ddf3a3e2487e"/>
-    <p:sldId xmlns:r="http://schemas.openxmlformats.org/officeDocument/2006/relationships" id="257" r:id="Rc3185e5857af4a93"/>
-    <p:sldId xmlns:r="http://schemas.openxmlformats.org/officeDocument/2006/relationships" id="258" r:id="Rf850147fdea54f7f"/>
-    <p:sldId xmlns:r="http://schemas.openxmlformats.org/officeDocument/2006/relationships" id="259" r:id="Rb9f2020ab98e4eea"/>
-    <p:sldId xmlns:r="http://schemas.openxmlformats.org/officeDocument/2006/relationships" id="260" r:id="R121511a27a524fdc"/>
-    <p:sldId xmlns:r="http://schemas.openxmlformats.org/officeDocument/2006/relationships" id="261" r:id="R85cab25393b240f2"/>
-    <p:sldId xmlns:r="http://schemas.openxmlformats.org/officeDocument/2006/relationships" id="262" r:id="Rcaaef4e624f44fc4"/>
-    <p:sldId xmlns:r="http://schemas.openxmlformats.org/officeDocument/2006/relationships" id="263" r:id="Rbdd66004847c4837"/>
-    <p:sldId xmlns:r="http://schemas.openxmlformats.org/officeDocument/2006/relationships" id="264" r:id="Rd46a7a4926884753"/>
-    <p:sldId xmlns:r="http://schemas.openxmlformats.org/officeDocument/2006/relationships" id="265" r:id="R227a2383e5c34f47"/>
-    <p:sldId xmlns:r="http://schemas.openxmlformats.org/officeDocument/2006/relationships" id="266" r:id="R7b5cfb5fe4d649cd"/>
-    <p:sldId xmlns:r="http://schemas.openxmlformats.org/officeDocument/2006/relationships" id="267" r:id="R92f1bc60ca134cf7"/>
-    <p:sldId xmlns:r="http://schemas.openxmlformats.org/officeDocument/2006/relationships" id="268" r:id="R2c455414950c4882"/>
-    <p:sldId xmlns:r="http://schemas.openxmlformats.org/officeDocument/2006/relationships" id="269" r:id="Rae29898fe1de465b"/>
-    <p:sldId xmlns:r="http://schemas.openxmlformats.org/officeDocument/2006/relationships" id="270" r:id="R8e82d48033134ff9"/>
-    <p:sldId xmlns:r="http://schemas.openxmlformats.org/officeDocument/2006/relationships" id="271" r:id="Rc2e11d884cca4f6d"/>
-    <p:sldId xmlns:r="http://schemas.openxmlformats.org/officeDocument/2006/relationships" id="272" r:id="Rede84a7769db49f1"/>
+    <p:sldId xmlns:r="http://schemas.openxmlformats.org/officeDocument/2006/relationships" id="256" r:id="Rbda7d531f9b94f8e"/>
+    <p:sldId xmlns:r="http://schemas.openxmlformats.org/officeDocument/2006/relationships" id="257" r:id="R0003ba676fde4c5b"/>
+    <p:sldId xmlns:r="http://schemas.openxmlformats.org/officeDocument/2006/relationships" id="258" r:id="R365c04da87f44539"/>
+    <p:sldId xmlns:r="http://schemas.openxmlformats.org/officeDocument/2006/relationships" id="259" r:id="Ree1945b50850495d"/>
+    <p:sldId xmlns:r="http://schemas.openxmlformats.org/officeDocument/2006/relationships" id="260" r:id="Ra72011ff606a4f03"/>
+    <p:sldId xmlns:r="http://schemas.openxmlformats.org/officeDocument/2006/relationships" id="261" r:id="Re003cd68d1bd43b5"/>
+    <p:sldId xmlns:r="http://schemas.openxmlformats.org/officeDocument/2006/relationships" id="262" r:id="Ra8d19871ff854167"/>
+    <p:sldId xmlns:r="http://schemas.openxmlformats.org/officeDocument/2006/relationships" id="263" r:id="R1e930b7201634394"/>
+    <p:sldId xmlns:r="http://schemas.openxmlformats.org/officeDocument/2006/relationships" id="264" r:id="R22ffc86e1b834d22"/>
+    <p:sldId xmlns:r="http://schemas.openxmlformats.org/officeDocument/2006/relationships" id="265" r:id="R24f69a797d474f5d"/>
+    <p:sldId xmlns:r="http://schemas.openxmlformats.org/officeDocument/2006/relationships" id="266" r:id="Rac0d90cfe8d94648"/>
+    <p:sldId xmlns:r="http://schemas.openxmlformats.org/officeDocument/2006/relationships" id="267" r:id="R81fe125420b544ec"/>
+    <p:sldId xmlns:r="http://schemas.openxmlformats.org/officeDocument/2006/relationships" id="268" r:id="Ra83249f033734ee5"/>
+    <p:sldId xmlns:r="http://schemas.openxmlformats.org/officeDocument/2006/relationships" id="269" r:id="R2a85f817b041408d"/>
+    <p:sldId xmlns:r="http://schemas.openxmlformats.org/officeDocument/2006/relationships" id="270" r:id="Rec40fe4f913a4cda"/>
+    <p:sldId xmlns:r="http://schemas.openxmlformats.org/officeDocument/2006/relationships" id="271" r:id="Rb50f58721a144180"/>
+    <p:sldId xmlns:r="http://schemas.openxmlformats.org/officeDocument/2006/relationships" id="272" r:id="R89cee37f46c6495e"/>
   </p:sldIdLst>
   <p:sldSz cx="12192000" cy="6858000"/>
   <p:notesSz cx="6858000" cy="9144000"/>
@@ -528,7 +528,7 @@
           <a:lstStyle xmlns:a="http://schemas.openxmlformats.org/drawingml/2006/main"/>
           <a:p xmlns:a="http://schemas.openxmlformats.org/drawingml/2006/main">
             <a:r>
-              <a:t>Share https://colab.research.google.com/github/lhernandez-sudo/project-syncere-cs-2027/blob/main/week-04-foundations-cloud/exercises/foundations-review.ipynb. Confirm every student sees Notebook ready before moving on.</a:t>
+              <a:t>Direct Colab link: https://colab.research.google.com/github/lhernandez-sudo/project-syncere-cs-2027/blob/main/week-04-foundations-cloud/exercises/foundations-review.ipynb. The course repository and Week 4 README both display a prominent START WEEK 4 IN COLAB link. Confirm every student sees Notebook ready before moving on.</a:t>
             </a:r>
           </a:p>
         </p:txBody>
@@ -1625,7 +1625,7 @@
           <p:cNvPr id="3" name="Title">
             <a:extLst xmlns:a="http://schemas.openxmlformats.org/drawingml/2006/main">
               <a:ext uri="{FF2B5EF4-FFF2-40B4-BE49-F238E27FC236}">
-                <a16:creationId xmlns:a16="http://schemas.microsoft.com/office/drawing/2014/main" id="{B7A3B7B5-C5BF-46F7-8C69-686FCC889235}"/>
+                <a16:creationId xmlns:a16="http://schemas.microsoft.com/office/drawing/2014/main" id="{9F7BC1C8-EB94-409C-948C-FD56F9328C1F}"/>
               </a:ext>
             </a:extLst>
           </p:cNvPr>
@@ -1854,7 +1854,7 @@
           <p:cNvPr id="2" name="Subtitle">
             <a:extLst xmlns:a="http://schemas.openxmlformats.org/drawingml/2006/main">
               <a:ext uri="{FF2B5EF4-FFF2-40B4-BE49-F238E27FC236}">
-                <a16:creationId xmlns:a16="http://schemas.microsoft.com/office/drawing/2014/main" id="{3E951BE9-E4F9-455A-B460-F9CF97730E67}"/>
+                <a16:creationId xmlns:a16="http://schemas.microsoft.com/office/drawing/2014/main" id="{38898DC6-C511-43A2-BA49-A0D56BE1308C}"/>
               </a:ext>
             </a:extLst>
           </p:cNvPr>
@@ -2100,7 +2100,7 @@
           <p:cNvPr id="2" name="Section title">
             <a:extLst xmlns:a="http://schemas.openxmlformats.org/drawingml/2006/main">
               <a:ext uri="{FF2B5EF4-FFF2-40B4-BE49-F238E27FC236}">
-                <a16:creationId xmlns:a16="http://schemas.microsoft.com/office/drawing/2014/main" id="{B0503226-F61E-4B58-BF14-FBB2AF347B11}"/>
+                <a16:creationId xmlns:a16="http://schemas.microsoft.com/office/drawing/2014/main" id="{B6091826-99B2-49AF-9811-9FAEFBEB2FBC}"/>
               </a:ext>
             </a:extLst>
           </p:cNvPr>
@@ -2346,7 +2346,7 @@
           <p:cNvPr id="3" name="Title">
             <a:extLst xmlns:a="http://schemas.openxmlformats.org/drawingml/2006/main">
               <a:ext uri="{FF2B5EF4-FFF2-40B4-BE49-F238E27FC236}">
-                <a16:creationId xmlns:a16="http://schemas.microsoft.com/office/drawing/2014/main" id="{AE0B2321-389C-4E5B-9A4D-7B66AA30B5C4}"/>
+                <a16:creationId xmlns:a16="http://schemas.microsoft.com/office/drawing/2014/main" id="{0070C71A-A529-4B84-A65C-7DFE39F9E470}"/>
               </a:ext>
             </a:extLst>
           </p:cNvPr>
@@ -2575,7 +2575,7 @@
           <p:cNvPr id="2" name="Body">
             <a:extLst xmlns:a="http://schemas.openxmlformats.org/drawingml/2006/main">
               <a:ext uri="{FF2B5EF4-FFF2-40B4-BE49-F238E27FC236}">
-                <a16:creationId xmlns:a16="http://schemas.microsoft.com/office/drawing/2014/main" id="{4B01BC7B-DDCC-469F-9DD6-12A095DA3EED}"/>
+                <a16:creationId xmlns:a16="http://schemas.microsoft.com/office/drawing/2014/main" id="{4535D5E8-1677-41FA-ABE8-21995748097C}"/>
               </a:ext>
             </a:extLst>
           </p:cNvPr>
@@ -2821,7 +2821,7 @@
           <p:cNvPr id="4" name="Title">
             <a:extLst xmlns:a="http://schemas.openxmlformats.org/drawingml/2006/main">
               <a:ext uri="{FF2B5EF4-FFF2-40B4-BE49-F238E27FC236}">
-                <a16:creationId xmlns:a16="http://schemas.microsoft.com/office/drawing/2014/main" id="{0DD0D4E7-5713-42DE-8D3B-4A4C1B537F1C}"/>
+                <a16:creationId xmlns:a16="http://schemas.microsoft.com/office/drawing/2014/main" id="{D7030D5D-23B5-48F8-B130-E2E5630564C2}"/>
               </a:ext>
             </a:extLst>
           </p:cNvPr>
@@ -3050,7 +3050,7 @@
           <p:cNvPr id="2" name="Left column">
             <a:extLst xmlns:a="http://schemas.openxmlformats.org/drawingml/2006/main">
               <a:ext uri="{FF2B5EF4-FFF2-40B4-BE49-F238E27FC236}">
-                <a16:creationId xmlns:a16="http://schemas.microsoft.com/office/drawing/2014/main" id="{81A51954-5CF5-487D-A8CA-4DA0D0757FF7}"/>
+                <a16:creationId xmlns:a16="http://schemas.microsoft.com/office/drawing/2014/main" id="{28BDB86D-7DC7-4422-8CD4-6AA9B7C70A64}"/>
               </a:ext>
             </a:extLst>
           </p:cNvPr>
@@ -3279,7 +3279,7 @@
           <p:cNvPr id="3" name="Right column">
             <a:extLst xmlns:a="http://schemas.openxmlformats.org/drawingml/2006/main">
               <a:ext uri="{FF2B5EF4-FFF2-40B4-BE49-F238E27FC236}">
-                <a16:creationId xmlns:a16="http://schemas.microsoft.com/office/drawing/2014/main" id="{8C1946C2-B47D-4480-8D22-CB5BBCE2EEDD}"/>
+                <a16:creationId xmlns:a16="http://schemas.microsoft.com/office/drawing/2014/main" id="{59EB51AA-8C28-4A4A-9D00-BDB94B7358DB}"/>
               </a:ext>
             </a:extLst>
           </p:cNvPr>
@@ -3525,7 +3525,7 @@
           <p:cNvPr id="3" name="Title">
             <a:extLst xmlns:a="http://schemas.openxmlformats.org/drawingml/2006/main">
               <a:ext uri="{FF2B5EF4-FFF2-40B4-BE49-F238E27FC236}">
-                <a16:creationId xmlns:a16="http://schemas.microsoft.com/office/drawing/2014/main" id="{A5B86D60-0BDF-407F-8E54-08BA14D2D726}"/>
+                <a16:creationId xmlns:a16="http://schemas.microsoft.com/office/drawing/2014/main" id="{A65288F5-229F-417F-96F5-0A297B666D8C}"/>
               </a:ext>
             </a:extLst>
           </p:cNvPr>
@@ -3754,7 +3754,7 @@
           <p:cNvPr id="2" name="Left column">
             <a:extLst xmlns:a="http://schemas.openxmlformats.org/drawingml/2006/main">
               <a:ext uri="{FF2B5EF4-FFF2-40B4-BE49-F238E27FC236}">
-                <a16:creationId xmlns:a16="http://schemas.microsoft.com/office/drawing/2014/main" id="{3BF9B423-7505-4BDC-BF99-77D75CEB5348}"/>
+                <a16:creationId xmlns:a16="http://schemas.microsoft.com/office/drawing/2014/main" id="{F11C2A75-AAAF-4DD0-ADF2-C2DAA8B4BA50}"/>
               </a:ext>
             </a:extLst>
           </p:cNvPr>
@@ -4021,12 +4021,12 @@
   </p:cSld>
   <p:clrMap bg1="lt1" tx1="dk1" bg2="lt2" tx2="dk2" accent1="accent1" accent2="accent2" accent3="accent3" accent4="accent4" accent5="accent5" accent6="accent6" hlink="hlink" folHlink="folHlink"/>
   <p:sldLayoutIdLst>
-    <p:sldLayoutId xmlns:r="http://schemas.openxmlformats.org/officeDocument/2006/relationships" id="2147483649" r:id="Raa0bc40aa38f41b0"/>
-    <p:sldLayoutId xmlns:r="http://schemas.openxmlformats.org/officeDocument/2006/relationships" id="2147483650" r:id="Rcf067b2b8ca74bbc"/>
-    <p:sldLayoutId xmlns:r="http://schemas.openxmlformats.org/officeDocument/2006/relationships" id="2147483651" r:id="Rff396bfc1e2f416b"/>
-    <p:sldLayoutId xmlns:r="http://schemas.openxmlformats.org/officeDocument/2006/relationships" id="2147483652" r:id="R3ea980985cbe4a3b"/>
-    <p:sldLayoutId xmlns:r="http://schemas.openxmlformats.org/officeDocument/2006/relationships" id="2147483653" r:id="R51e3bf15faf44a40"/>
-    <p:sldLayoutId xmlns:r="http://schemas.openxmlformats.org/officeDocument/2006/relationships" id="2147483654" r:id="R997f90f940a34926"/>
+    <p:sldLayoutId xmlns:r="http://schemas.openxmlformats.org/officeDocument/2006/relationships" id="2147483649" r:id="Rca971424f82047eb"/>
+    <p:sldLayoutId xmlns:r="http://schemas.openxmlformats.org/officeDocument/2006/relationships" id="2147483650" r:id="R86108ef07b104052"/>
+    <p:sldLayoutId xmlns:r="http://schemas.openxmlformats.org/officeDocument/2006/relationships" id="2147483651" r:id="R93dd3807e65743fe"/>
+    <p:sldLayoutId xmlns:r="http://schemas.openxmlformats.org/officeDocument/2006/relationships" id="2147483652" r:id="R3e4af439e9324275"/>
+    <p:sldLayoutId xmlns:r="http://schemas.openxmlformats.org/officeDocument/2006/relationships" id="2147483653" r:id="R9ccd4e1495d84915"/>
+    <p:sldLayoutId xmlns:r="http://schemas.openxmlformats.org/officeDocument/2006/relationships" id="2147483654" r:id="R32e26a64476e4e5f"/>
   </p:sldLayoutIdLst>
   <p:txStyles>
     <p:titleStyle>
@@ -4577,7 +4577,7 @@
           <p:cNvPr id="6" name="">
             <a:extLst xmlns:a="http://schemas.openxmlformats.org/drawingml/2006/main">
               <a:ext uri="{FF2B5EF4-FFF2-40B4-BE49-F238E27FC236}">
-                <a16:creationId xmlns:a16="http://schemas.microsoft.com/office/drawing/2014/main" id="{876D4EEF-4048-4B7F-A36C-EFE1F0FEA461}"/>
+                <a16:creationId xmlns:a16="http://schemas.microsoft.com/office/drawing/2014/main" id="{DD2271B9-E2DB-42C7-8CB6-6517BBE2273C}"/>
               </a:ext>
             </a:extLst>
           </p:cNvPr>
@@ -4608,7 +4608,7 @@
           <p:cNvPr id="2" name="">
             <a:extLst xmlns:a="http://schemas.openxmlformats.org/drawingml/2006/main">
               <a:ext uri="{FF2B5EF4-FFF2-40B4-BE49-F238E27FC236}">
-                <a16:creationId xmlns:a16="http://schemas.microsoft.com/office/drawing/2014/main" id="{72E99B02-862D-4E8B-8D9F-4E37605A3A81}"/>
+                <a16:creationId xmlns:a16="http://schemas.microsoft.com/office/drawing/2014/main" id="{69E736DB-A096-4537-9A34-4864386CB752}"/>
               </a:ext>
             </a:extLst>
           </p:cNvPr>
@@ -4729,7 +4729,7 @@
           <p:cNvPr id="3" name="">
             <a:extLst xmlns:a="http://schemas.openxmlformats.org/drawingml/2006/main">
               <a:ext uri="{FF2B5EF4-FFF2-40B4-BE49-F238E27FC236}">
-                <a16:creationId xmlns:a16="http://schemas.microsoft.com/office/drawing/2014/main" id="{6A78090A-4301-4691-972E-385FD9EC0DC0}"/>
+                <a16:creationId xmlns:a16="http://schemas.microsoft.com/office/drawing/2014/main" id="{BB246736-AE00-4648-BDE7-89F61606BAC1}"/>
               </a:ext>
             </a:extLst>
           </p:cNvPr>
@@ -4867,7 +4867,7 @@
           <p:cNvPr id="4" name="">
             <a:extLst xmlns:a="http://schemas.openxmlformats.org/drawingml/2006/main">
               <a:ext uri="{FF2B5EF4-FFF2-40B4-BE49-F238E27FC236}">
-                <a16:creationId xmlns:a16="http://schemas.microsoft.com/office/drawing/2014/main" id="{AF2D375A-965E-4FA2-A14E-66C22CFDF1C7}"/>
+                <a16:creationId xmlns:a16="http://schemas.microsoft.com/office/drawing/2014/main" id="{03CE4545-3114-4EA9-8DF9-D8A03D8A68E0}"/>
               </a:ext>
             </a:extLst>
           </p:cNvPr>
@@ -4988,7 +4988,7 @@
           <p:cNvPr id="5" name="">
             <a:extLst xmlns:a="http://schemas.openxmlformats.org/drawingml/2006/main">
               <a:ext uri="{FF2B5EF4-FFF2-40B4-BE49-F238E27FC236}">
-                <a16:creationId xmlns:a16="http://schemas.microsoft.com/office/drawing/2014/main" id="{BC141915-A8E9-474A-9F17-3EE91DE33768}"/>
+                <a16:creationId xmlns:a16="http://schemas.microsoft.com/office/drawing/2014/main" id="{1A9F1FCB-11E0-4780-87B7-17BB57B1418C}"/>
               </a:ext>
             </a:extLst>
           </p:cNvPr>
@@ -5107,7 +5107,7 @@
     </p:spTree>
     <p:extLst>
       <p:ext uri="{BB962C8B-B14F-4D97-AF65-F5344CB8AC3E}">
-        <p14:creationId xmlns:p14="http://schemas.microsoft.com/office/powerpoint/2010/main" val="1126343646"/>
+        <p14:creationId xmlns:p14="http://schemas.microsoft.com/office/powerpoint/2010/main" val="1274796185"/>
       </p:ext>
     </p:extLst>
   </p:cSld>
@@ -5135,10 +5135,10 @@
       </p:grpSpPr>
       <p:sp>
         <p:nvSpPr>
-          <p:cNvPr id="16" name="">
+          <p:cNvPr id="17" name="">
             <a:extLst xmlns:a="http://schemas.openxmlformats.org/drawingml/2006/main">
               <a:ext uri="{FF2B5EF4-FFF2-40B4-BE49-F238E27FC236}">
-                <a16:creationId xmlns:a16="http://schemas.microsoft.com/office/drawing/2014/main" id="{0150EA8B-B0D3-4BF7-B03A-76E5BED36DEE}"/>
+                <a16:creationId xmlns:a16="http://schemas.microsoft.com/office/drawing/2014/main" id="{B0FA1C85-14D9-4250-8649-F9DCACF7E251}"/>
               </a:ext>
             </a:extLst>
           </p:cNvPr>
@@ -5259,7 +5259,7 @@
           <p:cNvPr id="2" name="">
             <a:extLst xmlns:a="http://schemas.openxmlformats.org/drawingml/2006/main">
               <a:ext uri="{FF2B5EF4-FFF2-40B4-BE49-F238E27FC236}">
-                <a16:creationId xmlns:a16="http://schemas.microsoft.com/office/drawing/2014/main" id="{71D7A68F-F21E-46EB-8465-81FC84545777}"/>
+                <a16:creationId xmlns:a16="http://schemas.microsoft.com/office/drawing/2014/main" id="{FE54DDF6-4214-4748-905D-327C3B354846}"/>
               </a:ext>
             </a:extLst>
           </p:cNvPr>
@@ -5370,7 +5370,7 @@
                   <a:srgbClr val="557086"/>
                 </a:solidFill>
               </a:rPr>
-              <a:t>Open the shared link and make your own copy</a:t>
+              <a:t>Start from the course repository</a:t>
             </a:r>
           </a:p>
         </p:txBody>
@@ -5380,7 +5380,7 @@
           <p:cNvPr id="3" name="">
             <a:extLst xmlns:a="http://schemas.openxmlformats.org/drawingml/2006/main">
               <a:ext uri="{FF2B5EF4-FFF2-40B4-BE49-F238E27FC236}">
-                <a16:creationId xmlns:a16="http://schemas.microsoft.com/office/drawing/2014/main" id="{711C2DAE-1A03-4D5B-B9EE-6F041B879550}"/>
+                <a16:creationId xmlns:a16="http://schemas.microsoft.com/office/drawing/2014/main" id="{C0E7AF17-1272-47C7-A500-C52031AD2DB4}"/>
               </a:ext>
             </a:extLst>
           </p:cNvPr>
@@ -5391,7 +5391,7 @@
         </p:nvSpPr>
         <p:spPr>
           <a:xfrm xmlns:a="http://schemas.openxmlformats.org/drawingml/2006/main">
-            <a:off x="1000125" y="1619250"/>
+            <a:off x="857250" y="1571625"/>
             <a:ext cx="323850" cy="304800"/>
           </a:xfrm>
           <a:prstGeom xmlns:a="http://schemas.openxmlformats.org/drawingml/2006/main" prst="rect">
@@ -5407,70 +5407,70 @@
           <a:bodyPr xmlns:a="http://schemas.openxmlformats.org/drawingml/2006/main"/>
           <a:lstStyle xmlns:a="http://schemas.openxmlformats.org/drawingml/2006/main">
             <a:defPPr>
-              <a:defRPr sz="1800" b="1">
+              <a:defRPr sz="1650" b="1">
                 <a:solidFill>
                   <a:srgbClr val="DF6665"/>
                 </a:solidFill>
               </a:defRPr>
             </a:defPPr>
             <a:lvl1pPr>
-              <a:defRPr sz="1800" b="1">
+              <a:defRPr sz="1650" b="1">
                 <a:solidFill>
                   <a:srgbClr val="DF6665"/>
                 </a:solidFill>
               </a:defRPr>
             </a:lvl1pPr>
             <a:lvl2pPr>
-              <a:defRPr sz="1800" b="1">
+              <a:defRPr sz="1650" b="1">
                 <a:solidFill>
                   <a:srgbClr val="DF6665"/>
                 </a:solidFill>
               </a:defRPr>
             </a:lvl2pPr>
             <a:lvl3pPr>
-              <a:defRPr sz="1800" b="1">
+              <a:defRPr sz="1650" b="1">
                 <a:solidFill>
                   <a:srgbClr val="DF6665"/>
                 </a:solidFill>
               </a:defRPr>
             </a:lvl3pPr>
             <a:lvl4pPr>
-              <a:defRPr sz="1800" b="1">
+              <a:defRPr sz="1650" b="1">
                 <a:solidFill>
                   <a:srgbClr val="DF6665"/>
                 </a:solidFill>
               </a:defRPr>
             </a:lvl4pPr>
             <a:lvl5pPr>
-              <a:defRPr sz="1800" b="1">
+              <a:defRPr sz="1650" b="1">
                 <a:solidFill>
                   <a:srgbClr val="DF6665"/>
                 </a:solidFill>
               </a:defRPr>
             </a:lvl5pPr>
             <a:lvl6pPr>
-              <a:defRPr sz="1800" b="1">
+              <a:defRPr sz="1650" b="1">
                 <a:solidFill>
                   <a:srgbClr val="DF6665"/>
                 </a:solidFill>
               </a:defRPr>
             </a:lvl6pPr>
             <a:lvl7pPr>
-              <a:defRPr sz="1800" b="1">
+              <a:defRPr sz="1650" b="1">
                 <a:solidFill>
                   <a:srgbClr val="DF6665"/>
                 </a:solidFill>
               </a:defRPr>
             </a:lvl7pPr>
             <a:lvl8pPr>
-              <a:defRPr sz="1800" b="1">
+              <a:defRPr sz="1650" b="1">
                 <a:solidFill>
                   <a:srgbClr val="DF6665"/>
                 </a:solidFill>
               </a:defRPr>
             </a:lvl8pPr>
             <a:lvl9pPr>
-              <a:defRPr sz="1800" b="1">
+              <a:defRPr sz="1650" b="1">
                 <a:solidFill>
                   <a:srgbClr val="DF6665"/>
                 </a:solidFill>
@@ -5479,14 +5479,14 @@
           </a:lstStyle>
           <a:p xmlns:a="http://schemas.openxmlformats.org/drawingml/2006/main">
             <a:pPr>
-              <a:defRPr sz="1800" b="1">
+              <a:defRPr sz="1650" b="1">
                 <a:solidFill>
                   <a:srgbClr val="DF6665"/>
                 </a:solidFill>
               </a:defRPr>
             </a:pPr>
             <a:r>
-              <a:rPr sz="1800" b="1">
+              <a:rPr sz="1650" b="1">
                 <a:solidFill>
                   <a:srgbClr val="DF6665"/>
                 </a:solidFill>
@@ -5501,7 +5501,7 @@
           <p:cNvPr id="4" name="">
             <a:extLst xmlns:a="http://schemas.openxmlformats.org/drawingml/2006/main">
               <a:ext uri="{FF2B5EF4-FFF2-40B4-BE49-F238E27FC236}">
-                <a16:creationId xmlns:a16="http://schemas.microsoft.com/office/drawing/2014/main" id="{C01465C0-B6CD-40C9-8E81-A0835CEFF647}"/>
+                <a16:creationId xmlns:a16="http://schemas.microsoft.com/office/drawing/2014/main" id="{0F0BAE2E-0462-4977-A91F-51CFBCAFA416}"/>
               </a:ext>
             </a:extLst>
           </p:cNvPr>
@@ -5512,8 +5512,8 @@
         </p:nvSpPr>
         <p:spPr>
           <a:xfrm xmlns:a="http://schemas.openxmlformats.org/drawingml/2006/main">
-            <a:off x="1457325" y="1619250"/>
-            <a:ext cx="6781800" cy="762000"/>
+            <a:off x="1314450" y="1571625"/>
+            <a:ext cx="6877050" cy="685800"/>
           </a:xfrm>
           <a:prstGeom xmlns:a="http://schemas.openxmlformats.org/drawingml/2006/main" prst="rect">
             <a:avLst/>
@@ -5528,70 +5528,70 @@
           <a:bodyPr xmlns:a="http://schemas.openxmlformats.org/drawingml/2006/main"/>
           <a:lstStyle xmlns:a="http://schemas.openxmlformats.org/drawingml/2006/main">
             <a:defPPr>
-              <a:defRPr sz="2025" b="0">
+              <a:defRPr sz="1875" b="0">
                 <a:solidFill>
                   <a:srgbClr val="17324D"/>
                 </a:solidFill>
               </a:defRPr>
             </a:defPPr>
             <a:lvl1pPr>
-              <a:defRPr sz="2025" b="0">
+              <a:defRPr sz="1875" b="0">
                 <a:solidFill>
                   <a:srgbClr val="17324D"/>
                 </a:solidFill>
               </a:defRPr>
             </a:lvl1pPr>
             <a:lvl2pPr>
-              <a:defRPr sz="2025" b="0">
+              <a:defRPr sz="1875" b="0">
                 <a:solidFill>
                   <a:srgbClr val="17324D"/>
                 </a:solidFill>
               </a:defRPr>
             </a:lvl2pPr>
             <a:lvl3pPr>
-              <a:defRPr sz="2025" b="0">
+              <a:defRPr sz="1875" b="0">
                 <a:solidFill>
                   <a:srgbClr val="17324D"/>
                 </a:solidFill>
               </a:defRPr>
             </a:lvl3pPr>
             <a:lvl4pPr>
-              <a:defRPr sz="2025" b="0">
+              <a:defRPr sz="1875" b="0">
                 <a:solidFill>
                   <a:srgbClr val="17324D"/>
                 </a:solidFill>
               </a:defRPr>
             </a:lvl4pPr>
             <a:lvl5pPr>
-              <a:defRPr sz="2025" b="0">
+              <a:defRPr sz="1875" b="0">
                 <a:solidFill>
                   <a:srgbClr val="17324D"/>
                 </a:solidFill>
               </a:defRPr>
             </a:lvl5pPr>
             <a:lvl6pPr>
-              <a:defRPr sz="2025" b="0">
+              <a:defRPr sz="1875" b="0">
                 <a:solidFill>
                   <a:srgbClr val="17324D"/>
                 </a:solidFill>
               </a:defRPr>
             </a:lvl6pPr>
             <a:lvl7pPr>
-              <a:defRPr sz="2025" b="0">
+              <a:defRPr sz="1875" b="0">
                 <a:solidFill>
                   <a:srgbClr val="17324D"/>
                 </a:solidFill>
               </a:defRPr>
             </a:lvl7pPr>
             <a:lvl8pPr>
-              <a:defRPr sz="2025" b="0">
+              <a:defRPr sz="1875" b="0">
                 <a:solidFill>
                   <a:srgbClr val="17324D"/>
                 </a:solidFill>
               </a:defRPr>
             </a:lvl8pPr>
             <a:lvl9pPr>
-              <a:defRPr sz="2025" b="0">
+              <a:defRPr sz="1875" b="0">
                 <a:solidFill>
                   <a:srgbClr val="17324D"/>
                 </a:solidFill>
@@ -5600,19 +5600,19 @@
           </a:lstStyle>
           <a:p xmlns:a="http://schemas.openxmlformats.org/drawingml/2006/main">
             <a:pPr>
-              <a:defRPr sz="2025" b="0">
+              <a:defRPr sz="1875" b="0">
                 <a:solidFill>
                   <a:srgbClr val="17324D"/>
                 </a:solidFill>
               </a:defRPr>
             </a:pPr>
             <a:r>
-              <a:rPr sz="2025" b="0">
+              <a:rPr sz="1875" b="0">
                 <a:solidFill>
                   <a:srgbClr val="17324D"/>
                 </a:solidFill>
               </a:rPr>
-              <a:t>Open the Week 4 Colab link</a:t>
+              <a:t>Open the course repository</a:t>
             </a:r>
           </a:p>
         </p:txBody>
@@ -5622,7 +5622,7 @@
           <p:cNvPr id="5" name="">
             <a:extLst xmlns:a="http://schemas.openxmlformats.org/drawingml/2006/main">
               <a:ext uri="{FF2B5EF4-FFF2-40B4-BE49-F238E27FC236}">
-                <a16:creationId xmlns:a16="http://schemas.microsoft.com/office/drawing/2014/main" id="{0BF80F9F-F2B2-4CB6-800A-7E37CE8199A7}"/>
+                <a16:creationId xmlns:a16="http://schemas.microsoft.com/office/drawing/2014/main" id="{B09DB380-FAF0-46C5-B634-3796B4EC554B}"/>
               </a:ext>
             </a:extLst>
           </p:cNvPr>
@@ -5633,7 +5633,7 @@
         </p:nvSpPr>
         <p:spPr>
           <a:xfrm xmlns:a="http://schemas.openxmlformats.org/drawingml/2006/main">
-            <a:off x="1000125" y="2419350"/>
+            <a:off x="857250" y="2295525"/>
             <a:ext cx="323850" cy="304800"/>
           </a:xfrm>
           <a:prstGeom xmlns:a="http://schemas.openxmlformats.org/drawingml/2006/main" prst="rect">
@@ -5649,70 +5649,70 @@
           <a:bodyPr xmlns:a="http://schemas.openxmlformats.org/drawingml/2006/main"/>
           <a:lstStyle xmlns:a="http://schemas.openxmlformats.org/drawingml/2006/main">
             <a:defPPr>
-              <a:defRPr sz="1800" b="1">
+              <a:defRPr sz="1650" b="1">
                 <a:solidFill>
                   <a:srgbClr val="5AA446"/>
                 </a:solidFill>
               </a:defRPr>
             </a:defPPr>
             <a:lvl1pPr>
-              <a:defRPr sz="1800" b="1">
+              <a:defRPr sz="1650" b="1">
                 <a:solidFill>
                   <a:srgbClr val="5AA446"/>
                 </a:solidFill>
               </a:defRPr>
             </a:lvl1pPr>
             <a:lvl2pPr>
-              <a:defRPr sz="1800" b="1">
+              <a:defRPr sz="1650" b="1">
                 <a:solidFill>
                   <a:srgbClr val="5AA446"/>
                 </a:solidFill>
               </a:defRPr>
             </a:lvl2pPr>
             <a:lvl3pPr>
-              <a:defRPr sz="1800" b="1">
+              <a:defRPr sz="1650" b="1">
                 <a:solidFill>
                   <a:srgbClr val="5AA446"/>
                 </a:solidFill>
               </a:defRPr>
             </a:lvl3pPr>
             <a:lvl4pPr>
-              <a:defRPr sz="1800" b="1">
+              <a:defRPr sz="1650" b="1">
                 <a:solidFill>
                   <a:srgbClr val="5AA446"/>
                 </a:solidFill>
               </a:defRPr>
             </a:lvl4pPr>
             <a:lvl5pPr>
-              <a:defRPr sz="1800" b="1">
+              <a:defRPr sz="1650" b="1">
                 <a:solidFill>
                   <a:srgbClr val="5AA446"/>
                 </a:solidFill>
               </a:defRPr>
             </a:lvl5pPr>
             <a:lvl6pPr>
-              <a:defRPr sz="1800" b="1">
+              <a:defRPr sz="1650" b="1">
                 <a:solidFill>
                   <a:srgbClr val="5AA446"/>
                 </a:solidFill>
               </a:defRPr>
             </a:lvl6pPr>
             <a:lvl7pPr>
-              <a:defRPr sz="1800" b="1">
+              <a:defRPr sz="1650" b="1">
                 <a:solidFill>
                   <a:srgbClr val="5AA446"/>
                 </a:solidFill>
               </a:defRPr>
             </a:lvl7pPr>
             <a:lvl8pPr>
-              <a:defRPr sz="1800" b="1">
+              <a:defRPr sz="1650" b="1">
                 <a:solidFill>
                   <a:srgbClr val="5AA446"/>
                 </a:solidFill>
               </a:defRPr>
             </a:lvl8pPr>
             <a:lvl9pPr>
-              <a:defRPr sz="1800" b="1">
+              <a:defRPr sz="1650" b="1">
                 <a:solidFill>
                   <a:srgbClr val="5AA446"/>
                 </a:solidFill>
@@ -5721,14 +5721,14 @@
           </a:lstStyle>
           <a:p xmlns:a="http://schemas.openxmlformats.org/drawingml/2006/main">
             <a:pPr>
-              <a:defRPr sz="1800" b="1">
+              <a:defRPr sz="1650" b="1">
                 <a:solidFill>
                   <a:srgbClr val="5AA446"/>
                 </a:solidFill>
               </a:defRPr>
             </a:pPr>
             <a:r>
-              <a:rPr sz="1800" b="1">
+              <a:rPr sz="1650" b="1">
                 <a:solidFill>
                   <a:srgbClr val="5AA446"/>
                 </a:solidFill>
@@ -5743,7 +5743,7 @@
           <p:cNvPr id="6" name="">
             <a:extLst xmlns:a="http://schemas.openxmlformats.org/drawingml/2006/main">
               <a:ext uri="{FF2B5EF4-FFF2-40B4-BE49-F238E27FC236}">
-                <a16:creationId xmlns:a16="http://schemas.microsoft.com/office/drawing/2014/main" id="{FF89F25E-8099-43DC-90A1-9A3ECE39C991}"/>
+                <a16:creationId xmlns:a16="http://schemas.microsoft.com/office/drawing/2014/main" id="{91C15636-A7EB-4F16-8F97-DCF85E6B397F}"/>
               </a:ext>
             </a:extLst>
           </p:cNvPr>
@@ -5754,8 +5754,8 @@
         </p:nvSpPr>
         <p:spPr>
           <a:xfrm xmlns:a="http://schemas.openxmlformats.org/drawingml/2006/main">
-            <a:off x="1457325" y="2419350"/>
-            <a:ext cx="6781800" cy="762000"/>
+            <a:off x="1314450" y="2295525"/>
+            <a:ext cx="6877050" cy="685800"/>
           </a:xfrm>
           <a:prstGeom xmlns:a="http://schemas.openxmlformats.org/drawingml/2006/main" prst="rect">
             <a:avLst/>
@@ -5770,70 +5770,70 @@
           <a:bodyPr xmlns:a="http://schemas.openxmlformats.org/drawingml/2006/main"/>
           <a:lstStyle xmlns:a="http://schemas.openxmlformats.org/drawingml/2006/main">
             <a:defPPr>
-              <a:defRPr sz="2025" b="0">
+              <a:defRPr sz="1875" b="0">
                 <a:solidFill>
                   <a:srgbClr val="17324D"/>
                 </a:solidFill>
               </a:defRPr>
             </a:defPPr>
             <a:lvl1pPr>
-              <a:defRPr sz="2025" b="0">
+              <a:defRPr sz="1875" b="0">
                 <a:solidFill>
                   <a:srgbClr val="17324D"/>
                 </a:solidFill>
               </a:defRPr>
             </a:lvl1pPr>
             <a:lvl2pPr>
-              <a:defRPr sz="2025" b="0">
+              <a:defRPr sz="1875" b="0">
                 <a:solidFill>
                   <a:srgbClr val="17324D"/>
                 </a:solidFill>
               </a:defRPr>
             </a:lvl2pPr>
             <a:lvl3pPr>
-              <a:defRPr sz="2025" b="0">
+              <a:defRPr sz="1875" b="0">
                 <a:solidFill>
                   <a:srgbClr val="17324D"/>
                 </a:solidFill>
               </a:defRPr>
             </a:lvl3pPr>
             <a:lvl4pPr>
-              <a:defRPr sz="2025" b="0">
+              <a:defRPr sz="1875" b="0">
                 <a:solidFill>
                   <a:srgbClr val="17324D"/>
                 </a:solidFill>
               </a:defRPr>
             </a:lvl4pPr>
             <a:lvl5pPr>
-              <a:defRPr sz="2025" b="0">
+              <a:defRPr sz="1875" b="0">
                 <a:solidFill>
                   <a:srgbClr val="17324D"/>
                 </a:solidFill>
               </a:defRPr>
             </a:lvl5pPr>
             <a:lvl6pPr>
-              <a:defRPr sz="2025" b="0">
+              <a:defRPr sz="1875" b="0">
                 <a:solidFill>
                   <a:srgbClr val="17324D"/>
                 </a:solidFill>
               </a:defRPr>
             </a:lvl6pPr>
             <a:lvl7pPr>
-              <a:defRPr sz="2025" b="0">
+              <a:defRPr sz="1875" b="0">
                 <a:solidFill>
                   <a:srgbClr val="17324D"/>
                 </a:solidFill>
               </a:defRPr>
             </a:lvl7pPr>
             <a:lvl8pPr>
-              <a:defRPr sz="2025" b="0">
+              <a:defRPr sz="1875" b="0">
                 <a:solidFill>
                   <a:srgbClr val="17324D"/>
                 </a:solidFill>
               </a:defRPr>
             </a:lvl8pPr>
             <a:lvl9pPr>
-              <a:defRPr sz="2025" b="0">
+              <a:defRPr sz="1875" b="0">
                 <a:solidFill>
                   <a:srgbClr val="17324D"/>
                 </a:solidFill>
@@ -5842,19 +5842,19 @@
           </a:lstStyle>
           <a:p xmlns:a="http://schemas.openxmlformats.org/drawingml/2006/main">
             <a:pPr>
-              <a:defRPr sz="2025" b="0">
+              <a:defRPr sz="1875" b="0">
                 <a:solidFill>
                   <a:srgbClr val="17324D"/>
                 </a:solidFill>
               </a:defRPr>
             </a:pPr>
             <a:r>
-              <a:rPr sz="2025" b="0">
+              <a:rPr sz="1875" b="0">
                 <a:solidFill>
                   <a:srgbClr val="17324D"/>
                 </a:solidFill>
               </a:rPr>
-              <a:t>Choose File &gt; Save a copy in Drive</a:t>
+              <a:t>Select START WEEK 4 IN COLAB</a:t>
             </a:r>
           </a:p>
         </p:txBody>
@@ -5864,7 +5864,7 @@
           <p:cNvPr id="7" name="">
             <a:extLst xmlns:a="http://schemas.openxmlformats.org/drawingml/2006/main">
               <a:ext uri="{FF2B5EF4-FFF2-40B4-BE49-F238E27FC236}">
-                <a16:creationId xmlns:a16="http://schemas.microsoft.com/office/drawing/2014/main" id="{9F96708A-F367-4300-A431-CEB2D44275F4}"/>
+                <a16:creationId xmlns:a16="http://schemas.microsoft.com/office/drawing/2014/main" id="{0671749E-0871-4A56-943C-ABA9CCD354A1}"/>
               </a:ext>
             </a:extLst>
           </p:cNvPr>
@@ -5875,7 +5875,7 @@
         </p:nvSpPr>
         <p:spPr>
           <a:xfrm xmlns:a="http://schemas.openxmlformats.org/drawingml/2006/main">
-            <a:off x="1000125" y="3219450"/>
+            <a:off x="857250" y="3019425"/>
             <a:ext cx="323850" cy="304800"/>
           </a:xfrm>
           <a:prstGeom xmlns:a="http://schemas.openxmlformats.org/drawingml/2006/main" prst="rect">
@@ -5891,70 +5891,70 @@
           <a:bodyPr xmlns:a="http://schemas.openxmlformats.org/drawingml/2006/main"/>
           <a:lstStyle xmlns:a="http://schemas.openxmlformats.org/drawingml/2006/main">
             <a:defPPr>
-              <a:defRPr sz="1800" b="1">
+              <a:defRPr sz="1650" b="1">
                 <a:solidFill>
                   <a:srgbClr val="367D96"/>
                 </a:solidFill>
               </a:defRPr>
             </a:defPPr>
             <a:lvl1pPr>
-              <a:defRPr sz="1800" b="1">
+              <a:defRPr sz="1650" b="1">
                 <a:solidFill>
                   <a:srgbClr val="367D96"/>
                 </a:solidFill>
               </a:defRPr>
             </a:lvl1pPr>
             <a:lvl2pPr>
-              <a:defRPr sz="1800" b="1">
+              <a:defRPr sz="1650" b="1">
                 <a:solidFill>
                   <a:srgbClr val="367D96"/>
                 </a:solidFill>
               </a:defRPr>
             </a:lvl2pPr>
             <a:lvl3pPr>
-              <a:defRPr sz="1800" b="1">
+              <a:defRPr sz="1650" b="1">
                 <a:solidFill>
                   <a:srgbClr val="367D96"/>
                 </a:solidFill>
               </a:defRPr>
             </a:lvl3pPr>
             <a:lvl4pPr>
-              <a:defRPr sz="1800" b="1">
+              <a:defRPr sz="1650" b="1">
                 <a:solidFill>
                   <a:srgbClr val="367D96"/>
                 </a:solidFill>
               </a:defRPr>
             </a:lvl4pPr>
             <a:lvl5pPr>
-              <a:defRPr sz="1800" b="1">
+              <a:defRPr sz="1650" b="1">
                 <a:solidFill>
                   <a:srgbClr val="367D96"/>
                 </a:solidFill>
               </a:defRPr>
             </a:lvl5pPr>
             <a:lvl6pPr>
-              <a:defRPr sz="1800" b="1">
+              <a:defRPr sz="1650" b="1">
                 <a:solidFill>
                   <a:srgbClr val="367D96"/>
                 </a:solidFill>
               </a:defRPr>
             </a:lvl6pPr>
             <a:lvl7pPr>
-              <a:defRPr sz="1800" b="1">
+              <a:defRPr sz="1650" b="1">
                 <a:solidFill>
                   <a:srgbClr val="367D96"/>
                 </a:solidFill>
               </a:defRPr>
             </a:lvl7pPr>
             <a:lvl8pPr>
-              <a:defRPr sz="1800" b="1">
+              <a:defRPr sz="1650" b="1">
                 <a:solidFill>
                   <a:srgbClr val="367D96"/>
                 </a:solidFill>
               </a:defRPr>
             </a:lvl8pPr>
             <a:lvl9pPr>
-              <a:defRPr sz="1800" b="1">
+              <a:defRPr sz="1650" b="1">
                 <a:solidFill>
                   <a:srgbClr val="367D96"/>
                 </a:solidFill>
@@ -5963,14 +5963,14 @@
           </a:lstStyle>
           <a:p xmlns:a="http://schemas.openxmlformats.org/drawingml/2006/main">
             <a:pPr>
-              <a:defRPr sz="1800" b="1">
+              <a:defRPr sz="1650" b="1">
                 <a:solidFill>
                   <a:srgbClr val="367D96"/>
                 </a:solidFill>
               </a:defRPr>
             </a:pPr>
             <a:r>
-              <a:rPr sz="1800" b="1">
+              <a:rPr sz="1650" b="1">
                 <a:solidFill>
                   <a:srgbClr val="367D96"/>
                 </a:solidFill>
@@ -5985,7 +5985,7 @@
           <p:cNvPr id="8" name="">
             <a:extLst xmlns:a="http://schemas.openxmlformats.org/drawingml/2006/main">
               <a:ext uri="{FF2B5EF4-FFF2-40B4-BE49-F238E27FC236}">
-                <a16:creationId xmlns:a16="http://schemas.microsoft.com/office/drawing/2014/main" id="{8E2C0876-8A45-4021-852D-BD0A2FC5C2AA}"/>
+                <a16:creationId xmlns:a16="http://schemas.microsoft.com/office/drawing/2014/main" id="{35BFF8D6-4B1B-4A42-B085-778C7BB3FEB5}"/>
               </a:ext>
             </a:extLst>
           </p:cNvPr>
@@ -5996,8 +5996,8 @@
         </p:nvSpPr>
         <p:spPr>
           <a:xfrm xmlns:a="http://schemas.openxmlformats.org/drawingml/2006/main">
-            <a:off x="1457325" y="3219450"/>
-            <a:ext cx="6781800" cy="762000"/>
+            <a:off x="1314450" y="3019425"/>
+            <a:ext cx="6877050" cy="685800"/>
           </a:xfrm>
           <a:prstGeom xmlns:a="http://schemas.openxmlformats.org/drawingml/2006/main" prst="rect">
             <a:avLst/>
@@ -6012,70 +6012,70 @@
           <a:bodyPr xmlns:a="http://schemas.openxmlformats.org/drawingml/2006/main"/>
           <a:lstStyle xmlns:a="http://schemas.openxmlformats.org/drawingml/2006/main">
             <a:defPPr>
-              <a:defRPr sz="2025" b="0">
+              <a:defRPr sz="1875" b="0">
                 <a:solidFill>
                   <a:srgbClr val="17324D"/>
                 </a:solidFill>
               </a:defRPr>
             </a:defPPr>
             <a:lvl1pPr>
-              <a:defRPr sz="2025" b="0">
+              <a:defRPr sz="1875" b="0">
                 <a:solidFill>
                   <a:srgbClr val="17324D"/>
                 </a:solidFill>
               </a:defRPr>
             </a:lvl1pPr>
             <a:lvl2pPr>
-              <a:defRPr sz="2025" b="0">
+              <a:defRPr sz="1875" b="0">
                 <a:solidFill>
                   <a:srgbClr val="17324D"/>
                 </a:solidFill>
               </a:defRPr>
             </a:lvl2pPr>
             <a:lvl3pPr>
-              <a:defRPr sz="2025" b="0">
+              <a:defRPr sz="1875" b="0">
                 <a:solidFill>
                   <a:srgbClr val="17324D"/>
                 </a:solidFill>
               </a:defRPr>
             </a:lvl3pPr>
             <a:lvl4pPr>
-              <a:defRPr sz="2025" b="0">
+              <a:defRPr sz="1875" b="0">
                 <a:solidFill>
                   <a:srgbClr val="17324D"/>
                 </a:solidFill>
               </a:defRPr>
             </a:lvl4pPr>
             <a:lvl5pPr>
-              <a:defRPr sz="2025" b="0">
+              <a:defRPr sz="1875" b="0">
                 <a:solidFill>
                   <a:srgbClr val="17324D"/>
                 </a:solidFill>
               </a:defRPr>
             </a:lvl5pPr>
             <a:lvl6pPr>
-              <a:defRPr sz="2025" b="0">
+              <a:defRPr sz="1875" b="0">
                 <a:solidFill>
                   <a:srgbClr val="17324D"/>
                 </a:solidFill>
               </a:defRPr>
             </a:lvl6pPr>
             <a:lvl7pPr>
-              <a:defRPr sz="2025" b="0">
+              <a:defRPr sz="1875" b="0">
                 <a:solidFill>
                   <a:srgbClr val="17324D"/>
                 </a:solidFill>
               </a:defRPr>
             </a:lvl7pPr>
             <a:lvl8pPr>
-              <a:defRPr sz="2025" b="0">
+              <a:defRPr sz="1875" b="0">
                 <a:solidFill>
                   <a:srgbClr val="17324D"/>
                 </a:solidFill>
               </a:defRPr>
             </a:lvl8pPr>
             <a:lvl9pPr>
-              <a:defRPr sz="2025" b="0">
+              <a:defRPr sz="1875" b="0">
                 <a:solidFill>
                   <a:srgbClr val="17324D"/>
                 </a:solidFill>
@@ -6084,19 +6084,19 @@
           </a:lstStyle>
           <a:p xmlns:a="http://schemas.openxmlformats.org/drawingml/2006/main">
             <a:pPr>
-              <a:defRPr sz="2025" b="0">
+              <a:defRPr sz="1875" b="0">
                 <a:solidFill>
                   <a:srgbClr val="17324D"/>
                 </a:solidFill>
               </a:defRPr>
             </a:pPr>
             <a:r>
-              <a:rPr sz="2025" b="0">
+              <a:rPr sz="1875" b="0">
                 <a:solidFill>
                   <a:srgbClr val="17324D"/>
                 </a:solidFill>
               </a:rPr>
-              <a:t>Run Runtime check and Self-check helper</a:t>
+              <a:t>Choose File &gt; Save a copy in Drive</a:t>
             </a:r>
           </a:p>
         </p:txBody>
@@ -6106,7 +6106,7 @@
           <p:cNvPr id="9" name="">
             <a:extLst xmlns:a="http://schemas.openxmlformats.org/drawingml/2006/main">
               <a:ext uri="{FF2B5EF4-FFF2-40B4-BE49-F238E27FC236}">
-                <a16:creationId xmlns:a16="http://schemas.microsoft.com/office/drawing/2014/main" id="{EBD04CFB-33A2-424A-A799-2FA37BD88984}"/>
+                <a16:creationId xmlns:a16="http://schemas.microsoft.com/office/drawing/2014/main" id="{7545F08C-4C70-4944-BED3-B47E7E462B73}"/>
               </a:ext>
             </a:extLst>
           </p:cNvPr>
@@ -6117,7 +6117,7 @@
         </p:nvSpPr>
         <p:spPr>
           <a:xfrm xmlns:a="http://schemas.openxmlformats.org/drawingml/2006/main">
-            <a:off x="1000125" y="4019550"/>
+            <a:off x="857250" y="3743325"/>
             <a:ext cx="323850" cy="304800"/>
           </a:xfrm>
           <a:prstGeom xmlns:a="http://schemas.openxmlformats.org/drawingml/2006/main" prst="rect">
@@ -6133,70 +6133,70 @@
           <a:bodyPr xmlns:a="http://schemas.openxmlformats.org/drawingml/2006/main"/>
           <a:lstStyle xmlns:a="http://schemas.openxmlformats.org/drawingml/2006/main">
             <a:defPPr>
-              <a:defRPr sz="1800" b="1">
+              <a:defRPr sz="1650" b="1">
                 <a:solidFill>
                   <a:srgbClr val="3E9197"/>
                 </a:solidFill>
               </a:defRPr>
             </a:defPPr>
             <a:lvl1pPr>
-              <a:defRPr sz="1800" b="1">
+              <a:defRPr sz="1650" b="1">
                 <a:solidFill>
                   <a:srgbClr val="3E9197"/>
                 </a:solidFill>
               </a:defRPr>
             </a:lvl1pPr>
             <a:lvl2pPr>
-              <a:defRPr sz="1800" b="1">
+              <a:defRPr sz="1650" b="1">
                 <a:solidFill>
                   <a:srgbClr val="3E9197"/>
                 </a:solidFill>
               </a:defRPr>
             </a:lvl2pPr>
             <a:lvl3pPr>
-              <a:defRPr sz="1800" b="1">
+              <a:defRPr sz="1650" b="1">
                 <a:solidFill>
                   <a:srgbClr val="3E9197"/>
                 </a:solidFill>
               </a:defRPr>
             </a:lvl3pPr>
             <a:lvl4pPr>
-              <a:defRPr sz="1800" b="1">
+              <a:defRPr sz="1650" b="1">
                 <a:solidFill>
                   <a:srgbClr val="3E9197"/>
                 </a:solidFill>
               </a:defRPr>
             </a:lvl4pPr>
             <a:lvl5pPr>
-              <a:defRPr sz="1800" b="1">
+              <a:defRPr sz="1650" b="1">
                 <a:solidFill>
                   <a:srgbClr val="3E9197"/>
                 </a:solidFill>
               </a:defRPr>
             </a:lvl5pPr>
             <a:lvl6pPr>
-              <a:defRPr sz="1800" b="1">
+              <a:defRPr sz="1650" b="1">
                 <a:solidFill>
                   <a:srgbClr val="3E9197"/>
                 </a:solidFill>
               </a:defRPr>
             </a:lvl6pPr>
             <a:lvl7pPr>
-              <a:defRPr sz="1800" b="1">
+              <a:defRPr sz="1650" b="1">
                 <a:solidFill>
                   <a:srgbClr val="3E9197"/>
                 </a:solidFill>
               </a:defRPr>
             </a:lvl7pPr>
             <a:lvl8pPr>
-              <a:defRPr sz="1800" b="1">
+              <a:defRPr sz="1650" b="1">
                 <a:solidFill>
                   <a:srgbClr val="3E9197"/>
                 </a:solidFill>
               </a:defRPr>
             </a:lvl8pPr>
             <a:lvl9pPr>
-              <a:defRPr sz="1800" b="1">
+              <a:defRPr sz="1650" b="1">
                 <a:solidFill>
                   <a:srgbClr val="3E9197"/>
                 </a:solidFill>
@@ -6205,14 +6205,14 @@
           </a:lstStyle>
           <a:p xmlns:a="http://schemas.openxmlformats.org/drawingml/2006/main">
             <a:pPr>
-              <a:defRPr sz="1800" b="1">
+              <a:defRPr sz="1650" b="1">
                 <a:solidFill>
                   <a:srgbClr val="3E9197"/>
                 </a:solidFill>
               </a:defRPr>
             </a:pPr>
             <a:r>
-              <a:rPr sz="1800" b="1">
+              <a:rPr sz="1650" b="1">
                 <a:solidFill>
                   <a:srgbClr val="3E9197"/>
                 </a:solidFill>
@@ -6227,7 +6227,7 @@
           <p:cNvPr id="10" name="">
             <a:extLst xmlns:a="http://schemas.openxmlformats.org/drawingml/2006/main">
               <a:ext uri="{FF2B5EF4-FFF2-40B4-BE49-F238E27FC236}">
-                <a16:creationId xmlns:a16="http://schemas.microsoft.com/office/drawing/2014/main" id="{E1412998-F8A1-4CB1-A285-2FE2B907BB4E}"/>
+                <a16:creationId xmlns:a16="http://schemas.microsoft.com/office/drawing/2014/main" id="{482EE03C-1D65-486C-9C59-0AFF5FD8EB8A}"/>
               </a:ext>
             </a:extLst>
           </p:cNvPr>
@@ -6238,8 +6238,8 @@
         </p:nvSpPr>
         <p:spPr>
           <a:xfrm xmlns:a="http://schemas.openxmlformats.org/drawingml/2006/main">
-            <a:off x="1457325" y="4019550"/>
-            <a:ext cx="6781800" cy="762000"/>
+            <a:off x="1314450" y="3743325"/>
+            <a:ext cx="6877050" cy="685800"/>
           </a:xfrm>
           <a:prstGeom xmlns:a="http://schemas.openxmlformats.org/drawingml/2006/main" prst="rect">
             <a:avLst/>
@@ -6254,70 +6254,70 @@
           <a:bodyPr xmlns:a="http://schemas.openxmlformats.org/drawingml/2006/main"/>
           <a:lstStyle xmlns:a="http://schemas.openxmlformats.org/drawingml/2006/main">
             <a:defPPr>
-              <a:defRPr sz="2025" b="0">
+              <a:defRPr sz="1875" b="0">
                 <a:solidFill>
                   <a:srgbClr val="17324D"/>
                 </a:solidFill>
               </a:defRPr>
             </a:defPPr>
             <a:lvl1pPr>
-              <a:defRPr sz="2025" b="0">
+              <a:defRPr sz="1875" b="0">
                 <a:solidFill>
                   <a:srgbClr val="17324D"/>
                 </a:solidFill>
               </a:defRPr>
             </a:lvl1pPr>
             <a:lvl2pPr>
-              <a:defRPr sz="2025" b="0">
+              <a:defRPr sz="1875" b="0">
                 <a:solidFill>
                   <a:srgbClr val="17324D"/>
                 </a:solidFill>
               </a:defRPr>
             </a:lvl2pPr>
             <a:lvl3pPr>
-              <a:defRPr sz="2025" b="0">
+              <a:defRPr sz="1875" b="0">
                 <a:solidFill>
                   <a:srgbClr val="17324D"/>
                 </a:solidFill>
               </a:defRPr>
             </a:lvl3pPr>
             <a:lvl4pPr>
-              <a:defRPr sz="2025" b="0">
+              <a:defRPr sz="1875" b="0">
                 <a:solidFill>
                   <a:srgbClr val="17324D"/>
                 </a:solidFill>
               </a:defRPr>
             </a:lvl4pPr>
             <a:lvl5pPr>
-              <a:defRPr sz="2025" b="0">
+              <a:defRPr sz="1875" b="0">
                 <a:solidFill>
                   <a:srgbClr val="17324D"/>
                 </a:solidFill>
               </a:defRPr>
             </a:lvl5pPr>
             <a:lvl6pPr>
-              <a:defRPr sz="2025" b="0">
+              <a:defRPr sz="1875" b="0">
                 <a:solidFill>
                   <a:srgbClr val="17324D"/>
                 </a:solidFill>
               </a:defRPr>
             </a:lvl6pPr>
             <a:lvl7pPr>
-              <a:defRPr sz="2025" b="0">
+              <a:defRPr sz="1875" b="0">
                 <a:solidFill>
                   <a:srgbClr val="17324D"/>
                 </a:solidFill>
               </a:defRPr>
             </a:lvl7pPr>
             <a:lvl8pPr>
-              <a:defRPr sz="2025" b="0">
+              <a:defRPr sz="1875" b="0">
                 <a:solidFill>
                   <a:srgbClr val="17324D"/>
                 </a:solidFill>
               </a:defRPr>
             </a:lvl8pPr>
             <a:lvl9pPr>
-              <a:defRPr sz="2025" b="0">
+              <a:defRPr sz="1875" b="0">
                 <a:solidFill>
                   <a:srgbClr val="17324D"/>
                 </a:solidFill>
@@ -6326,19 +6326,19 @@
           </a:lstStyle>
           <a:p xmlns:a="http://schemas.openxmlformats.org/drawingml/2006/main">
             <a:pPr>
-              <a:defRPr sz="2025" b="0">
+              <a:defRPr sz="1875" b="0">
                 <a:solidFill>
                   <a:srgbClr val="17324D"/>
                 </a:solidFill>
               </a:defRPr>
             </a:pPr>
             <a:r>
-              <a:rPr sz="2025" b="0">
+              <a:rPr sz="1875" b="0">
                 <a:solidFill>
                   <a:srgbClr val="17324D"/>
                 </a:solidFill>
               </a:rPr>
-              <a:t>Rename the copy with your name</a:t>
+              <a:t>Run Runtime check and rename your copy</a:t>
             </a:r>
           </a:p>
         </p:txBody>
@@ -6348,7 +6348,7 @@
           <p:cNvPr id="11" name="">
             <a:extLst xmlns:a="http://schemas.openxmlformats.org/drawingml/2006/main">
               <a:ext uri="{FF2B5EF4-FFF2-40B4-BE49-F238E27FC236}">
-                <a16:creationId xmlns:a16="http://schemas.microsoft.com/office/drawing/2014/main" id="{190B3874-3290-42E1-9D3F-57F0FD5002C5}"/>
+                <a16:creationId xmlns:a16="http://schemas.microsoft.com/office/drawing/2014/main" id="{07FA755B-DD88-41B4-9874-40B872FEE327}"/>
               </a:ext>
             </a:extLst>
           </p:cNvPr>
@@ -6359,8 +6359,8 @@
         </p:nvSpPr>
         <p:spPr>
           <a:xfrm xmlns:a="http://schemas.openxmlformats.org/drawingml/2006/main">
-            <a:off x="8524875" y="1571625"/>
-            <a:ext cx="2571750" cy="2619375"/>
+            <a:off x="8524875" y="1476375"/>
+            <a:ext cx="2571750" cy="2714625"/>
           </a:xfrm>
           <a:prstGeom xmlns:a="http://schemas.openxmlformats.org/drawingml/2006/main" prst="roundRect">
             <a:avLst>
@@ -6381,7 +6381,7 @@
           <p:cNvPr id="12" name="">
             <a:extLst xmlns:a="http://schemas.openxmlformats.org/drawingml/2006/main">
               <a:ext uri="{FF2B5EF4-FFF2-40B4-BE49-F238E27FC236}">
-                <a16:creationId xmlns:a16="http://schemas.microsoft.com/office/drawing/2014/main" id="{87FE28EF-20A6-4565-8F4B-1440C29796FE}"/>
+                <a16:creationId xmlns:a16="http://schemas.microsoft.com/office/drawing/2014/main" id="{FC9A0824-C4FF-4E2E-A051-BD87C3CA5499}"/>
               </a:ext>
             </a:extLst>
           </p:cNvPr>
@@ -6392,7 +6392,7 @@
         </p:nvSpPr>
         <p:spPr>
           <a:xfrm xmlns:a="http://schemas.openxmlformats.org/drawingml/2006/main">
-            <a:off x="8905875" y="2190750"/>
+            <a:off x="8905875" y="2095500"/>
             <a:ext cx="1809750" cy="457200"/>
           </a:xfrm>
           <a:prstGeom xmlns:a="http://schemas.openxmlformats.org/drawingml/2006/main" prst="rect">
@@ -6502,7 +6502,7 @@
           <p:cNvPr id="13" name="">
             <a:extLst xmlns:a="http://schemas.openxmlformats.org/drawingml/2006/main">
               <a:ext uri="{FF2B5EF4-FFF2-40B4-BE49-F238E27FC236}">
-                <a16:creationId xmlns:a16="http://schemas.microsoft.com/office/drawing/2014/main" id="{94C2DC55-669E-45B0-A0C4-7AC61646661A}"/>
+                <a16:creationId xmlns:a16="http://schemas.microsoft.com/office/drawing/2014/main" id="{6E328DDE-3653-4B06-9F9C-05B2219AD1EE}"/>
               </a:ext>
             </a:extLst>
           </p:cNvPr>
@@ -6513,7 +6513,7 @@
         </p:nvSpPr>
         <p:spPr>
           <a:xfrm xmlns:a="http://schemas.openxmlformats.org/drawingml/2006/main">
-            <a:off x="8905875" y="3095625"/>
+            <a:off x="8905875" y="3000375"/>
             <a:ext cx="1809750" cy="762000"/>
           </a:xfrm>
           <a:prstGeom xmlns:a="http://schemas.openxmlformats.org/drawingml/2006/main" prst="rect">
@@ -6640,7 +6640,7 @@
           <p:cNvPr id="14" name="">
             <a:extLst xmlns:a="http://schemas.openxmlformats.org/drawingml/2006/main">
               <a:ext uri="{FF2B5EF4-FFF2-40B4-BE49-F238E27FC236}">
-                <a16:creationId xmlns:a16="http://schemas.microsoft.com/office/drawing/2014/main" id="{CAB923CC-4109-4474-B389-DE0A7B32A820}"/>
+                <a16:creationId xmlns:a16="http://schemas.microsoft.com/office/drawing/2014/main" id="{98DC3E3E-AF8A-401D-820C-F5DEB4D6931D}"/>
               </a:ext>
             </a:extLst>
           </p:cNvPr>
@@ -6651,7 +6651,128 @@
         </p:nvSpPr>
         <p:spPr>
           <a:xfrm xmlns:a="http://schemas.openxmlformats.org/drawingml/2006/main">
-            <a:off x="1428750" y="5334000"/>
+            <a:off x="1285875" y="4905375"/>
+            <a:ext cx="9620250" cy="361950"/>
+          </a:xfrm>
+          <a:prstGeom xmlns:a="http://schemas.openxmlformats.org/drawingml/2006/main" prst="rect">
+            <a:avLst/>
+          </a:prstGeom>
+          <a:noFill xmlns:a="http://schemas.openxmlformats.org/drawingml/2006/main"/>
+          <a:ln xmlns:a="http://schemas.openxmlformats.org/drawingml/2006/main" w="0">
+            <a:noFill/>
+            <a:prstDash val="solid"/>
+          </a:ln>
+        </p:spPr>
+        <p:txBody>
+          <a:bodyPr xmlns:a="http://schemas.openxmlformats.org/drawingml/2006/main"/>
+          <a:lstStyle xmlns:a="http://schemas.openxmlformats.org/drawingml/2006/main">
+            <a:defPPr algn="ctr">
+              <a:defRPr sz="1650" b="1">
+                <a:solidFill>
+                  <a:srgbClr val="367D96"/>
+                </a:solidFill>
+              </a:defRPr>
+            </a:defPPr>
+            <a:lvl1pPr algn="ctr">
+              <a:defRPr sz="1650" b="1">
+                <a:solidFill>
+                  <a:srgbClr val="367D96"/>
+                </a:solidFill>
+              </a:defRPr>
+            </a:lvl1pPr>
+            <a:lvl2pPr algn="ctr">
+              <a:defRPr sz="1650" b="1">
+                <a:solidFill>
+                  <a:srgbClr val="367D96"/>
+                </a:solidFill>
+              </a:defRPr>
+            </a:lvl2pPr>
+            <a:lvl3pPr algn="ctr">
+              <a:defRPr sz="1650" b="1">
+                <a:solidFill>
+                  <a:srgbClr val="367D96"/>
+                </a:solidFill>
+              </a:defRPr>
+            </a:lvl3pPr>
+            <a:lvl4pPr algn="ctr">
+              <a:defRPr sz="1650" b="1">
+                <a:solidFill>
+                  <a:srgbClr val="367D96"/>
+                </a:solidFill>
+              </a:defRPr>
+            </a:lvl4pPr>
+            <a:lvl5pPr algn="ctr">
+              <a:defRPr sz="1650" b="1">
+                <a:solidFill>
+                  <a:srgbClr val="367D96"/>
+                </a:solidFill>
+              </a:defRPr>
+            </a:lvl5pPr>
+            <a:lvl6pPr algn="ctr">
+              <a:defRPr sz="1650" b="1">
+                <a:solidFill>
+                  <a:srgbClr val="367D96"/>
+                </a:solidFill>
+              </a:defRPr>
+            </a:lvl6pPr>
+            <a:lvl7pPr algn="ctr">
+              <a:defRPr sz="1650" b="1">
+                <a:solidFill>
+                  <a:srgbClr val="367D96"/>
+                </a:solidFill>
+              </a:defRPr>
+            </a:lvl7pPr>
+            <a:lvl8pPr algn="ctr">
+              <a:defRPr sz="1650" b="1">
+                <a:solidFill>
+                  <a:srgbClr val="367D96"/>
+                </a:solidFill>
+              </a:defRPr>
+            </a:lvl8pPr>
+            <a:lvl9pPr algn="ctr">
+              <a:defRPr sz="1650" b="1">
+                <a:solidFill>
+                  <a:srgbClr val="367D96"/>
+                </a:solidFill>
+              </a:defRPr>
+            </a:lvl9pPr>
+          </a:lstStyle>
+          <a:p xmlns:a="http://schemas.openxmlformats.org/drawingml/2006/main">
+            <a:pPr algn="ctr">
+              <a:defRPr sz="1650" b="1">
+                <a:solidFill>
+                  <a:srgbClr val="367D96"/>
+                </a:solidFill>
+              </a:defRPr>
+            </a:pPr>
+            <a:r>
+              <a:rPr sz="1650" b="1">
+                <a:solidFill>
+                  <a:srgbClr val="367D96"/>
+                </a:solidFill>
+              </a:rPr>
+              <a:t>github.com/lhernandez-sudo/project-syncere-cs-2027</a:t>
+            </a:r>
+          </a:p>
+        </p:txBody>
+      </p:sp>
+      <p:sp>
+        <p:nvSpPr>
+          <p:cNvPr id="15" name="">
+            <a:extLst xmlns:a="http://schemas.openxmlformats.org/drawingml/2006/main">
+              <a:ext uri="{FF2B5EF4-FFF2-40B4-BE49-F238E27FC236}">
+                <a16:creationId xmlns:a16="http://schemas.microsoft.com/office/drawing/2014/main" id="{4E686B27-D287-483D-AF6A-C7BBECB03ABC}"/>
+              </a:ext>
+            </a:extLst>
+          </p:cNvPr>
+          <p:cNvSpPr>
+            <a:spLocks xmlns:a="http://schemas.openxmlformats.org/drawingml/2006/main" noGrp="1"/>
+          </p:cNvSpPr>
+          <p:nvPr/>
+        </p:nvSpPr>
+        <p:spPr>
+          <a:xfrm xmlns:a="http://schemas.openxmlformats.org/drawingml/2006/main">
+            <a:off x="1428750" y="5476875"/>
             <a:ext cx="9334500" cy="400050"/>
           </a:xfrm>
           <a:prstGeom xmlns:a="http://schemas.openxmlformats.org/drawingml/2006/main" prst="rect">
@@ -6667,70 +6788,70 @@
           <a:bodyPr xmlns:a="http://schemas.openxmlformats.org/drawingml/2006/main"/>
           <a:lstStyle xmlns:a="http://schemas.openxmlformats.org/drawingml/2006/main">
             <a:defPPr algn="ctr">
-              <a:defRPr sz="1800" b="1">
+              <a:defRPr sz="1725" b="1">
                 <a:solidFill>
                   <a:srgbClr val="DF6665"/>
                 </a:solidFill>
               </a:defRPr>
             </a:defPPr>
             <a:lvl1pPr algn="ctr">
-              <a:defRPr sz="1800" b="1">
+              <a:defRPr sz="1725" b="1">
                 <a:solidFill>
                   <a:srgbClr val="DF6665"/>
                 </a:solidFill>
               </a:defRPr>
             </a:lvl1pPr>
             <a:lvl2pPr algn="ctr">
-              <a:defRPr sz="1800" b="1">
+              <a:defRPr sz="1725" b="1">
                 <a:solidFill>
                   <a:srgbClr val="DF6665"/>
                 </a:solidFill>
               </a:defRPr>
             </a:lvl2pPr>
             <a:lvl3pPr algn="ctr">
-              <a:defRPr sz="1800" b="1">
+              <a:defRPr sz="1725" b="1">
                 <a:solidFill>
                   <a:srgbClr val="DF6665"/>
                 </a:solidFill>
               </a:defRPr>
             </a:lvl3pPr>
             <a:lvl4pPr algn="ctr">
-              <a:defRPr sz="1800" b="1">
+              <a:defRPr sz="1725" b="1">
                 <a:solidFill>
                   <a:srgbClr val="DF6665"/>
                 </a:solidFill>
               </a:defRPr>
             </a:lvl4pPr>
             <a:lvl5pPr algn="ctr">
-              <a:defRPr sz="1800" b="1">
+              <a:defRPr sz="1725" b="1">
                 <a:solidFill>
                   <a:srgbClr val="DF6665"/>
                 </a:solidFill>
               </a:defRPr>
             </a:lvl5pPr>
             <a:lvl6pPr algn="ctr">
-              <a:defRPr sz="1800" b="1">
+              <a:defRPr sz="1725" b="1">
                 <a:solidFill>
                   <a:srgbClr val="DF6665"/>
                 </a:solidFill>
               </a:defRPr>
             </a:lvl6pPr>
             <a:lvl7pPr algn="ctr">
-              <a:defRPr sz="1800" b="1">
+              <a:defRPr sz="1725" b="1">
                 <a:solidFill>
                   <a:srgbClr val="DF6665"/>
                 </a:solidFill>
               </a:defRPr>
             </a:lvl7pPr>
             <a:lvl8pPr algn="ctr">
-              <a:defRPr sz="1800" b="1">
+              <a:defRPr sz="1725" b="1">
                 <a:solidFill>
                   <a:srgbClr val="DF6665"/>
                 </a:solidFill>
               </a:defRPr>
             </a:lvl8pPr>
             <a:lvl9pPr algn="ctr">
-              <a:defRPr sz="1800" b="1">
+              <a:defRPr sz="1725" b="1">
                 <a:solidFill>
                   <a:srgbClr val="DF6665"/>
                 </a:solidFill>
@@ -6739,14 +6860,14 @@
           </a:lstStyle>
           <a:p xmlns:a="http://schemas.openxmlformats.org/drawingml/2006/main">
             <a:pPr algn="ctr">
-              <a:defRPr sz="1800" b="1">
+              <a:defRPr sz="1725" b="1">
                 <a:solidFill>
                   <a:srgbClr val="DF6665"/>
                 </a:solidFill>
               </a:defRPr>
             </a:pPr>
             <a:r>
-              <a:rPr sz="1800" b="1">
+              <a:rPr sz="1725" b="1">
                 <a:solidFill>
                   <a:srgbClr val="DF6665"/>
                 </a:solidFill>
@@ -6758,10 +6879,10 @@
       </p:sp>
       <p:sp>
         <p:nvSpPr>
-          <p:cNvPr id="15" name="">
+          <p:cNvPr id="16" name="">
             <a:extLst xmlns:a="http://schemas.openxmlformats.org/drawingml/2006/main">
               <a:ext uri="{FF2B5EF4-FFF2-40B4-BE49-F238E27FC236}">
-                <a16:creationId xmlns:a16="http://schemas.microsoft.com/office/drawing/2014/main" id="{58AE99B4-3420-4212-BCD7-6D2DD008AAC0}"/>
+                <a16:creationId xmlns:a16="http://schemas.microsoft.com/office/drawing/2014/main" id="{0107908D-28EC-4D25-97A2-68B457544A46}"/>
               </a:ext>
             </a:extLst>
           </p:cNvPr>
@@ -6880,7 +7001,7 @@
     </p:spTree>
     <p:extLst>
       <p:ext uri="{BB962C8B-B14F-4D97-AF65-F5344CB8AC3E}">
-        <p14:creationId xmlns:p14="http://schemas.microsoft.com/office/powerpoint/2010/main" val="746939203"/>
+        <p14:creationId xmlns:p14="http://schemas.microsoft.com/office/powerpoint/2010/main" val="158052092"/>
       </p:ext>
     </p:extLst>
   </p:cSld>
@@ -6911,7 +7032,7 @@
           <p:cNvPr id="17" name="">
             <a:extLst xmlns:a="http://schemas.openxmlformats.org/drawingml/2006/main">
               <a:ext uri="{FF2B5EF4-FFF2-40B4-BE49-F238E27FC236}">
-                <a16:creationId xmlns:a16="http://schemas.microsoft.com/office/drawing/2014/main" id="{9BC998D4-DCD7-432A-B307-6CD79FF0B0B0}"/>
+                <a16:creationId xmlns:a16="http://schemas.microsoft.com/office/drawing/2014/main" id="{B1A03B18-C91E-42F8-A3EC-96CE8F6B34E3}"/>
               </a:ext>
             </a:extLst>
           </p:cNvPr>
@@ -7032,7 +7153,7 @@
           <p:cNvPr id="2" name="">
             <a:extLst xmlns:a="http://schemas.openxmlformats.org/drawingml/2006/main">
               <a:ext uri="{FF2B5EF4-FFF2-40B4-BE49-F238E27FC236}">
-                <a16:creationId xmlns:a16="http://schemas.microsoft.com/office/drawing/2014/main" id="{41B07012-11B9-47D7-A58C-1C32D1E0A10C}"/>
+                <a16:creationId xmlns:a16="http://schemas.microsoft.com/office/drawing/2014/main" id="{2F76CAEC-1539-4310-A552-67AD8DDCC910}"/>
               </a:ext>
             </a:extLst>
           </p:cNvPr>
@@ -7153,7 +7274,7 @@
           <p:cNvPr id="3" name="">
             <a:extLst xmlns:a="http://schemas.openxmlformats.org/drawingml/2006/main">
               <a:ext uri="{FF2B5EF4-FFF2-40B4-BE49-F238E27FC236}">
-                <a16:creationId xmlns:a16="http://schemas.microsoft.com/office/drawing/2014/main" id="{0C69E5DD-9E0D-4DAB-BF46-6181D614AF83}"/>
+                <a16:creationId xmlns:a16="http://schemas.microsoft.com/office/drawing/2014/main" id="{E79F1F71-6C50-49BC-9E14-926D8D4FBB64}"/>
               </a:ext>
             </a:extLst>
           </p:cNvPr>
@@ -7274,7 +7395,7 @@
           <p:cNvPr id="4" name="">
             <a:extLst xmlns:a="http://schemas.openxmlformats.org/drawingml/2006/main">
               <a:ext uri="{FF2B5EF4-FFF2-40B4-BE49-F238E27FC236}">
-                <a16:creationId xmlns:a16="http://schemas.microsoft.com/office/drawing/2014/main" id="{C93A0E93-54DB-4B44-BDC7-A136FB937898}"/>
+                <a16:creationId xmlns:a16="http://schemas.microsoft.com/office/drawing/2014/main" id="{BC12CB68-2BA5-4D9A-86AB-A1CFC42B4C9B}"/>
               </a:ext>
             </a:extLst>
           </p:cNvPr>
@@ -7395,7 +7516,7 @@
           <p:cNvPr id="5" name="">
             <a:extLst xmlns:a="http://schemas.openxmlformats.org/drawingml/2006/main">
               <a:ext uri="{FF2B5EF4-FFF2-40B4-BE49-F238E27FC236}">
-                <a16:creationId xmlns:a16="http://schemas.microsoft.com/office/drawing/2014/main" id="{950AFD58-3C7A-48FB-A069-C88ACDC805CA}"/>
+                <a16:creationId xmlns:a16="http://schemas.microsoft.com/office/drawing/2014/main" id="{636E39B5-E1CB-416C-B07E-7DD65F60521F}"/>
               </a:ext>
             </a:extLst>
           </p:cNvPr>
@@ -7516,7 +7637,7 @@
           <p:cNvPr id="6" name="">
             <a:extLst xmlns:a="http://schemas.openxmlformats.org/drawingml/2006/main">
               <a:ext uri="{FF2B5EF4-FFF2-40B4-BE49-F238E27FC236}">
-                <a16:creationId xmlns:a16="http://schemas.microsoft.com/office/drawing/2014/main" id="{FFD7D8FD-57C3-429E-8648-1B144CA7A4CA}"/>
+                <a16:creationId xmlns:a16="http://schemas.microsoft.com/office/drawing/2014/main" id="{BC16B8A8-72D8-4D81-9CDE-31BDCA780976}"/>
               </a:ext>
             </a:extLst>
           </p:cNvPr>
@@ -7637,7 +7758,7 @@
           <p:cNvPr id="7" name="">
             <a:extLst xmlns:a="http://schemas.openxmlformats.org/drawingml/2006/main">
               <a:ext uri="{FF2B5EF4-FFF2-40B4-BE49-F238E27FC236}">
-                <a16:creationId xmlns:a16="http://schemas.microsoft.com/office/drawing/2014/main" id="{D2DD7540-8BC2-41F6-88B7-3C98AD07F3F5}"/>
+                <a16:creationId xmlns:a16="http://schemas.microsoft.com/office/drawing/2014/main" id="{8386C1DE-BDA8-4AB2-B8BA-54F6612109DE}"/>
               </a:ext>
             </a:extLst>
           </p:cNvPr>
@@ -7758,7 +7879,7 @@
           <p:cNvPr id="8" name="">
             <a:extLst xmlns:a="http://schemas.openxmlformats.org/drawingml/2006/main">
               <a:ext uri="{FF2B5EF4-FFF2-40B4-BE49-F238E27FC236}">
-                <a16:creationId xmlns:a16="http://schemas.microsoft.com/office/drawing/2014/main" id="{99EBB272-1EA3-4EF5-A77F-FC21BEDE8F2C}"/>
+                <a16:creationId xmlns:a16="http://schemas.microsoft.com/office/drawing/2014/main" id="{97F11320-A51A-4DFE-B035-92856EF7244B}"/>
               </a:ext>
             </a:extLst>
           </p:cNvPr>
@@ -7879,7 +8000,7 @@
           <p:cNvPr id="9" name="">
             <a:extLst xmlns:a="http://schemas.openxmlformats.org/drawingml/2006/main">
               <a:ext uri="{FF2B5EF4-FFF2-40B4-BE49-F238E27FC236}">
-                <a16:creationId xmlns:a16="http://schemas.microsoft.com/office/drawing/2014/main" id="{93834A71-1630-4B4E-9790-CE16AC0A687E}"/>
+                <a16:creationId xmlns:a16="http://schemas.microsoft.com/office/drawing/2014/main" id="{9ACB6CBD-646F-4894-86D8-C3A62BDBCA70}"/>
               </a:ext>
             </a:extLst>
           </p:cNvPr>
@@ -8000,7 +8121,7 @@
           <p:cNvPr id="10" name="">
             <a:extLst xmlns:a="http://schemas.openxmlformats.org/drawingml/2006/main">
               <a:ext uri="{FF2B5EF4-FFF2-40B4-BE49-F238E27FC236}">
-                <a16:creationId xmlns:a16="http://schemas.microsoft.com/office/drawing/2014/main" id="{7327ABCF-93A7-410E-8F6D-59F0E8D989D5}"/>
+                <a16:creationId xmlns:a16="http://schemas.microsoft.com/office/drawing/2014/main" id="{4335957A-4EB2-4673-9C1C-5E6680257752}"/>
               </a:ext>
             </a:extLst>
           </p:cNvPr>
@@ -8121,7 +8242,7 @@
           <p:cNvPr id="11" name="">
             <a:extLst xmlns:a="http://schemas.openxmlformats.org/drawingml/2006/main">
               <a:ext uri="{FF2B5EF4-FFF2-40B4-BE49-F238E27FC236}">
-                <a16:creationId xmlns:a16="http://schemas.microsoft.com/office/drawing/2014/main" id="{10BFB4A3-546A-4CFF-8EDB-DB137B1702C3}"/>
+                <a16:creationId xmlns:a16="http://schemas.microsoft.com/office/drawing/2014/main" id="{2C2A2F3D-B90C-47CB-A054-1CB41C3199AA}"/>
               </a:ext>
             </a:extLst>
           </p:cNvPr>
@@ -8242,7 +8363,7 @@
           <p:cNvPr id="12" name="">
             <a:extLst xmlns:a="http://schemas.openxmlformats.org/drawingml/2006/main">
               <a:ext uri="{FF2B5EF4-FFF2-40B4-BE49-F238E27FC236}">
-                <a16:creationId xmlns:a16="http://schemas.microsoft.com/office/drawing/2014/main" id="{A8369894-87C7-434C-B4E0-58F3C334372E}"/>
+                <a16:creationId xmlns:a16="http://schemas.microsoft.com/office/drawing/2014/main" id="{07D40906-DD10-41FE-814E-FDA649E6F23E}"/>
               </a:ext>
             </a:extLst>
           </p:cNvPr>
@@ -8277,7 +8398,7 @@
           <p:cNvPr id="13" name="">
             <a:extLst xmlns:a="http://schemas.openxmlformats.org/drawingml/2006/main">
               <a:ext uri="{FF2B5EF4-FFF2-40B4-BE49-F238E27FC236}">
-                <a16:creationId xmlns:a16="http://schemas.microsoft.com/office/drawing/2014/main" id="{27F4B1E3-7FE9-40E4-8530-BD27E60C9C19}"/>
+                <a16:creationId xmlns:a16="http://schemas.microsoft.com/office/drawing/2014/main" id="{4E0DA042-90E1-430B-BBEB-C664EDCE9280}"/>
               </a:ext>
             </a:extLst>
           </p:cNvPr>
@@ -8398,7 +8519,7 @@
           <p:cNvPr id="14" name="">
             <a:extLst xmlns:a="http://schemas.openxmlformats.org/drawingml/2006/main">
               <a:ext uri="{FF2B5EF4-FFF2-40B4-BE49-F238E27FC236}">
-                <a16:creationId xmlns:a16="http://schemas.microsoft.com/office/drawing/2014/main" id="{7889E813-0FF3-4274-94D6-665CF9F693DE}"/>
+                <a16:creationId xmlns:a16="http://schemas.microsoft.com/office/drawing/2014/main" id="{F1C8BBB2-D2F9-4C0D-863C-C671351EB212}"/>
               </a:ext>
             </a:extLst>
           </p:cNvPr>
@@ -8570,7 +8691,7 @@
           <p:cNvPr id="15" name="">
             <a:extLst xmlns:a="http://schemas.openxmlformats.org/drawingml/2006/main">
               <a:ext uri="{FF2B5EF4-FFF2-40B4-BE49-F238E27FC236}">
-                <a16:creationId xmlns:a16="http://schemas.microsoft.com/office/drawing/2014/main" id="{9A93ABE2-A46D-4661-8A38-5826FEAFF410}"/>
+                <a16:creationId xmlns:a16="http://schemas.microsoft.com/office/drawing/2014/main" id="{61CEB6FC-631E-4FFB-8201-A0A70EB35551}"/>
               </a:ext>
             </a:extLst>
           </p:cNvPr>
@@ -8691,7 +8812,7 @@
           <p:cNvPr id="16" name="">
             <a:extLst xmlns:a="http://schemas.openxmlformats.org/drawingml/2006/main">
               <a:ext uri="{FF2B5EF4-FFF2-40B4-BE49-F238E27FC236}">
-                <a16:creationId xmlns:a16="http://schemas.microsoft.com/office/drawing/2014/main" id="{B27A5C8A-3A24-4A5A-A7FA-B9DBEC2FA939}"/>
+                <a16:creationId xmlns:a16="http://schemas.microsoft.com/office/drawing/2014/main" id="{95E93669-BDED-4489-B926-16C04EF8BA97}"/>
               </a:ext>
             </a:extLst>
           </p:cNvPr>
@@ -8810,7 +8931,7 @@
     </p:spTree>
     <p:extLst>
       <p:ext uri="{BB962C8B-B14F-4D97-AF65-F5344CB8AC3E}">
-        <p14:creationId xmlns:p14="http://schemas.microsoft.com/office/powerpoint/2010/main" val="1735006849"/>
+        <p14:creationId xmlns:p14="http://schemas.microsoft.com/office/powerpoint/2010/main" val="736272164"/>
       </p:ext>
     </p:extLst>
   </p:cSld>
@@ -8841,7 +8962,7 @@
           <p:cNvPr id="3" name="">
             <a:extLst xmlns:a="http://schemas.openxmlformats.org/drawingml/2006/main">
               <a:ext uri="{FF2B5EF4-FFF2-40B4-BE49-F238E27FC236}">
-                <a16:creationId xmlns:a16="http://schemas.microsoft.com/office/drawing/2014/main" id="{F5F98C46-9184-45C2-B231-C528731EB567}"/>
+                <a16:creationId xmlns:a16="http://schemas.microsoft.com/office/drawing/2014/main" id="{4B877EC2-1EF8-4087-8C22-46886B28C31D}"/>
               </a:ext>
             </a:extLst>
           </p:cNvPr>
@@ -8962,7 +9083,7 @@
           <p:cNvPr id="2" name="">
             <a:extLst xmlns:a="http://schemas.openxmlformats.org/drawingml/2006/main">
               <a:ext uri="{FF2B5EF4-FFF2-40B4-BE49-F238E27FC236}">
-                <a16:creationId xmlns:a16="http://schemas.microsoft.com/office/drawing/2014/main" id="{7285870D-6814-4FEE-BDAB-99C768861747}"/>
+                <a16:creationId xmlns:a16="http://schemas.microsoft.com/office/drawing/2014/main" id="{07C36FD4-6888-4E48-B8E3-C7792218FCF0}"/>
               </a:ext>
             </a:extLst>
           </p:cNvPr>
@@ -9081,7 +9202,7 @@
     </p:spTree>
     <p:extLst>
       <p:ext uri="{BB962C8B-B14F-4D97-AF65-F5344CB8AC3E}">
-        <p14:creationId xmlns:p14="http://schemas.microsoft.com/office/powerpoint/2010/main" val="2038382692"/>
+        <p14:creationId xmlns:p14="http://schemas.microsoft.com/office/powerpoint/2010/main" val="833993254"/>
       </p:ext>
     </p:extLst>
   </p:cSld>
@@ -9112,7 +9233,7 @@
           <p:cNvPr id="17" name="">
             <a:extLst xmlns:a="http://schemas.openxmlformats.org/drawingml/2006/main">
               <a:ext uri="{FF2B5EF4-FFF2-40B4-BE49-F238E27FC236}">
-                <a16:creationId xmlns:a16="http://schemas.microsoft.com/office/drawing/2014/main" id="{A8DF8EAB-2758-4062-9B2C-AE4E895513A4}"/>
+                <a16:creationId xmlns:a16="http://schemas.microsoft.com/office/drawing/2014/main" id="{8AAA5BA4-75A5-45BE-93EC-F530DD8F6376}"/>
               </a:ext>
             </a:extLst>
           </p:cNvPr>
@@ -9233,7 +9354,7 @@
           <p:cNvPr id="2" name="">
             <a:extLst xmlns:a="http://schemas.openxmlformats.org/drawingml/2006/main">
               <a:ext uri="{FF2B5EF4-FFF2-40B4-BE49-F238E27FC236}">
-                <a16:creationId xmlns:a16="http://schemas.microsoft.com/office/drawing/2014/main" id="{20A482E4-C2C0-4039-9080-CAC580750605}"/>
+                <a16:creationId xmlns:a16="http://schemas.microsoft.com/office/drawing/2014/main" id="{B6CB3959-D43E-41BE-9294-0CA652E75181}"/>
               </a:ext>
             </a:extLst>
           </p:cNvPr>
@@ -9354,7 +9475,7 @@
           <p:cNvPr id="3" name="">
             <a:extLst xmlns:a="http://schemas.openxmlformats.org/drawingml/2006/main">
               <a:ext uri="{FF2B5EF4-FFF2-40B4-BE49-F238E27FC236}">
-                <a16:creationId xmlns:a16="http://schemas.microsoft.com/office/drawing/2014/main" id="{1E7F73A3-F752-4221-90B1-96711A1C47C8}"/>
+                <a16:creationId xmlns:a16="http://schemas.microsoft.com/office/drawing/2014/main" id="{F0BEC09D-7BFA-463B-B7E2-9FE2302A15BA}"/>
               </a:ext>
             </a:extLst>
           </p:cNvPr>
@@ -9475,7 +9596,7 @@
           <p:cNvPr id="4" name="">
             <a:extLst xmlns:a="http://schemas.openxmlformats.org/drawingml/2006/main">
               <a:ext uri="{FF2B5EF4-FFF2-40B4-BE49-F238E27FC236}">
-                <a16:creationId xmlns:a16="http://schemas.microsoft.com/office/drawing/2014/main" id="{4B96F384-B9F4-48C5-A933-610EECCFC6A4}"/>
+                <a16:creationId xmlns:a16="http://schemas.microsoft.com/office/drawing/2014/main" id="{F630799D-8F99-4570-98A1-AA2778AC2B3A}"/>
               </a:ext>
             </a:extLst>
           </p:cNvPr>
@@ -9596,7 +9717,7 @@
           <p:cNvPr id="5" name="">
             <a:extLst xmlns:a="http://schemas.openxmlformats.org/drawingml/2006/main">
               <a:ext uri="{FF2B5EF4-FFF2-40B4-BE49-F238E27FC236}">
-                <a16:creationId xmlns:a16="http://schemas.microsoft.com/office/drawing/2014/main" id="{63DEDDD7-1D73-4CBF-86C1-553430168458}"/>
+                <a16:creationId xmlns:a16="http://schemas.microsoft.com/office/drawing/2014/main" id="{2E8370DC-6F27-4971-991C-322F92F1C94F}"/>
               </a:ext>
             </a:extLst>
           </p:cNvPr>
@@ -9717,7 +9838,7 @@
           <p:cNvPr id="6" name="">
             <a:extLst xmlns:a="http://schemas.openxmlformats.org/drawingml/2006/main">
               <a:ext uri="{FF2B5EF4-FFF2-40B4-BE49-F238E27FC236}">
-                <a16:creationId xmlns:a16="http://schemas.microsoft.com/office/drawing/2014/main" id="{97776346-F197-4940-B369-95332F913D99}"/>
+                <a16:creationId xmlns:a16="http://schemas.microsoft.com/office/drawing/2014/main" id="{BB3E3EB7-2994-4AA2-97BF-B744506EDA2E}"/>
               </a:ext>
             </a:extLst>
           </p:cNvPr>
@@ -9838,7 +9959,7 @@
           <p:cNvPr id="7" name="">
             <a:extLst xmlns:a="http://schemas.openxmlformats.org/drawingml/2006/main">
               <a:ext uri="{FF2B5EF4-FFF2-40B4-BE49-F238E27FC236}">
-                <a16:creationId xmlns:a16="http://schemas.microsoft.com/office/drawing/2014/main" id="{FB082076-FB79-4FC6-B222-20C07A790531}"/>
+                <a16:creationId xmlns:a16="http://schemas.microsoft.com/office/drawing/2014/main" id="{29DF409F-6A2B-4F3F-8057-9CF7B25126BC}"/>
               </a:ext>
             </a:extLst>
           </p:cNvPr>
@@ -9959,7 +10080,7 @@
           <p:cNvPr id="8" name="">
             <a:extLst xmlns:a="http://schemas.openxmlformats.org/drawingml/2006/main">
               <a:ext uri="{FF2B5EF4-FFF2-40B4-BE49-F238E27FC236}">
-                <a16:creationId xmlns:a16="http://schemas.microsoft.com/office/drawing/2014/main" id="{4DD779BB-C861-4935-950F-45103E92861F}"/>
+                <a16:creationId xmlns:a16="http://schemas.microsoft.com/office/drawing/2014/main" id="{0145AC65-E4EB-4636-9D90-DBD5A42C28DF}"/>
               </a:ext>
             </a:extLst>
           </p:cNvPr>
@@ -10080,7 +10201,7 @@
           <p:cNvPr id="9" name="">
             <a:extLst xmlns:a="http://schemas.openxmlformats.org/drawingml/2006/main">
               <a:ext uri="{FF2B5EF4-FFF2-40B4-BE49-F238E27FC236}">
-                <a16:creationId xmlns:a16="http://schemas.microsoft.com/office/drawing/2014/main" id="{CF63C9AF-36B8-42D5-840A-68B30DB3EDB5}"/>
+                <a16:creationId xmlns:a16="http://schemas.microsoft.com/office/drawing/2014/main" id="{B6153185-99F9-4026-ABC0-086AD28876CD}"/>
               </a:ext>
             </a:extLst>
           </p:cNvPr>
@@ -10201,7 +10322,7 @@
           <p:cNvPr id="10" name="">
             <a:extLst xmlns:a="http://schemas.openxmlformats.org/drawingml/2006/main">
               <a:ext uri="{FF2B5EF4-FFF2-40B4-BE49-F238E27FC236}">
-                <a16:creationId xmlns:a16="http://schemas.microsoft.com/office/drawing/2014/main" id="{9D8D1563-4313-407B-9B66-19654D943F42}"/>
+                <a16:creationId xmlns:a16="http://schemas.microsoft.com/office/drawing/2014/main" id="{DA48026E-27CF-456D-8704-F416758FF49A}"/>
               </a:ext>
             </a:extLst>
           </p:cNvPr>
@@ -10322,7 +10443,7 @@
           <p:cNvPr id="11" name="">
             <a:extLst xmlns:a="http://schemas.openxmlformats.org/drawingml/2006/main">
               <a:ext uri="{FF2B5EF4-FFF2-40B4-BE49-F238E27FC236}">
-                <a16:creationId xmlns:a16="http://schemas.microsoft.com/office/drawing/2014/main" id="{0929B879-707E-4235-8AE4-9714E60B1BC6}"/>
+                <a16:creationId xmlns:a16="http://schemas.microsoft.com/office/drawing/2014/main" id="{DB7E8783-D2B0-49F2-94BA-FEB98A031EA6}"/>
               </a:ext>
             </a:extLst>
           </p:cNvPr>
@@ -10443,7 +10564,7 @@
           <p:cNvPr id="12" name="">
             <a:extLst xmlns:a="http://schemas.openxmlformats.org/drawingml/2006/main">
               <a:ext uri="{FF2B5EF4-FFF2-40B4-BE49-F238E27FC236}">
-                <a16:creationId xmlns:a16="http://schemas.microsoft.com/office/drawing/2014/main" id="{C4D766BB-19CF-46F2-AC8A-30DD70B74608}"/>
+                <a16:creationId xmlns:a16="http://schemas.microsoft.com/office/drawing/2014/main" id="{2ADFDFC6-7965-4CBD-B852-549E713E2D00}"/>
               </a:ext>
             </a:extLst>
           </p:cNvPr>
@@ -10478,7 +10599,7 @@
           <p:cNvPr id="13" name="">
             <a:extLst xmlns:a="http://schemas.openxmlformats.org/drawingml/2006/main">
               <a:ext uri="{FF2B5EF4-FFF2-40B4-BE49-F238E27FC236}">
-                <a16:creationId xmlns:a16="http://schemas.microsoft.com/office/drawing/2014/main" id="{BECD66A1-880C-4032-88EB-E8FFC9A522E7}"/>
+                <a16:creationId xmlns:a16="http://schemas.microsoft.com/office/drawing/2014/main" id="{BD28A797-FB41-42D3-8408-2FC075B77FA3}"/>
               </a:ext>
             </a:extLst>
           </p:cNvPr>
@@ -10599,7 +10720,7 @@
           <p:cNvPr id="14" name="">
             <a:extLst xmlns:a="http://schemas.openxmlformats.org/drawingml/2006/main">
               <a:ext uri="{FF2B5EF4-FFF2-40B4-BE49-F238E27FC236}">
-                <a16:creationId xmlns:a16="http://schemas.microsoft.com/office/drawing/2014/main" id="{CFF38347-9C9F-4520-9A79-EA97DC0A1EAB}"/>
+                <a16:creationId xmlns:a16="http://schemas.microsoft.com/office/drawing/2014/main" id="{19F56C9F-E4F8-402D-A641-3F12B7EF9963}"/>
               </a:ext>
             </a:extLst>
           </p:cNvPr>
@@ -10754,7 +10875,7 @@
           <p:cNvPr id="15" name="">
             <a:extLst xmlns:a="http://schemas.openxmlformats.org/drawingml/2006/main">
               <a:ext uri="{FF2B5EF4-FFF2-40B4-BE49-F238E27FC236}">
-                <a16:creationId xmlns:a16="http://schemas.microsoft.com/office/drawing/2014/main" id="{9BEF1559-0706-431F-A38C-8B22E0F5503A}"/>
+                <a16:creationId xmlns:a16="http://schemas.microsoft.com/office/drawing/2014/main" id="{F7F42184-83E9-495D-A15F-2633E9CF142E}"/>
               </a:ext>
             </a:extLst>
           </p:cNvPr>
@@ -10875,7 +10996,7 @@
           <p:cNvPr id="16" name="">
             <a:extLst xmlns:a="http://schemas.openxmlformats.org/drawingml/2006/main">
               <a:ext uri="{FF2B5EF4-FFF2-40B4-BE49-F238E27FC236}">
-                <a16:creationId xmlns:a16="http://schemas.microsoft.com/office/drawing/2014/main" id="{E48426A7-C675-460A-88DC-23D937F50B82}"/>
+                <a16:creationId xmlns:a16="http://schemas.microsoft.com/office/drawing/2014/main" id="{16E2E386-AC75-4161-BF89-F80FEA318462}"/>
               </a:ext>
             </a:extLst>
           </p:cNvPr>
@@ -10994,7 +11115,7 @@
     </p:spTree>
     <p:extLst>
       <p:ext uri="{BB962C8B-B14F-4D97-AF65-F5344CB8AC3E}">
-        <p14:creationId xmlns:p14="http://schemas.microsoft.com/office/powerpoint/2010/main" val="1973680598"/>
+        <p14:creationId xmlns:p14="http://schemas.microsoft.com/office/powerpoint/2010/main" val="637869688"/>
       </p:ext>
     </p:extLst>
   </p:cSld>
@@ -11025,7 +11146,7 @@
           <p:cNvPr id="3" name="">
             <a:extLst xmlns:a="http://schemas.openxmlformats.org/drawingml/2006/main">
               <a:ext uri="{FF2B5EF4-FFF2-40B4-BE49-F238E27FC236}">
-                <a16:creationId xmlns:a16="http://schemas.microsoft.com/office/drawing/2014/main" id="{23B3C295-6D8B-4E22-85DE-6B7B225FFA00}"/>
+                <a16:creationId xmlns:a16="http://schemas.microsoft.com/office/drawing/2014/main" id="{6EB7F724-2B86-49D4-84E2-72B06337EEA9}"/>
               </a:ext>
             </a:extLst>
           </p:cNvPr>
@@ -11146,7 +11267,7 @@
           <p:cNvPr id="2" name="">
             <a:extLst xmlns:a="http://schemas.openxmlformats.org/drawingml/2006/main">
               <a:ext uri="{FF2B5EF4-FFF2-40B4-BE49-F238E27FC236}">
-                <a16:creationId xmlns:a16="http://schemas.microsoft.com/office/drawing/2014/main" id="{EDF850FD-9EFF-4E09-B28E-05DBF2DC41F8}"/>
+                <a16:creationId xmlns:a16="http://schemas.microsoft.com/office/drawing/2014/main" id="{5C647D78-F89B-48B3-8562-6DA994C0093D}"/>
               </a:ext>
             </a:extLst>
           </p:cNvPr>
@@ -11265,7 +11386,7 @@
     </p:spTree>
     <p:extLst>
       <p:ext uri="{BB962C8B-B14F-4D97-AF65-F5344CB8AC3E}">
-        <p14:creationId xmlns:p14="http://schemas.microsoft.com/office/powerpoint/2010/main" val="1769717962"/>
+        <p14:creationId xmlns:p14="http://schemas.microsoft.com/office/powerpoint/2010/main" val="537076591"/>
       </p:ext>
     </p:extLst>
   </p:cSld>
@@ -11296,7 +11417,7 @@
           <p:cNvPr id="16" name="">
             <a:extLst xmlns:a="http://schemas.openxmlformats.org/drawingml/2006/main">
               <a:ext uri="{FF2B5EF4-FFF2-40B4-BE49-F238E27FC236}">
-                <a16:creationId xmlns:a16="http://schemas.microsoft.com/office/drawing/2014/main" id="{FB8E4C24-A1C8-4251-B600-9D953C0201C5}"/>
+                <a16:creationId xmlns:a16="http://schemas.microsoft.com/office/drawing/2014/main" id="{F7B69105-D430-4C0F-92B8-C62A4B01094F}"/>
               </a:ext>
             </a:extLst>
           </p:cNvPr>
@@ -11417,7 +11538,7 @@
           <p:cNvPr id="2" name="">
             <a:extLst xmlns:a="http://schemas.openxmlformats.org/drawingml/2006/main">
               <a:ext uri="{FF2B5EF4-FFF2-40B4-BE49-F238E27FC236}">
-                <a16:creationId xmlns:a16="http://schemas.microsoft.com/office/drawing/2014/main" id="{28A7BA84-E45D-4283-9F6A-3848F6D8BD8B}"/>
+                <a16:creationId xmlns:a16="http://schemas.microsoft.com/office/drawing/2014/main" id="{18C33A29-FD54-459B-8F4C-58EF78C22F70}"/>
               </a:ext>
             </a:extLst>
           </p:cNvPr>
@@ -11538,7 +11659,7 @@
           <p:cNvPr id="3" name="">
             <a:extLst xmlns:a="http://schemas.openxmlformats.org/drawingml/2006/main">
               <a:ext uri="{FF2B5EF4-FFF2-40B4-BE49-F238E27FC236}">
-                <a16:creationId xmlns:a16="http://schemas.microsoft.com/office/drawing/2014/main" id="{2A7649B1-EC32-4787-A337-266E2E5CBC6A}"/>
+                <a16:creationId xmlns:a16="http://schemas.microsoft.com/office/drawing/2014/main" id="{F25DD731-E754-4EDB-B529-CDAF8B73AD9B}"/>
               </a:ext>
             </a:extLst>
           </p:cNvPr>
@@ -11659,7 +11780,7 @@
           <p:cNvPr id="4" name="">
             <a:extLst xmlns:a="http://schemas.openxmlformats.org/drawingml/2006/main">
               <a:ext uri="{FF2B5EF4-FFF2-40B4-BE49-F238E27FC236}">
-                <a16:creationId xmlns:a16="http://schemas.microsoft.com/office/drawing/2014/main" id="{352EA901-1AA0-4273-8239-0246D83DC54F}"/>
+                <a16:creationId xmlns:a16="http://schemas.microsoft.com/office/drawing/2014/main" id="{F1F8652E-CD3B-4030-8063-8F18527E0C5C}"/>
               </a:ext>
             </a:extLst>
           </p:cNvPr>
@@ -11780,7 +11901,7 @@
           <p:cNvPr id="5" name="">
             <a:extLst xmlns:a="http://schemas.openxmlformats.org/drawingml/2006/main">
               <a:ext uri="{FF2B5EF4-FFF2-40B4-BE49-F238E27FC236}">
-                <a16:creationId xmlns:a16="http://schemas.microsoft.com/office/drawing/2014/main" id="{79B313C3-45AE-4292-B440-DC1CFF1B1D7A}"/>
+                <a16:creationId xmlns:a16="http://schemas.microsoft.com/office/drawing/2014/main" id="{F7EDA4FD-7F7E-4EB6-AD8D-FD2C6CB0FF17}"/>
               </a:ext>
             </a:extLst>
           </p:cNvPr>
@@ -11901,7 +12022,7 @@
           <p:cNvPr id="6" name="">
             <a:extLst xmlns:a="http://schemas.openxmlformats.org/drawingml/2006/main">
               <a:ext uri="{FF2B5EF4-FFF2-40B4-BE49-F238E27FC236}">
-                <a16:creationId xmlns:a16="http://schemas.microsoft.com/office/drawing/2014/main" id="{58EF1878-ECB0-45AA-AFF5-C16202BB2E3C}"/>
+                <a16:creationId xmlns:a16="http://schemas.microsoft.com/office/drawing/2014/main" id="{CDC92B98-2E98-40A8-8014-4B96A615EF81}"/>
               </a:ext>
             </a:extLst>
           </p:cNvPr>
@@ -12022,7 +12143,7 @@
           <p:cNvPr id="7" name="">
             <a:extLst xmlns:a="http://schemas.openxmlformats.org/drawingml/2006/main">
               <a:ext uri="{FF2B5EF4-FFF2-40B4-BE49-F238E27FC236}">
-                <a16:creationId xmlns:a16="http://schemas.microsoft.com/office/drawing/2014/main" id="{0C984773-4C53-4D32-9332-76857D7AFEB0}"/>
+                <a16:creationId xmlns:a16="http://schemas.microsoft.com/office/drawing/2014/main" id="{A19D511E-7FAF-4FED-B74A-500E149FA8D9}"/>
               </a:ext>
             </a:extLst>
           </p:cNvPr>
@@ -12143,7 +12264,7 @@
           <p:cNvPr id="8" name="">
             <a:extLst xmlns:a="http://schemas.openxmlformats.org/drawingml/2006/main">
               <a:ext uri="{FF2B5EF4-FFF2-40B4-BE49-F238E27FC236}">
-                <a16:creationId xmlns:a16="http://schemas.microsoft.com/office/drawing/2014/main" id="{8A563E29-6865-485A-AC3B-4E3F1E3861FB}"/>
+                <a16:creationId xmlns:a16="http://schemas.microsoft.com/office/drawing/2014/main" id="{1603114D-E5D6-49C7-97CC-AB5676FFB1A2}"/>
               </a:ext>
             </a:extLst>
           </p:cNvPr>
@@ -12264,7 +12385,7 @@
           <p:cNvPr id="9" name="">
             <a:extLst xmlns:a="http://schemas.openxmlformats.org/drawingml/2006/main">
               <a:ext uri="{FF2B5EF4-FFF2-40B4-BE49-F238E27FC236}">
-                <a16:creationId xmlns:a16="http://schemas.microsoft.com/office/drawing/2014/main" id="{CF4C756F-293F-48CF-BC22-96443800BA43}"/>
+                <a16:creationId xmlns:a16="http://schemas.microsoft.com/office/drawing/2014/main" id="{5E82210B-E594-4C25-A8C9-98C462E991AD}"/>
               </a:ext>
             </a:extLst>
           </p:cNvPr>
@@ -12385,7 +12506,7 @@
           <p:cNvPr id="10" name="">
             <a:extLst xmlns:a="http://schemas.openxmlformats.org/drawingml/2006/main">
               <a:ext uri="{FF2B5EF4-FFF2-40B4-BE49-F238E27FC236}">
-                <a16:creationId xmlns:a16="http://schemas.microsoft.com/office/drawing/2014/main" id="{2452E9A8-CE76-4CF7-929C-461C7D46DDED}"/>
+                <a16:creationId xmlns:a16="http://schemas.microsoft.com/office/drawing/2014/main" id="{2EDBB9DD-87A0-490E-B89E-EDCBF54AD9D0}"/>
               </a:ext>
             </a:extLst>
           </p:cNvPr>
@@ -12506,7 +12627,7 @@
           <p:cNvPr id="11" name="">
             <a:extLst xmlns:a="http://schemas.openxmlformats.org/drawingml/2006/main">
               <a:ext uri="{FF2B5EF4-FFF2-40B4-BE49-F238E27FC236}">
-                <a16:creationId xmlns:a16="http://schemas.microsoft.com/office/drawing/2014/main" id="{F39DA233-701B-4B49-8689-0C4BEF26FA84}"/>
+                <a16:creationId xmlns:a16="http://schemas.microsoft.com/office/drawing/2014/main" id="{99A36F5D-C23E-4E8C-A917-3D5A2AB866BF}"/>
               </a:ext>
             </a:extLst>
           </p:cNvPr>
@@ -12541,7 +12662,7 @@
           <p:cNvPr id="12" name="">
             <a:extLst xmlns:a="http://schemas.openxmlformats.org/drawingml/2006/main">
               <a:ext uri="{FF2B5EF4-FFF2-40B4-BE49-F238E27FC236}">
-                <a16:creationId xmlns:a16="http://schemas.microsoft.com/office/drawing/2014/main" id="{57E16725-A65B-41B2-AB29-2C74A0264EDA}"/>
+                <a16:creationId xmlns:a16="http://schemas.microsoft.com/office/drawing/2014/main" id="{37953E53-4BC2-427E-A4CA-19FF6A0136A0}"/>
               </a:ext>
             </a:extLst>
           </p:cNvPr>
@@ -12662,7 +12783,7 @@
           <p:cNvPr id="13" name="">
             <a:extLst xmlns:a="http://schemas.openxmlformats.org/drawingml/2006/main">
               <a:ext uri="{FF2B5EF4-FFF2-40B4-BE49-F238E27FC236}">
-                <a16:creationId xmlns:a16="http://schemas.microsoft.com/office/drawing/2014/main" id="{B65839A5-91C0-44BD-82B3-1E982BE2C030}"/>
+                <a16:creationId xmlns:a16="http://schemas.microsoft.com/office/drawing/2014/main" id="{B00EB397-AB9A-4611-A7B8-D552A4AB6076}"/>
               </a:ext>
             </a:extLst>
           </p:cNvPr>
@@ -12805,7 +12926,7 @@
           <p:cNvPr id="14" name="">
             <a:extLst xmlns:a="http://schemas.openxmlformats.org/drawingml/2006/main">
               <a:ext uri="{FF2B5EF4-FFF2-40B4-BE49-F238E27FC236}">
-                <a16:creationId xmlns:a16="http://schemas.microsoft.com/office/drawing/2014/main" id="{47ED9F25-661D-4F75-BC1F-8901BB0E8BCD}"/>
+                <a16:creationId xmlns:a16="http://schemas.microsoft.com/office/drawing/2014/main" id="{E18E338E-847C-40E5-AC68-A8A1414C9DE4}"/>
               </a:ext>
             </a:extLst>
           </p:cNvPr>
@@ -12926,7 +13047,7 @@
           <p:cNvPr id="15" name="">
             <a:extLst xmlns:a="http://schemas.openxmlformats.org/drawingml/2006/main">
               <a:ext uri="{FF2B5EF4-FFF2-40B4-BE49-F238E27FC236}">
-                <a16:creationId xmlns:a16="http://schemas.microsoft.com/office/drawing/2014/main" id="{7AE41EF7-07D6-4BDA-B949-14190D733068}"/>
+                <a16:creationId xmlns:a16="http://schemas.microsoft.com/office/drawing/2014/main" id="{161CB893-B1C5-4970-9552-B591E52E6BC0}"/>
               </a:ext>
             </a:extLst>
           </p:cNvPr>
@@ -13045,7 +13166,7 @@
     </p:spTree>
     <p:extLst>
       <p:ext uri="{BB962C8B-B14F-4D97-AF65-F5344CB8AC3E}">
-        <p14:creationId xmlns:p14="http://schemas.microsoft.com/office/powerpoint/2010/main" val="2127464131"/>
+        <p14:creationId xmlns:p14="http://schemas.microsoft.com/office/powerpoint/2010/main" val="2072209402"/>
       </p:ext>
     </p:extLst>
   </p:cSld>
@@ -13076,7 +13197,7 @@
           <p:cNvPr id="14" name="">
             <a:extLst xmlns:a="http://schemas.openxmlformats.org/drawingml/2006/main">
               <a:ext uri="{FF2B5EF4-FFF2-40B4-BE49-F238E27FC236}">
-                <a16:creationId xmlns:a16="http://schemas.microsoft.com/office/drawing/2014/main" id="{09E26D1D-DA2E-41E5-A845-70DC987F2D4C}"/>
+                <a16:creationId xmlns:a16="http://schemas.microsoft.com/office/drawing/2014/main" id="{CA02A906-A2FF-4A84-A808-295FD6506D94}"/>
               </a:ext>
             </a:extLst>
           </p:cNvPr>
@@ -13197,7 +13318,7 @@
           <p:cNvPr id="2" name="">
             <a:extLst xmlns:a="http://schemas.openxmlformats.org/drawingml/2006/main">
               <a:ext uri="{FF2B5EF4-FFF2-40B4-BE49-F238E27FC236}">
-                <a16:creationId xmlns:a16="http://schemas.microsoft.com/office/drawing/2014/main" id="{C7B2CCCA-318D-41D9-AB67-3D11C30CED31}"/>
+                <a16:creationId xmlns:a16="http://schemas.microsoft.com/office/drawing/2014/main" id="{69934D36-0A30-43AB-ADB9-1AC7AD671F73}"/>
               </a:ext>
             </a:extLst>
           </p:cNvPr>
@@ -13318,7 +13439,7 @@
           <p:cNvPr id="3" name="">
             <a:extLst xmlns:a="http://schemas.openxmlformats.org/drawingml/2006/main">
               <a:ext uri="{FF2B5EF4-FFF2-40B4-BE49-F238E27FC236}">
-                <a16:creationId xmlns:a16="http://schemas.microsoft.com/office/drawing/2014/main" id="{0AF0BE2E-7C42-4B18-AB8B-A2A420480A26}"/>
+                <a16:creationId xmlns:a16="http://schemas.microsoft.com/office/drawing/2014/main" id="{E1FB6698-213C-4EE3-93CA-6416CABC7A04}"/>
               </a:ext>
             </a:extLst>
           </p:cNvPr>
@@ -13439,7 +13560,7 @@
           <p:cNvPr id="4" name="">
             <a:extLst xmlns:a="http://schemas.openxmlformats.org/drawingml/2006/main">
               <a:ext uri="{FF2B5EF4-FFF2-40B4-BE49-F238E27FC236}">
-                <a16:creationId xmlns:a16="http://schemas.microsoft.com/office/drawing/2014/main" id="{95E23465-59C0-4F84-81C5-97BACD71AB34}"/>
+                <a16:creationId xmlns:a16="http://schemas.microsoft.com/office/drawing/2014/main" id="{CE43EF44-8EE9-4636-B74F-13BA35680492}"/>
               </a:ext>
             </a:extLst>
           </p:cNvPr>
@@ -13560,7 +13681,7 @@
           <p:cNvPr id="5" name="">
             <a:extLst xmlns:a="http://schemas.openxmlformats.org/drawingml/2006/main">
               <a:ext uri="{FF2B5EF4-FFF2-40B4-BE49-F238E27FC236}">
-                <a16:creationId xmlns:a16="http://schemas.microsoft.com/office/drawing/2014/main" id="{4C674A09-2396-4ABD-A653-730BFE9F6B27}"/>
+                <a16:creationId xmlns:a16="http://schemas.microsoft.com/office/drawing/2014/main" id="{8466F08B-9FE0-4B37-99DC-1A4A060FE9E3}"/>
               </a:ext>
             </a:extLst>
           </p:cNvPr>
@@ -13681,7 +13802,7 @@
           <p:cNvPr id="6" name="">
             <a:extLst xmlns:a="http://schemas.openxmlformats.org/drawingml/2006/main">
               <a:ext uri="{FF2B5EF4-FFF2-40B4-BE49-F238E27FC236}">
-                <a16:creationId xmlns:a16="http://schemas.microsoft.com/office/drawing/2014/main" id="{887727B7-FA6E-4B39-AB05-8E70829E3557}"/>
+                <a16:creationId xmlns:a16="http://schemas.microsoft.com/office/drawing/2014/main" id="{2C2BD4A9-7E9F-4FF7-8BD5-4A1D9E138600}"/>
               </a:ext>
             </a:extLst>
           </p:cNvPr>
@@ -13802,7 +13923,7 @@
           <p:cNvPr id="7" name="">
             <a:extLst xmlns:a="http://schemas.openxmlformats.org/drawingml/2006/main">
               <a:ext uri="{FF2B5EF4-FFF2-40B4-BE49-F238E27FC236}">
-                <a16:creationId xmlns:a16="http://schemas.microsoft.com/office/drawing/2014/main" id="{55DE33F9-D99E-4E45-9F9D-0E3D4D73F830}"/>
+                <a16:creationId xmlns:a16="http://schemas.microsoft.com/office/drawing/2014/main" id="{CBEEE23F-8FF9-41F0-85FB-DD77C69B9170}"/>
               </a:ext>
             </a:extLst>
           </p:cNvPr>
@@ -13923,7 +14044,7 @@
           <p:cNvPr id="8" name="">
             <a:extLst xmlns:a="http://schemas.openxmlformats.org/drawingml/2006/main">
               <a:ext uri="{FF2B5EF4-FFF2-40B4-BE49-F238E27FC236}">
-                <a16:creationId xmlns:a16="http://schemas.microsoft.com/office/drawing/2014/main" id="{7ACC3CB8-0294-4CAA-9B44-6F65AA47E472}"/>
+                <a16:creationId xmlns:a16="http://schemas.microsoft.com/office/drawing/2014/main" id="{9BF575B6-1CE8-48A1-8380-C73BFBD884AC}"/>
               </a:ext>
             </a:extLst>
           </p:cNvPr>
@@ -14044,7 +14165,7 @@
           <p:cNvPr id="9" name="">
             <a:extLst xmlns:a="http://schemas.openxmlformats.org/drawingml/2006/main">
               <a:ext uri="{FF2B5EF4-FFF2-40B4-BE49-F238E27FC236}">
-                <a16:creationId xmlns:a16="http://schemas.microsoft.com/office/drawing/2014/main" id="{CEE3904D-3276-4CCC-A84B-28C19DB849A2}"/>
+                <a16:creationId xmlns:a16="http://schemas.microsoft.com/office/drawing/2014/main" id="{13FC5701-CA3D-4CD4-808A-62BE5333B6FB}"/>
               </a:ext>
             </a:extLst>
           </p:cNvPr>
@@ -14165,7 +14286,7 @@
           <p:cNvPr id="10" name="">
             <a:extLst xmlns:a="http://schemas.openxmlformats.org/drawingml/2006/main">
               <a:ext uri="{FF2B5EF4-FFF2-40B4-BE49-F238E27FC236}">
-                <a16:creationId xmlns:a16="http://schemas.microsoft.com/office/drawing/2014/main" id="{4A411ED4-22C7-4445-B792-520A976CACF4}"/>
+                <a16:creationId xmlns:a16="http://schemas.microsoft.com/office/drawing/2014/main" id="{F42D41DF-2EA2-4063-9D65-1644E4E23D7F}"/>
               </a:ext>
             </a:extLst>
           </p:cNvPr>
@@ -14286,7 +14407,7 @@
           <p:cNvPr id="11" name="">
             <a:extLst xmlns:a="http://schemas.openxmlformats.org/drawingml/2006/main">
               <a:ext uri="{FF2B5EF4-FFF2-40B4-BE49-F238E27FC236}">
-                <a16:creationId xmlns:a16="http://schemas.microsoft.com/office/drawing/2014/main" id="{135E6127-E390-48EB-888A-6AB2B0DD9093}"/>
+                <a16:creationId xmlns:a16="http://schemas.microsoft.com/office/drawing/2014/main" id="{2226035F-9280-4121-BB60-86D2FBEBFA82}"/>
               </a:ext>
             </a:extLst>
           </p:cNvPr>
@@ -14407,7 +14528,7 @@
           <p:cNvPr id="12" name="">
             <a:extLst xmlns:a="http://schemas.openxmlformats.org/drawingml/2006/main">
               <a:ext uri="{FF2B5EF4-FFF2-40B4-BE49-F238E27FC236}">
-                <a16:creationId xmlns:a16="http://schemas.microsoft.com/office/drawing/2014/main" id="{5058F24E-07F4-46BA-AA19-A3133973D2FC}"/>
+                <a16:creationId xmlns:a16="http://schemas.microsoft.com/office/drawing/2014/main" id="{4CA0F2B9-2793-4968-A07E-770D18EC47B9}"/>
               </a:ext>
             </a:extLst>
           </p:cNvPr>
@@ -14528,7 +14649,7 @@
           <p:cNvPr id="13" name="">
             <a:extLst xmlns:a="http://schemas.openxmlformats.org/drawingml/2006/main">
               <a:ext uri="{FF2B5EF4-FFF2-40B4-BE49-F238E27FC236}">
-                <a16:creationId xmlns:a16="http://schemas.microsoft.com/office/drawing/2014/main" id="{646409BF-95D6-4F78-A74D-0860B8096B64}"/>
+                <a16:creationId xmlns:a16="http://schemas.microsoft.com/office/drawing/2014/main" id="{5BDC56F5-8A29-49B0-9F8B-86E95A721588}"/>
               </a:ext>
             </a:extLst>
           </p:cNvPr>
@@ -14647,7 +14768,7 @@
     </p:spTree>
     <p:extLst>
       <p:ext uri="{BB962C8B-B14F-4D97-AF65-F5344CB8AC3E}">
-        <p14:creationId xmlns:p14="http://schemas.microsoft.com/office/powerpoint/2010/main" val="584113880"/>
+        <p14:creationId xmlns:p14="http://schemas.microsoft.com/office/powerpoint/2010/main" val="569380540"/>
       </p:ext>
     </p:extLst>
   </p:cSld>
@@ -14678,7 +14799,7 @@
           <p:cNvPr id="16" name="">
             <a:extLst xmlns:a="http://schemas.openxmlformats.org/drawingml/2006/main">
               <a:ext uri="{FF2B5EF4-FFF2-40B4-BE49-F238E27FC236}">
-                <a16:creationId xmlns:a16="http://schemas.microsoft.com/office/drawing/2014/main" id="{AF5B5F18-822B-49C0-BAC6-41CF97E7B249}"/>
+                <a16:creationId xmlns:a16="http://schemas.microsoft.com/office/drawing/2014/main" id="{B13D3A45-B3CB-403D-9DAB-21F0C3689B2E}"/>
               </a:ext>
             </a:extLst>
           </p:cNvPr>
@@ -14799,7 +14920,7 @@
           <p:cNvPr id="2" name="">
             <a:extLst xmlns:a="http://schemas.openxmlformats.org/drawingml/2006/main">
               <a:ext uri="{FF2B5EF4-FFF2-40B4-BE49-F238E27FC236}">
-                <a16:creationId xmlns:a16="http://schemas.microsoft.com/office/drawing/2014/main" id="{39B0FB0F-A551-41A0-9968-1CFA1A5C312A}"/>
+                <a16:creationId xmlns:a16="http://schemas.microsoft.com/office/drawing/2014/main" id="{9CCCE801-9368-477E-BF2C-80EB98D48BA6}"/>
               </a:ext>
             </a:extLst>
           </p:cNvPr>
@@ -14920,7 +15041,7 @@
           <p:cNvPr id="3" name="">
             <a:extLst xmlns:a="http://schemas.openxmlformats.org/drawingml/2006/main">
               <a:ext uri="{FF2B5EF4-FFF2-40B4-BE49-F238E27FC236}">
-                <a16:creationId xmlns:a16="http://schemas.microsoft.com/office/drawing/2014/main" id="{A64960B1-F9D1-4E0F-9241-914355F00F16}"/>
+                <a16:creationId xmlns:a16="http://schemas.microsoft.com/office/drawing/2014/main" id="{DB2962F0-4BE2-4937-A5E1-A8412B972EDF}"/>
               </a:ext>
             </a:extLst>
           </p:cNvPr>
@@ -15041,7 +15162,7 @@
           <p:cNvPr id="4" name="">
             <a:extLst xmlns:a="http://schemas.openxmlformats.org/drawingml/2006/main">
               <a:ext uri="{FF2B5EF4-FFF2-40B4-BE49-F238E27FC236}">
-                <a16:creationId xmlns:a16="http://schemas.microsoft.com/office/drawing/2014/main" id="{67A1F2F4-E14D-4472-BA2A-49D1414DAC2A}"/>
+                <a16:creationId xmlns:a16="http://schemas.microsoft.com/office/drawing/2014/main" id="{301B2EEA-95A5-4A5F-A0B8-3E36F99DEB24}"/>
               </a:ext>
             </a:extLst>
           </p:cNvPr>
@@ -15162,7 +15283,7 @@
           <p:cNvPr id="5" name="">
             <a:extLst xmlns:a="http://schemas.openxmlformats.org/drawingml/2006/main">
               <a:ext uri="{FF2B5EF4-FFF2-40B4-BE49-F238E27FC236}">
-                <a16:creationId xmlns:a16="http://schemas.microsoft.com/office/drawing/2014/main" id="{673B99AD-CF0A-4FA0-B261-3C09468221E1}"/>
+                <a16:creationId xmlns:a16="http://schemas.microsoft.com/office/drawing/2014/main" id="{93920A6C-8F14-4BF6-9834-293F95C0645F}"/>
               </a:ext>
             </a:extLst>
           </p:cNvPr>
@@ -15283,7 +15404,7 @@
           <p:cNvPr id="6" name="">
             <a:extLst xmlns:a="http://schemas.openxmlformats.org/drawingml/2006/main">
               <a:ext uri="{FF2B5EF4-FFF2-40B4-BE49-F238E27FC236}">
-                <a16:creationId xmlns:a16="http://schemas.microsoft.com/office/drawing/2014/main" id="{0BE2F5A8-21E7-4E2F-B69F-CA51699337B4}"/>
+                <a16:creationId xmlns:a16="http://schemas.microsoft.com/office/drawing/2014/main" id="{252CF227-F175-454A-9C7E-B5C61B9A68AF}"/>
               </a:ext>
             </a:extLst>
           </p:cNvPr>
@@ -15404,7 +15525,7 @@
           <p:cNvPr id="7" name="">
             <a:extLst xmlns:a="http://schemas.openxmlformats.org/drawingml/2006/main">
               <a:ext uri="{FF2B5EF4-FFF2-40B4-BE49-F238E27FC236}">
-                <a16:creationId xmlns:a16="http://schemas.microsoft.com/office/drawing/2014/main" id="{310B618C-4405-4757-8FD4-2BEB58D759F3}"/>
+                <a16:creationId xmlns:a16="http://schemas.microsoft.com/office/drawing/2014/main" id="{4A109437-D172-4441-8DF4-6626462BFFE3}"/>
               </a:ext>
             </a:extLst>
           </p:cNvPr>
@@ -15525,7 +15646,7 @@
           <p:cNvPr id="8" name="">
             <a:extLst xmlns:a="http://schemas.openxmlformats.org/drawingml/2006/main">
               <a:ext uri="{FF2B5EF4-FFF2-40B4-BE49-F238E27FC236}">
-                <a16:creationId xmlns:a16="http://schemas.microsoft.com/office/drawing/2014/main" id="{3463E3BF-A148-4576-8C5A-926147CF86C7}"/>
+                <a16:creationId xmlns:a16="http://schemas.microsoft.com/office/drawing/2014/main" id="{46350C55-EA41-4783-AEA0-4F2243B68EED}"/>
               </a:ext>
             </a:extLst>
           </p:cNvPr>
@@ -15646,7 +15767,7 @@
           <p:cNvPr id="9" name="">
             <a:extLst xmlns:a="http://schemas.openxmlformats.org/drawingml/2006/main">
               <a:ext uri="{FF2B5EF4-FFF2-40B4-BE49-F238E27FC236}">
-                <a16:creationId xmlns:a16="http://schemas.microsoft.com/office/drawing/2014/main" id="{CDD2C8F1-4419-4689-8C3C-6A6D992E3D89}"/>
+                <a16:creationId xmlns:a16="http://schemas.microsoft.com/office/drawing/2014/main" id="{6F57BBE4-03D4-4100-A3AE-AD1D1A4C23F4}"/>
               </a:ext>
             </a:extLst>
           </p:cNvPr>
@@ -15767,7 +15888,7 @@
           <p:cNvPr id="10" name="">
             <a:extLst xmlns:a="http://schemas.openxmlformats.org/drawingml/2006/main">
               <a:ext uri="{FF2B5EF4-FFF2-40B4-BE49-F238E27FC236}">
-                <a16:creationId xmlns:a16="http://schemas.microsoft.com/office/drawing/2014/main" id="{C3F71A3F-DD05-40FE-910B-44D3C2561DBE}"/>
+                <a16:creationId xmlns:a16="http://schemas.microsoft.com/office/drawing/2014/main" id="{F54BF383-4351-4DF0-A6CE-4AA1C5E325DE}"/>
               </a:ext>
             </a:extLst>
           </p:cNvPr>
@@ -15888,7 +16009,7 @@
           <p:cNvPr id="11" name="">
             <a:extLst xmlns:a="http://schemas.openxmlformats.org/drawingml/2006/main">
               <a:ext uri="{FF2B5EF4-FFF2-40B4-BE49-F238E27FC236}">
-                <a16:creationId xmlns:a16="http://schemas.microsoft.com/office/drawing/2014/main" id="{836288A3-984C-4C5B-87E1-BB8B7C54AA8B}"/>
+                <a16:creationId xmlns:a16="http://schemas.microsoft.com/office/drawing/2014/main" id="{4C820339-E6D6-43BD-A7C1-A97C92ECD9A4}"/>
               </a:ext>
             </a:extLst>
           </p:cNvPr>
@@ -16009,7 +16130,7 @@
           <p:cNvPr id="12" name="">
             <a:extLst xmlns:a="http://schemas.openxmlformats.org/drawingml/2006/main">
               <a:ext uri="{FF2B5EF4-FFF2-40B4-BE49-F238E27FC236}">
-                <a16:creationId xmlns:a16="http://schemas.microsoft.com/office/drawing/2014/main" id="{7E8C3FD7-E74B-4CCB-A30D-EB96B0DF75DF}"/>
+                <a16:creationId xmlns:a16="http://schemas.microsoft.com/office/drawing/2014/main" id="{9F0714D9-D27D-4D59-9FC5-32ED430B252C}"/>
               </a:ext>
             </a:extLst>
           </p:cNvPr>
@@ -16130,7 +16251,7 @@
           <p:cNvPr id="13" name="">
             <a:extLst xmlns:a="http://schemas.openxmlformats.org/drawingml/2006/main">
               <a:ext uri="{FF2B5EF4-FFF2-40B4-BE49-F238E27FC236}">
-                <a16:creationId xmlns:a16="http://schemas.microsoft.com/office/drawing/2014/main" id="{4C1E599C-6149-460C-B941-B8B6EBD456D0}"/>
+                <a16:creationId xmlns:a16="http://schemas.microsoft.com/office/drawing/2014/main" id="{15C59914-A88B-43CC-841F-C7063602CA18}"/>
               </a:ext>
             </a:extLst>
           </p:cNvPr>
@@ -16251,7 +16372,7 @@
           <p:cNvPr id="14" name="">
             <a:extLst xmlns:a="http://schemas.openxmlformats.org/drawingml/2006/main">
               <a:ext uri="{FF2B5EF4-FFF2-40B4-BE49-F238E27FC236}">
-                <a16:creationId xmlns:a16="http://schemas.microsoft.com/office/drawing/2014/main" id="{41AD8D2C-6C8F-4323-86C2-CBF66FCF675E}"/>
+                <a16:creationId xmlns:a16="http://schemas.microsoft.com/office/drawing/2014/main" id="{0F9E005B-3565-4CC5-95A7-538472958B43}"/>
               </a:ext>
             </a:extLst>
           </p:cNvPr>
@@ -16372,7 +16493,7 @@
           <p:cNvPr id="15" name="">
             <a:extLst xmlns:a="http://schemas.openxmlformats.org/drawingml/2006/main">
               <a:ext uri="{FF2B5EF4-FFF2-40B4-BE49-F238E27FC236}">
-                <a16:creationId xmlns:a16="http://schemas.microsoft.com/office/drawing/2014/main" id="{26D567A7-D204-4B56-9BCD-EE15271F8AA5}"/>
+                <a16:creationId xmlns:a16="http://schemas.microsoft.com/office/drawing/2014/main" id="{53489DD4-38F6-4691-A592-81168942BED8}"/>
               </a:ext>
             </a:extLst>
           </p:cNvPr>
@@ -16491,7 +16612,7 @@
     </p:spTree>
     <p:extLst>
       <p:ext uri="{BB962C8B-B14F-4D97-AF65-F5344CB8AC3E}">
-        <p14:creationId xmlns:p14="http://schemas.microsoft.com/office/powerpoint/2010/main" val="1288875612"/>
+        <p14:creationId xmlns:p14="http://schemas.microsoft.com/office/powerpoint/2010/main" val="1647706343"/>
       </p:ext>
     </p:extLst>
   </p:cSld>
@@ -16522,7 +16643,7 @@
           <p:cNvPr id="9" name="">
             <a:extLst xmlns:a="http://schemas.openxmlformats.org/drawingml/2006/main">
               <a:ext uri="{FF2B5EF4-FFF2-40B4-BE49-F238E27FC236}">
-                <a16:creationId xmlns:a16="http://schemas.microsoft.com/office/drawing/2014/main" id="{8396A5FE-E486-42D0-BBD5-69CD30362239}"/>
+                <a16:creationId xmlns:a16="http://schemas.microsoft.com/office/drawing/2014/main" id="{464C9BFC-728B-4C51-9097-6D4F49368F6C}"/>
               </a:ext>
             </a:extLst>
           </p:cNvPr>
@@ -16643,7 +16764,7 @@
           <p:cNvPr id="2" name="">
             <a:extLst xmlns:a="http://schemas.openxmlformats.org/drawingml/2006/main">
               <a:ext uri="{FF2B5EF4-FFF2-40B4-BE49-F238E27FC236}">
-                <a16:creationId xmlns:a16="http://schemas.microsoft.com/office/drawing/2014/main" id="{3D5CC06C-7F3A-4473-9957-4976F7AB016B}"/>
+                <a16:creationId xmlns:a16="http://schemas.microsoft.com/office/drawing/2014/main" id="{5740EB5F-EC4E-4806-A3C1-2C5D35CF77F8}"/>
               </a:ext>
             </a:extLst>
           </p:cNvPr>
@@ -16764,7 +16885,7 @@
           <p:cNvPr id="3" name="">
             <a:extLst xmlns:a="http://schemas.openxmlformats.org/drawingml/2006/main">
               <a:ext uri="{FF2B5EF4-FFF2-40B4-BE49-F238E27FC236}">
-                <a16:creationId xmlns:a16="http://schemas.microsoft.com/office/drawing/2014/main" id="{AEAD7A45-BAE6-44E3-9EED-EE3CEC1B0A45}"/>
+                <a16:creationId xmlns:a16="http://schemas.microsoft.com/office/drawing/2014/main" id="{BBAA9E40-2E81-4C84-84BE-4DE8D3E161D9}"/>
               </a:ext>
             </a:extLst>
           </p:cNvPr>
@@ -16797,7 +16918,7 @@
           <p:cNvPr id="4" name="">
             <a:extLst xmlns:a="http://schemas.openxmlformats.org/drawingml/2006/main">
               <a:ext uri="{FF2B5EF4-FFF2-40B4-BE49-F238E27FC236}">
-                <a16:creationId xmlns:a16="http://schemas.microsoft.com/office/drawing/2014/main" id="{A4E55734-DC6E-4AB5-9BB5-C70A6BC5A270}"/>
+                <a16:creationId xmlns:a16="http://schemas.microsoft.com/office/drawing/2014/main" id="{76959723-2A95-4B9E-A92B-C59BC01B78F6}"/>
               </a:ext>
             </a:extLst>
           </p:cNvPr>
@@ -16969,7 +17090,7 @@
           <p:cNvPr id="5" name="">
             <a:extLst xmlns:a="http://schemas.openxmlformats.org/drawingml/2006/main">
               <a:ext uri="{FF2B5EF4-FFF2-40B4-BE49-F238E27FC236}">
-                <a16:creationId xmlns:a16="http://schemas.microsoft.com/office/drawing/2014/main" id="{767054F7-190E-4D12-8D01-F6148B83A1F1}"/>
+                <a16:creationId xmlns:a16="http://schemas.microsoft.com/office/drawing/2014/main" id="{73EF2EE9-4CAA-4381-A0C3-8337C2101F69}"/>
               </a:ext>
             </a:extLst>
           </p:cNvPr>
@@ -17090,7 +17211,7 @@
           <p:cNvPr id="6" name="">
             <a:extLst xmlns:a="http://schemas.openxmlformats.org/drawingml/2006/main">
               <a:ext uri="{FF2B5EF4-FFF2-40B4-BE49-F238E27FC236}">
-                <a16:creationId xmlns:a16="http://schemas.microsoft.com/office/drawing/2014/main" id="{64DEDD67-FD47-4A6D-9BF9-C9564824024B}"/>
+                <a16:creationId xmlns:a16="http://schemas.microsoft.com/office/drawing/2014/main" id="{836FF22A-4A1A-4AD4-ACEC-57DBEAFC54F2}"/>
               </a:ext>
             </a:extLst>
           </p:cNvPr>
@@ -17211,7 +17332,7 @@
           <p:cNvPr id="7" name="">
             <a:extLst xmlns:a="http://schemas.openxmlformats.org/drawingml/2006/main">
               <a:ext uri="{FF2B5EF4-FFF2-40B4-BE49-F238E27FC236}">
-                <a16:creationId xmlns:a16="http://schemas.microsoft.com/office/drawing/2014/main" id="{C9EF5E5B-C1B5-4C20-A560-EBBD050CB88C}"/>
+                <a16:creationId xmlns:a16="http://schemas.microsoft.com/office/drawing/2014/main" id="{41E4D9D4-0951-4D8C-A3D6-765ED3A2E0EA}"/>
               </a:ext>
             </a:extLst>
           </p:cNvPr>
@@ -17332,7 +17453,7 @@
           <p:cNvPr id="8" name="">
             <a:extLst xmlns:a="http://schemas.openxmlformats.org/drawingml/2006/main">
               <a:ext uri="{FF2B5EF4-FFF2-40B4-BE49-F238E27FC236}">
-                <a16:creationId xmlns:a16="http://schemas.microsoft.com/office/drawing/2014/main" id="{130D466F-DBB4-45A9-B31D-F8C43BF067C4}"/>
+                <a16:creationId xmlns:a16="http://schemas.microsoft.com/office/drawing/2014/main" id="{E216F884-A1A8-4679-A1C5-1B3B7298FF99}"/>
               </a:ext>
             </a:extLst>
           </p:cNvPr>
@@ -17451,7 +17572,7 @@
     </p:spTree>
     <p:extLst>
       <p:ext uri="{BB962C8B-B14F-4D97-AF65-F5344CB8AC3E}">
-        <p14:creationId xmlns:p14="http://schemas.microsoft.com/office/powerpoint/2010/main" val="778283172"/>
+        <p14:creationId xmlns:p14="http://schemas.microsoft.com/office/powerpoint/2010/main" val="1943843533"/>
       </p:ext>
     </p:extLst>
   </p:cSld>
@@ -17482,7 +17603,7 @@
           <p:cNvPr id="12" name="">
             <a:extLst xmlns:a="http://schemas.openxmlformats.org/drawingml/2006/main">
               <a:ext uri="{FF2B5EF4-FFF2-40B4-BE49-F238E27FC236}">
-                <a16:creationId xmlns:a16="http://schemas.microsoft.com/office/drawing/2014/main" id="{521D414C-C6EF-49B4-B426-0261B7925D84}"/>
+                <a16:creationId xmlns:a16="http://schemas.microsoft.com/office/drawing/2014/main" id="{A4CDBF5D-707C-4C73-B2D5-087717F56CB8}"/>
               </a:ext>
             </a:extLst>
           </p:cNvPr>
@@ -17603,7 +17724,7 @@
           <p:cNvPr id="2" name="">
             <a:extLst xmlns:a="http://schemas.openxmlformats.org/drawingml/2006/main">
               <a:ext uri="{FF2B5EF4-FFF2-40B4-BE49-F238E27FC236}">
-                <a16:creationId xmlns:a16="http://schemas.microsoft.com/office/drawing/2014/main" id="{8CF574C0-CA3F-4A0F-95E2-281AE85CDA8B}"/>
+                <a16:creationId xmlns:a16="http://schemas.microsoft.com/office/drawing/2014/main" id="{5ED85E24-D870-4020-BD7B-F45DA7811F5A}"/>
               </a:ext>
             </a:extLst>
           </p:cNvPr>
@@ -17724,7 +17845,7 @@
           <p:cNvPr id="3" name="">
             <a:extLst xmlns:a="http://schemas.openxmlformats.org/drawingml/2006/main">
               <a:ext uri="{FF2B5EF4-FFF2-40B4-BE49-F238E27FC236}">
-                <a16:creationId xmlns:a16="http://schemas.microsoft.com/office/drawing/2014/main" id="{7E4D3F02-64A1-4D03-A7F9-4584160C9917}"/>
+                <a16:creationId xmlns:a16="http://schemas.microsoft.com/office/drawing/2014/main" id="{885DC4ED-2EDE-4BB6-A1FF-6EBB4EE9EBFF}"/>
               </a:ext>
             </a:extLst>
           </p:cNvPr>
@@ -17757,7 +17878,7 @@
           <p:cNvPr id="4" name="">
             <a:extLst xmlns:a="http://schemas.openxmlformats.org/drawingml/2006/main">
               <a:ext uri="{FF2B5EF4-FFF2-40B4-BE49-F238E27FC236}">
-                <a16:creationId xmlns:a16="http://schemas.microsoft.com/office/drawing/2014/main" id="{C764ED3F-D6D1-40A0-8A9E-180E246BDBA1}"/>
+                <a16:creationId xmlns:a16="http://schemas.microsoft.com/office/drawing/2014/main" id="{D0F3B040-FF7E-49CF-81A4-4E120504A42D}"/>
               </a:ext>
             </a:extLst>
           </p:cNvPr>
@@ -17946,7 +18067,7 @@
           <p:cNvPr id="5" name="">
             <a:extLst xmlns:a="http://schemas.openxmlformats.org/drawingml/2006/main">
               <a:ext uri="{FF2B5EF4-FFF2-40B4-BE49-F238E27FC236}">
-                <a16:creationId xmlns:a16="http://schemas.microsoft.com/office/drawing/2014/main" id="{FB00219F-B559-42B8-ADAA-59D7BB222BC1}"/>
+                <a16:creationId xmlns:a16="http://schemas.microsoft.com/office/drawing/2014/main" id="{60342447-9D06-4472-B155-2DA7C967FD0B}"/>
               </a:ext>
             </a:extLst>
           </p:cNvPr>
@@ -17979,7 +18100,7 @@
           <p:cNvPr id="6" name="">
             <a:extLst xmlns:a="http://schemas.openxmlformats.org/drawingml/2006/main">
               <a:ext uri="{FF2B5EF4-FFF2-40B4-BE49-F238E27FC236}">
-                <a16:creationId xmlns:a16="http://schemas.microsoft.com/office/drawing/2014/main" id="{1B8222D9-F43D-4887-A451-14BB153A6908}"/>
+                <a16:creationId xmlns:a16="http://schemas.microsoft.com/office/drawing/2014/main" id="{3C95F1E6-9F8C-4B8A-8720-5A7E92BA0556}"/>
               </a:ext>
             </a:extLst>
           </p:cNvPr>
@@ -18151,7 +18272,7 @@
           <p:cNvPr id="7" name="">
             <a:extLst xmlns:a="http://schemas.openxmlformats.org/drawingml/2006/main">
               <a:ext uri="{FF2B5EF4-FFF2-40B4-BE49-F238E27FC236}">
-                <a16:creationId xmlns:a16="http://schemas.microsoft.com/office/drawing/2014/main" id="{391C3260-600B-4FAD-A3CA-D4CF1A71F7A2}"/>
+                <a16:creationId xmlns:a16="http://schemas.microsoft.com/office/drawing/2014/main" id="{9D8A69DC-B243-4514-AA6F-63D90EA668C6}"/>
               </a:ext>
             </a:extLst>
           </p:cNvPr>
@@ -18272,7 +18393,7 @@
           <p:cNvPr id="8" name="">
             <a:extLst xmlns:a="http://schemas.openxmlformats.org/drawingml/2006/main">
               <a:ext uri="{FF2B5EF4-FFF2-40B4-BE49-F238E27FC236}">
-                <a16:creationId xmlns:a16="http://schemas.microsoft.com/office/drawing/2014/main" id="{D0E20F49-A20C-459C-A2FD-FE2B871A6593}"/>
+                <a16:creationId xmlns:a16="http://schemas.microsoft.com/office/drawing/2014/main" id="{7B97C76C-134D-4107-8F7E-97D7909B2100}"/>
               </a:ext>
             </a:extLst>
           </p:cNvPr>
@@ -18393,7 +18514,7 @@
           <p:cNvPr id="9" name="">
             <a:extLst xmlns:a="http://schemas.openxmlformats.org/drawingml/2006/main">
               <a:ext uri="{FF2B5EF4-FFF2-40B4-BE49-F238E27FC236}">
-                <a16:creationId xmlns:a16="http://schemas.microsoft.com/office/drawing/2014/main" id="{42D5CE48-C586-46F7-B306-01AE3CA8DEE0}"/>
+                <a16:creationId xmlns:a16="http://schemas.microsoft.com/office/drawing/2014/main" id="{A03670FA-F58E-403A-944B-4E248130C41E}"/>
               </a:ext>
             </a:extLst>
           </p:cNvPr>
@@ -18514,7 +18635,7 @@
           <p:cNvPr id="10" name="">
             <a:extLst xmlns:a="http://schemas.openxmlformats.org/drawingml/2006/main">
               <a:ext uri="{FF2B5EF4-FFF2-40B4-BE49-F238E27FC236}">
-                <a16:creationId xmlns:a16="http://schemas.microsoft.com/office/drawing/2014/main" id="{ED71D82A-B85C-43AE-B451-5D17C3C5391A}"/>
+                <a16:creationId xmlns:a16="http://schemas.microsoft.com/office/drawing/2014/main" id="{0E5B04BB-B253-4CCB-83D4-D18D1B29E56B}"/>
               </a:ext>
             </a:extLst>
           </p:cNvPr>
@@ -18635,7 +18756,7 @@
           <p:cNvPr id="11" name="">
             <a:extLst xmlns:a="http://schemas.openxmlformats.org/drawingml/2006/main">
               <a:ext uri="{FF2B5EF4-FFF2-40B4-BE49-F238E27FC236}">
-                <a16:creationId xmlns:a16="http://schemas.microsoft.com/office/drawing/2014/main" id="{43EB312C-4E5B-40F4-BE14-6AD2682E3670}"/>
+                <a16:creationId xmlns:a16="http://schemas.microsoft.com/office/drawing/2014/main" id="{5923B446-C1C5-4A55-BD0A-A0C67E4C7C42}"/>
               </a:ext>
             </a:extLst>
           </p:cNvPr>
@@ -18754,7 +18875,7 @@
     </p:spTree>
     <p:extLst>
       <p:ext uri="{BB962C8B-B14F-4D97-AF65-F5344CB8AC3E}">
-        <p14:creationId xmlns:p14="http://schemas.microsoft.com/office/powerpoint/2010/main" val="1433832303"/>
+        <p14:creationId xmlns:p14="http://schemas.microsoft.com/office/powerpoint/2010/main" val="1228807137"/>
       </p:ext>
     </p:extLst>
   </p:cSld>
@@ -18785,7 +18906,7 @@
           <p:cNvPr id="10" name="">
             <a:extLst xmlns:a="http://schemas.openxmlformats.org/drawingml/2006/main">
               <a:ext uri="{FF2B5EF4-FFF2-40B4-BE49-F238E27FC236}">
-                <a16:creationId xmlns:a16="http://schemas.microsoft.com/office/drawing/2014/main" id="{B55AABB2-B8CA-496E-88B8-5157662ED16F}"/>
+                <a16:creationId xmlns:a16="http://schemas.microsoft.com/office/drawing/2014/main" id="{F181170E-F0E4-427A-8525-811E3F393877}"/>
               </a:ext>
             </a:extLst>
           </p:cNvPr>
@@ -18906,7 +19027,7 @@
           <p:cNvPr id="2" name="">
             <a:extLst xmlns:a="http://schemas.openxmlformats.org/drawingml/2006/main">
               <a:ext uri="{FF2B5EF4-FFF2-40B4-BE49-F238E27FC236}">
-                <a16:creationId xmlns:a16="http://schemas.microsoft.com/office/drawing/2014/main" id="{2EAB8B64-1808-4453-BFF5-2D28E278C49D}"/>
+                <a16:creationId xmlns:a16="http://schemas.microsoft.com/office/drawing/2014/main" id="{C4274F1D-7CBE-46FA-B7F3-E27E8384EDC4}"/>
               </a:ext>
             </a:extLst>
           </p:cNvPr>
@@ -19027,7 +19148,7 @@
           <p:cNvPr id="3" name="">
             <a:extLst xmlns:a="http://schemas.openxmlformats.org/drawingml/2006/main">
               <a:ext uri="{FF2B5EF4-FFF2-40B4-BE49-F238E27FC236}">
-                <a16:creationId xmlns:a16="http://schemas.microsoft.com/office/drawing/2014/main" id="{1DE9D926-FA33-4DBD-BAC3-CEC6D7E29E23}"/>
+                <a16:creationId xmlns:a16="http://schemas.microsoft.com/office/drawing/2014/main" id="{28193015-6816-4A2F-81F3-28C1379E1676}"/>
               </a:ext>
             </a:extLst>
           </p:cNvPr>
@@ -19060,7 +19181,7 @@
           <p:cNvPr id="4" name="">
             <a:extLst xmlns:a="http://schemas.openxmlformats.org/drawingml/2006/main">
               <a:ext uri="{FF2B5EF4-FFF2-40B4-BE49-F238E27FC236}">
-                <a16:creationId xmlns:a16="http://schemas.microsoft.com/office/drawing/2014/main" id="{69F1F276-ABAF-4325-9DF2-0CAE795B9615}"/>
+                <a16:creationId xmlns:a16="http://schemas.microsoft.com/office/drawing/2014/main" id="{9E9DED19-C9E1-4D74-B1F5-835FAA42A74E}"/>
               </a:ext>
             </a:extLst>
           </p:cNvPr>
@@ -19237,7 +19358,7 @@
           <p:cNvPr id="5" name="">
             <a:extLst xmlns:a="http://schemas.openxmlformats.org/drawingml/2006/main">
               <a:ext uri="{FF2B5EF4-FFF2-40B4-BE49-F238E27FC236}">
-                <a16:creationId xmlns:a16="http://schemas.microsoft.com/office/drawing/2014/main" id="{90548309-98D2-4F17-A580-1A055C206C55}"/>
+                <a16:creationId xmlns:a16="http://schemas.microsoft.com/office/drawing/2014/main" id="{0511DFBC-3323-48BF-A5BF-FD550A612C60}"/>
               </a:ext>
             </a:extLst>
           </p:cNvPr>
@@ -19358,7 +19479,7 @@
           <p:cNvPr id="6" name="">
             <a:extLst xmlns:a="http://schemas.openxmlformats.org/drawingml/2006/main">
               <a:ext uri="{FF2B5EF4-FFF2-40B4-BE49-F238E27FC236}">
-                <a16:creationId xmlns:a16="http://schemas.microsoft.com/office/drawing/2014/main" id="{3FBB5BC8-2495-4AB0-90FE-CCBAEA82910C}"/>
+                <a16:creationId xmlns:a16="http://schemas.microsoft.com/office/drawing/2014/main" id="{0619009A-53BD-42B8-8EE2-8FB8A1F1D4A0}"/>
               </a:ext>
             </a:extLst>
           </p:cNvPr>
@@ -19479,7 +19600,7 @@
           <p:cNvPr id="7" name="">
             <a:extLst xmlns:a="http://schemas.openxmlformats.org/drawingml/2006/main">
               <a:ext uri="{FF2B5EF4-FFF2-40B4-BE49-F238E27FC236}">
-                <a16:creationId xmlns:a16="http://schemas.microsoft.com/office/drawing/2014/main" id="{30495787-E2B9-4598-B15A-98E0D42CCD6A}"/>
+                <a16:creationId xmlns:a16="http://schemas.microsoft.com/office/drawing/2014/main" id="{44256E53-3761-4C9F-A6B2-54DB3A420414}"/>
               </a:ext>
             </a:extLst>
           </p:cNvPr>
@@ -19600,7 +19721,7 @@
           <p:cNvPr id="8" name="">
             <a:extLst xmlns:a="http://schemas.openxmlformats.org/drawingml/2006/main">
               <a:ext uri="{FF2B5EF4-FFF2-40B4-BE49-F238E27FC236}">
-                <a16:creationId xmlns:a16="http://schemas.microsoft.com/office/drawing/2014/main" id="{426E8F25-7CBA-4F16-8316-6384CB197E34}"/>
+                <a16:creationId xmlns:a16="http://schemas.microsoft.com/office/drawing/2014/main" id="{2717A0A8-C855-43B6-92C9-6F8C0D1FAA16}"/>
               </a:ext>
             </a:extLst>
           </p:cNvPr>
@@ -19721,7 +19842,7 @@
           <p:cNvPr id="9" name="">
             <a:extLst xmlns:a="http://schemas.openxmlformats.org/drawingml/2006/main">
               <a:ext uri="{FF2B5EF4-FFF2-40B4-BE49-F238E27FC236}">
-                <a16:creationId xmlns:a16="http://schemas.microsoft.com/office/drawing/2014/main" id="{9E32062D-9002-4C7C-AD3B-7C41BC39B207}"/>
+                <a16:creationId xmlns:a16="http://schemas.microsoft.com/office/drawing/2014/main" id="{B87C171A-20E3-4C69-A369-D2516C06DCA1}"/>
               </a:ext>
             </a:extLst>
           </p:cNvPr>
@@ -19840,7 +19961,7 @@
     </p:spTree>
     <p:extLst>
       <p:ext uri="{BB962C8B-B14F-4D97-AF65-F5344CB8AC3E}">
-        <p14:creationId xmlns:p14="http://schemas.microsoft.com/office/powerpoint/2010/main" val="1703847996"/>
+        <p14:creationId xmlns:p14="http://schemas.microsoft.com/office/powerpoint/2010/main" val="780715048"/>
       </p:ext>
     </p:extLst>
   </p:cSld>
@@ -19871,7 +19992,7 @@
           <p:cNvPr id="12" name="">
             <a:extLst xmlns:a="http://schemas.openxmlformats.org/drawingml/2006/main">
               <a:ext uri="{FF2B5EF4-FFF2-40B4-BE49-F238E27FC236}">
-                <a16:creationId xmlns:a16="http://schemas.microsoft.com/office/drawing/2014/main" id="{093FB43B-0539-4C6B-BF59-273392564A00}"/>
+                <a16:creationId xmlns:a16="http://schemas.microsoft.com/office/drawing/2014/main" id="{28C5661C-DB1D-4A7F-AE5A-08EE884D9219}"/>
               </a:ext>
             </a:extLst>
           </p:cNvPr>
@@ -19992,7 +20113,7 @@
           <p:cNvPr id="2" name="">
             <a:extLst xmlns:a="http://schemas.openxmlformats.org/drawingml/2006/main">
               <a:ext uri="{FF2B5EF4-FFF2-40B4-BE49-F238E27FC236}">
-                <a16:creationId xmlns:a16="http://schemas.microsoft.com/office/drawing/2014/main" id="{9EF0364A-5B95-4995-A0AE-CA0AD16D665D}"/>
+                <a16:creationId xmlns:a16="http://schemas.microsoft.com/office/drawing/2014/main" id="{ECEFD2B0-954C-43C4-9765-CC33E7784E67}"/>
               </a:ext>
             </a:extLst>
           </p:cNvPr>
@@ -20113,7 +20234,7 @@
           <p:cNvPr id="3" name="">
             <a:extLst xmlns:a="http://schemas.openxmlformats.org/drawingml/2006/main">
               <a:ext uri="{FF2B5EF4-FFF2-40B4-BE49-F238E27FC236}">
-                <a16:creationId xmlns:a16="http://schemas.microsoft.com/office/drawing/2014/main" id="{E4624341-B1FB-4998-9545-FB6D91C190FF}"/>
+                <a16:creationId xmlns:a16="http://schemas.microsoft.com/office/drawing/2014/main" id="{4A516ED4-5D98-4060-B753-87DE9E913A75}"/>
               </a:ext>
             </a:extLst>
           </p:cNvPr>
@@ -20251,7 +20372,7 @@
           <p:cNvPr id="4" name="">
             <a:extLst xmlns:a="http://schemas.openxmlformats.org/drawingml/2006/main">
               <a:ext uri="{FF2B5EF4-FFF2-40B4-BE49-F238E27FC236}">
-                <a16:creationId xmlns:a16="http://schemas.microsoft.com/office/drawing/2014/main" id="{065A24EB-BE69-4EE6-BF39-7F0A896AA6DE}"/>
+                <a16:creationId xmlns:a16="http://schemas.microsoft.com/office/drawing/2014/main" id="{FA776D46-F139-46FC-A5F9-5A38824179F6}"/>
               </a:ext>
             </a:extLst>
           </p:cNvPr>
@@ -20372,7 +20493,7 @@
           <p:cNvPr id="5" name="">
             <a:extLst xmlns:a="http://schemas.openxmlformats.org/drawingml/2006/main">
               <a:ext uri="{FF2B5EF4-FFF2-40B4-BE49-F238E27FC236}">
-                <a16:creationId xmlns:a16="http://schemas.microsoft.com/office/drawing/2014/main" id="{78EBA203-E73A-4830-98E0-ECF1AF197169}"/>
+                <a16:creationId xmlns:a16="http://schemas.microsoft.com/office/drawing/2014/main" id="{2008EFC9-0929-4010-B111-62E4F5672C27}"/>
               </a:ext>
             </a:extLst>
           </p:cNvPr>
@@ -20510,7 +20631,7 @@
           <p:cNvPr id="6" name="">
             <a:extLst xmlns:a="http://schemas.openxmlformats.org/drawingml/2006/main">
               <a:ext uri="{FF2B5EF4-FFF2-40B4-BE49-F238E27FC236}">
-                <a16:creationId xmlns:a16="http://schemas.microsoft.com/office/drawing/2014/main" id="{1E24C049-472A-45C0-8F13-287B59F53B6D}"/>
+                <a16:creationId xmlns:a16="http://schemas.microsoft.com/office/drawing/2014/main" id="{C635FB04-CF7A-45FD-B750-0CD4E206D766}"/>
               </a:ext>
             </a:extLst>
           </p:cNvPr>
@@ -20631,7 +20752,7 @@
           <p:cNvPr id="7" name="">
             <a:extLst xmlns:a="http://schemas.openxmlformats.org/drawingml/2006/main">
               <a:ext uri="{FF2B5EF4-FFF2-40B4-BE49-F238E27FC236}">
-                <a16:creationId xmlns:a16="http://schemas.microsoft.com/office/drawing/2014/main" id="{1947AAA9-62C4-4E56-8427-53CC8B67097B}"/>
+                <a16:creationId xmlns:a16="http://schemas.microsoft.com/office/drawing/2014/main" id="{CF5A1095-E34A-4349-B1F4-E3656FB4C303}"/>
               </a:ext>
             </a:extLst>
           </p:cNvPr>
@@ -20769,7 +20890,7 @@
           <p:cNvPr id="8" name="">
             <a:extLst xmlns:a="http://schemas.openxmlformats.org/drawingml/2006/main">
               <a:ext uri="{FF2B5EF4-FFF2-40B4-BE49-F238E27FC236}">
-                <a16:creationId xmlns:a16="http://schemas.microsoft.com/office/drawing/2014/main" id="{A32D87C2-EB59-4DA5-9253-1E3F60409431}"/>
+                <a16:creationId xmlns:a16="http://schemas.microsoft.com/office/drawing/2014/main" id="{190E056C-16E6-42A7-A69E-94BBAA240E4C}"/>
               </a:ext>
             </a:extLst>
           </p:cNvPr>
@@ -20890,7 +21011,7 @@
           <p:cNvPr id="9" name="">
             <a:extLst xmlns:a="http://schemas.openxmlformats.org/drawingml/2006/main">
               <a:ext uri="{FF2B5EF4-FFF2-40B4-BE49-F238E27FC236}">
-                <a16:creationId xmlns:a16="http://schemas.microsoft.com/office/drawing/2014/main" id="{E8DD0C6A-7B2C-4C63-947F-061B228E50C3}"/>
+                <a16:creationId xmlns:a16="http://schemas.microsoft.com/office/drawing/2014/main" id="{53FA465A-D9C4-4DA4-8EC1-AF3B5F0ABAF1}"/>
               </a:ext>
             </a:extLst>
           </p:cNvPr>
@@ -21028,7 +21149,7 @@
           <p:cNvPr id="10" name="">
             <a:extLst xmlns:a="http://schemas.openxmlformats.org/drawingml/2006/main">
               <a:ext uri="{FF2B5EF4-FFF2-40B4-BE49-F238E27FC236}">
-                <a16:creationId xmlns:a16="http://schemas.microsoft.com/office/drawing/2014/main" id="{202E0FBA-C5CF-4346-9F25-ED8AC646D5CB}"/>
+                <a16:creationId xmlns:a16="http://schemas.microsoft.com/office/drawing/2014/main" id="{369446E6-472F-4097-AB88-FC574A85E83A}"/>
               </a:ext>
             </a:extLst>
           </p:cNvPr>
@@ -21149,7 +21270,7 @@
           <p:cNvPr id="11" name="">
             <a:extLst xmlns:a="http://schemas.openxmlformats.org/drawingml/2006/main">
               <a:ext uri="{FF2B5EF4-FFF2-40B4-BE49-F238E27FC236}">
-                <a16:creationId xmlns:a16="http://schemas.microsoft.com/office/drawing/2014/main" id="{DBD1AC17-F96E-4F4D-9012-667E7F09E130}"/>
+                <a16:creationId xmlns:a16="http://schemas.microsoft.com/office/drawing/2014/main" id="{7E3E5ED9-9CEB-47DD-A182-23DBB4D09DDB}"/>
               </a:ext>
             </a:extLst>
           </p:cNvPr>
@@ -21268,7 +21389,7 @@
     </p:spTree>
     <p:extLst>
       <p:ext uri="{BB962C8B-B14F-4D97-AF65-F5344CB8AC3E}">
-        <p14:creationId xmlns:p14="http://schemas.microsoft.com/office/powerpoint/2010/main" val="1219806448"/>
+        <p14:creationId xmlns:p14="http://schemas.microsoft.com/office/powerpoint/2010/main" val="18059213"/>
       </p:ext>
     </p:extLst>
   </p:cSld>
@@ -21299,7 +21420,7 @@
           <p:cNvPr id="9" name="">
             <a:extLst xmlns:a="http://schemas.openxmlformats.org/drawingml/2006/main">
               <a:ext uri="{FF2B5EF4-FFF2-40B4-BE49-F238E27FC236}">
-                <a16:creationId xmlns:a16="http://schemas.microsoft.com/office/drawing/2014/main" id="{7452BBE7-0799-46A8-97C0-138B748C0CD9}"/>
+                <a16:creationId xmlns:a16="http://schemas.microsoft.com/office/drawing/2014/main" id="{C3BE6D66-45A0-4DBD-93CE-2D92AED34819}"/>
               </a:ext>
             </a:extLst>
           </p:cNvPr>
@@ -21420,7 +21541,7 @@
           <p:cNvPr id="2" name="">
             <a:extLst xmlns:a="http://schemas.openxmlformats.org/drawingml/2006/main">
               <a:ext uri="{FF2B5EF4-FFF2-40B4-BE49-F238E27FC236}">
-                <a16:creationId xmlns:a16="http://schemas.microsoft.com/office/drawing/2014/main" id="{23398108-5B12-49DF-898E-27DFBD72BF0C}"/>
+                <a16:creationId xmlns:a16="http://schemas.microsoft.com/office/drawing/2014/main" id="{12FBBC4C-3306-41FD-B0F3-7704ECF01577}"/>
               </a:ext>
             </a:extLst>
           </p:cNvPr>
@@ -21541,7 +21662,7 @@
           <p:cNvPr id="3" name="">
             <a:extLst xmlns:a="http://schemas.openxmlformats.org/drawingml/2006/main">
               <a:ext uri="{FF2B5EF4-FFF2-40B4-BE49-F238E27FC236}">
-                <a16:creationId xmlns:a16="http://schemas.microsoft.com/office/drawing/2014/main" id="{B665E5A1-02F6-4752-B59C-08F286BE5A4A}"/>
+                <a16:creationId xmlns:a16="http://schemas.microsoft.com/office/drawing/2014/main" id="{2A7B0BCF-10DA-40F4-9EA4-8A2C8BE0E4D9}"/>
               </a:ext>
             </a:extLst>
           </p:cNvPr>
@@ -21662,7 +21783,7 @@
           <p:cNvPr id="4" name="">
             <a:extLst xmlns:a="http://schemas.openxmlformats.org/drawingml/2006/main">
               <a:ext uri="{FF2B5EF4-FFF2-40B4-BE49-F238E27FC236}">
-                <a16:creationId xmlns:a16="http://schemas.microsoft.com/office/drawing/2014/main" id="{BBFEF614-9321-459A-A55D-514DAADA435A}"/>
+                <a16:creationId xmlns:a16="http://schemas.microsoft.com/office/drawing/2014/main" id="{71F4BFA6-AC15-43A3-8B76-1F0EDDCB5180}"/>
               </a:ext>
             </a:extLst>
           </p:cNvPr>
@@ -21817,7 +21938,7 @@
           <p:cNvPr id="5" name="">
             <a:extLst xmlns:a="http://schemas.openxmlformats.org/drawingml/2006/main">
               <a:ext uri="{FF2B5EF4-FFF2-40B4-BE49-F238E27FC236}">
-                <a16:creationId xmlns:a16="http://schemas.microsoft.com/office/drawing/2014/main" id="{BCF701FF-2604-477C-88F2-75F7669A58C0}"/>
+                <a16:creationId xmlns:a16="http://schemas.microsoft.com/office/drawing/2014/main" id="{9D6F9A5E-DA9F-42A7-ADCA-6637F951D9AA}"/>
               </a:ext>
             </a:extLst>
           </p:cNvPr>
@@ -21938,7 +22059,7 @@
           <p:cNvPr id="6" name="">
             <a:extLst xmlns:a="http://schemas.openxmlformats.org/drawingml/2006/main">
               <a:ext uri="{FF2B5EF4-FFF2-40B4-BE49-F238E27FC236}">
-                <a16:creationId xmlns:a16="http://schemas.microsoft.com/office/drawing/2014/main" id="{CE2104F1-8F4A-4BBB-A805-47D7982CCE56}"/>
+                <a16:creationId xmlns:a16="http://schemas.microsoft.com/office/drawing/2014/main" id="{89D2EE0C-AE22-42B7-BD61-0C76F9DB17F1}"/>
               </a:ext>
             </a:extLst>
           </p:cNvPr>
@@ -22093,7 +22214,7 @@
           <p:cNvPr id="7" name="">
             <a:extLst xmlns:a="http://schemas.openxmlformats.org/drawingml/2006/main">
               <a:ext uri="{FF2B5EF4-FFF2-40B4-BE49-F238E27FC236}">
-                <a16:creationId xmlns:a16="http://schemas.microsoft.com/office/drawing/2014/main" id="{2ECE68F9-57DA-4C43-8905-BFA101EF1475}"/>
+                <a16:creationId xmlns:a16="http://schemas.microsoft.com/office/drawing/2014/main" id="{CB108D16-23C2-4F70-80F1-B1DC2680E29D}"/>
               </a:ext>
             </a:extLst>
           </p:cNvPr>
@@ -22214,7 +22335,7 @@
           <p:cNvPr id="8" name="">
             <a:extLst xmlns:a="http://schemas.openxmlformats.org/drawingml/2006/main">
               <a:ext uri="{FF2B5EF4-FFF2-40B4-BE49-F238E27FC236}">
-                <a16:creationId xmlns:a16="http://schemas.microsoft.com/office/drawing/2014/main" id="{8CFB228E-5037-430D-B47E-0B4B952ABD42}"/>
+                <a16:creationId xmlns:a16="http://schemas.microsoft.com/office/drawing/2014/main" id="{EE585D90-853F-45B8-980F-FF05372B22B2}"/>
               </a:ext>
             </a:extLst>
           </p:cNvPr>
@@ -22333,7 +22454,7 @@
     </p:spTree>
     <p:extLst>
       <p:ext uri="{BB962C8B-B14F-4D97-AF65-F5344CB8AC3E}">
-        <p14:creationId xmlns:p14="http://schemas.microsoft.com/office/powerpoint/2010/main" val="1126267867"/>
+        <p14:creationId xmlns:p14="http://schemas.microsoft.com/office/powerpoint/2010/main" val="294605948"/>
       </p:ext>
     </p:extLst>
   </p:cSld>
@@ -22364,7 +22485,7 @@
           <p:cNvPr id="11" name="">
             <a:extLst xmlns:a="http://schemas.openxmlformats.org/drawingml/2006/main">
               <a:ext uri="{FF2B5EF4-FFF2-40B4-BE49-F238E27FC236}">
-                <a16:creationId xmlns:a16="http://schemas.microsoft.com/office/drawing/2014/main" id="{D1D42141-F93A-46A4-9B52-F736DEB9A260}"/>
+                <a16:creationId xmlns:a16="http://schemas.microsoft.com/office/drawing/2014/main" id="{715A5037-C54F-41D7-A80A-7DAF30ACFB1F}"/>
               </a:ext>
             </a:extLst>
           </p:cNvPr>
@@ -22485,7 +22606,7 @@
           <p:cNvPr id="2" name="">
             <a:extLst xmlns:a="http://schemas.openxmlformats.org/drawingml/2006/main">
               <a:ext uri="{FF2B5EF4-FFF2-40B4-BE49-F238E27FC236}">
-                <a16:creationId xmlns:a16="http://schemas.microsoft.com/office/drawing/2014/main" id="{53A879A0-92EC-409F-A6B8-13B26C155AC7}"/>
+                <a16:creationId xmlns:a16="http://schemas.microsoft.com/office/drawing/2014/main" id="{52DE1F44-BD25-4967-8F81-3FF3FEB641AE}"/>
               </a:ext>
             </a:extLst>
           </p:cNvPr>
@@ -22606,7 +22727,7 @@
           <p:cNvPr id="3" name="">
             <a:extLst xmlns:a="http://schemas.openxmlformats.org/drawingml/2006/main">
               <a:ext uri="{FF2B5EF4-FFF2-40B4-BE49-F238E27FC236}">
-                <a16:creationId xmlns:a16="http://schemas.microsoft.com/office/drawing/2014/main" id="{A43F7789-6AE3-4F3A-BB48-A720457ADAFD}"/>
+                <a16:creationId xmlns:a16="http://schemas.microsoft.com/office/drawing/2014/main" id="{A3337AA8-F245-43A5-A27A-86E86E51D84A}"/>
               </a:ext>
             </a:extLst>
           </p:cNvPr>
@@ -22744,7 +22865,7 @@
           <p:cNvPr id="4" name="">
             <a:extLst xmlns:a="http://schemas.openxmlformats.org/drawingml/2006/main">
               <a:ext uri="{FF2B5EF4-FFF2-40B4-BE49-F238E27FC236}">
-                <a16:creationId xmlns:a16="http://schemas.microsoft.com/office/drawing/2014/main" id="{3B7348E5-3E5C-4148-B48D-40F8C882B168}"/>
+                <a16:creationId xmlns:a16="http://schemas.microsoft.com/office/drawing/2014/main" id="{23263847-0C12-4909-B577-7CA52A619CC1}"/>
               </a:ext>
             </a:extLst>
           </p:cNvPr>
@@ -22865,7 +22986,7 @@
           <p:cNvPr id="5" name="">
             <a:extLst xmlns:a="http://schemas.openxmlformats.org/drawingml/2006/main">
               <a:ext uri="{FF2B5EF4-FFF2-40B4-BE49-F238E27FC236}">
-                <a16:creationId xmlns:a16="http://schemas.microsoft.com/office/drawing/2014/main" id="{5495835A-7261-413A-93F8-6822222049D8}"/>
+                <a16:creationId xmlns:a16="http://schemas.microsoft.com/office/drawing/2014/main" id="{838FB2C7-1219-4503-A71D-D7736A443FD2}"/>
               </a:ext>
             </a:extLst>
           </p:cNvPr>
@@ -23003,7 +23124,7 @@
           <p:cNvPr id="6" name="">
             <a:extLst xmlns:a="http://schemas.openxmlformats.org/drawingml/2006/main">
               <a:ext uri="{FF2B5EF4-FFF2-40B4-BE49-F238E27FC236}">
-                <a16:creationId xmlns:a16="http://schemas.microsoft.com/office/drawing/2014/main" id="{CD54954B-17E8-4EF9-A0C6-FC390B24EA1C}"/>
+                <a16:creationId xmlns:a16="http://schemas.microsoft.com/office/drawing/2014/main" id="{3CE1D2F9-9A00-4DE0-8C4E-AE3A6359BF24}"/>
               </a:ext>
             </a:extLst>
           </p:cNvPr>
@@ -23124,7 +23245,7 @@
           <p:cNvPr id="7" name="">
             <a:extLst xmlns:a="http://schemas.openxmlformats.org/drawingml/2006/main">
               <a:ext uri="{FF2B5EF4-FFF2-40B4-BE49-F238E27FC236}">
-                <a16:creationId xmlns:a16="http://schemas.microsoft.com/office/drawing/2014/main" id="{C93CC3AF-1761-48F7-AEA7-118B10E38D75}"/>
+                <a16:creationId xmlns:a16="http://schemas.microsoft.com/office/drawing/2014/main" id="{A1590E1F-6A76-4719-95B3-C9803D6BFBC6}"/>
               </a:ext>
             </a:extLst>
           </p:cNvPr>
@@ -23262,7 +23383,7 @@
           <p:cNvPr id="8" name="">
             <a:extLst xmlns:a="http://schemas.openxmlformats.org/drawingml/2006/main">
               <a:ext uri="{FF2B5EF4-FFF2-40B4-BE49-F238E27FC236}">
-                <a16:creationId xmlns:a16="http://schemas.microsoft.com/office/drawing/2014/main" id="{3DEB6B4F-0DE1-4B48-9D33-8F15C716879E}"/>
+                <a16:creationId xmlns:a16="http://schemas.microsoft.com/office/drawing/2014/main" id="{83843A91-591B-472F-8E77-51C835FF17DD}"/>
               </a:ext>
             </a:extLst>
           </p:cNvPr>
@@ -23383,7 +23504,7 @@
           <p:cNvPr id="9" name="">
             <a:extLst xmlns:a="http://schemas.openxmlformats.org/drawingml/2006/main">
               <a:ext uri="{FF2B5EF4-FFF2-40B4-BE49-F238E27FC236}">
-                <a16:creationId xmlns:a16="http://schemas.microsoft.com/office/drawing/2014/main" id="{607F735F-376D-4E96-9AF3-F3345A5BB3F7}"/>
+                <a16:creationId xmlns:a16="http://schemas.microsoft.com/office/drawing/2014/main" id="{E8DC104F-6F15-4E0A-9DCD-F3B6A26EDF8D}"/>
               </a:ext>
             </a:extLst>
           </p:cNvPr>
@@ -23504,7 +23625,7 @@
           <p:cNvPr id="10" name="">
             <a:extLst xmlns:a="http://schemas.openxmlformats.org/drawingml/2006/main">
               <a:ext uri="{FF2B5EF4-FFF2-40B4-BE49-F238E27FC236}">
-                <a16:creationId xmlns:a16="http://schemas.microsoft.com/office/drawing/2014/main" id="{0A7FC305-5377-4EF1-A61B-E86E66A7F3B1}"/>
+                <a16:creationId xmlns:a16="http://schemas.microsoft.com/office/drawing/2014/main" id="{3D2A59E4-2CA6-4148-A0E8-7C5D06AB3F20}"/>
               </a:ext>
             </a:extLst>
           </p:cNvPr>
@@ -23623,7 +23744,7 @@
     </p:spTree>
     <p:extLst>
       <p:ext uri="{BB962C8B-B14F-4D97-AF65-F5344CB8AC3E}">
-        <p14:creationId xmlns:p14="http://schemas.microsoft.com/office/powerpoint/2010/main" val="961230437"/>
+        <p14:creationId xmlns:p14="http://schemas.microsoft.com/office/powerpoint/2010/main" val="107465773"/>
       </p:ext>
     </p:extLst>
   </p:cSld>
@@ -23654,7 +23775,7 @@
           <p:cNvPr id="13" name="">
             <a:extLst xmlns:a="http://schemas.openxmlformats.org/drawingml/2006/main">
               <a:ext uri="{FF2B5EF4-FFF2-40B4-BE49-F238E27FC236}">
-                <a16:creationId xmlns:a16="http://schemas.microsoft.com/office/drawing/2014/main" id="{B05BFCF0-194F-4C4F-ACAC-FDD22A417E33}"/>
+                <a16:creationId xmlns:a16="http://schemas.microsoft.com/office/drawing/2014/main" id="{A48B664E-7267-4CBA-B66A-6874861F0CE0}"/>
               </a:ext>
             </a:extLst>
           </p:cNvPr>
@@ -23775,7 +23896,7 @@
           <p:cNvPr id="2" name="">
             <a:extLst xmlns:a="http://schemas.openxmlformats.org/drawingml/2006/main">
               <a:ext uri="{FF2B5EF4-FFF2-40B4-BE49-F238E27FC236}">
-                <a16:creationId xmlns:a16="http://schemas.microsoft.com/office/drawing/2014/main" id="{BBB0DBAB-93C4-4841-BB2D-2553012DEA02}"/>
+                <a16:creationId xmlns:a16="http://schemas.microsoft.com/office/drawing/2014/main" id="{CB0920BF-E0C5-43F7-8AFB-3BAECFC052FF}"/>
               </a:ext>
             </a:extLst>
           </p:cNvPr>
@@ -23896,7 +24017,7 @@
           <p:cNvPr id="3" name="">
             <a:extLst xmlns:a="http://schemas.openxmlformats.org/drawingml/2006/main">
               <a:ext uri="{FF2B5EF4-FFF2-40B4-BE49-F238E27FC236}">
-                <a16:creationId xmlns:a16="http://schemas.microsoft.com/office/drawing/2014/main" id="{ECB98030-5255-4E45-9649-3043CB7EA18B}"/>
+                <a16:creationId xmlns:a16="http://schemas.microsoft.com/office/drawing/2014/main" id="{F470284A-9E06-47F5-8118-151F59CD7DA5}"/>
               </a:ext>
             </a:extLst>
           </p:cNvPr>
@@ -24017,7 +24138,7 @@
           <p:cNvPr id="4" name="">
             <a:extLst xmlns:a="http://schemas.openxmlformats.org/drawingml/2006/main">
               <a:ext uri="{FF2B5EF4-FFF2-40B4-BE49-F238E27FC236}">
-                <a16:creationId xmlns:a16="http://schemas.microsoft.com/office/drawing/2014/main" id="{22E70B43-B6F1-4ED2-AF68-CCC7AF2EFA2B}"/>
+                <a16:creationId xmlns:a16="http://schemas.microsoft.com/office/drawing/2014/main" id="{F6F52A75-8319-48C2-95F3-790DB96CB6EA}"/>
               </a:ext>
             </a:extLst>
           </p:cNvPr>
@@ -24138,7 +24259,7 @@
           <p:cNvPr id="5" name="">
             <a:extLst xmlns:a="http://schemas.openxmlformats.org/drawingml/2006/main">
               <a:ext uri="{FF2B5EF4-FFF2-40B4-BE49-F238E27FC236}">
-                <a16:creationId xmlns:a16="http://schemas.microsoft.com/office/drawing/2014/main" id="{36535723-E87D-4E65-8AFA-B03EBC0D4960}"/>
+                <a16:creationId xmlns:a16="http://schemas.microsoft.com/office/drawing/2014/main" id="{E2A24D4F-D52C-4630-8CF4-5F50B72C09A3}"/>
               </a:ext>
             </a:extLst>
           </p:cNvPr>
@@ -24259,7 +24380,7 @@
           <p:cNvPr id="6" name="">
             <a:extLst xmlns:a="http://schemas.openxmlformats.org/drawingml/2006/main">
               <a:ext uri="{FF2B5EF4-FFF2-40B4-BE49-F238E27FC236}">
-                <a16:creationId xmlns:a16="http://schemas.microsoft.com/office/drawing/2014/main" id="{A3490C34-085B-46F1-BDB7-AF825D765928}"/>
+                <a16:creationId xmlns:a16="http://schemas.microsoft.com/office/drawing/2014/main" id="{8E6D8A2B-1947-4E33-91EC-9515DAEB6052}"/>
               </a:ext>
             </a:extLst>
           </p:cNvPr>
@@ -24380,7 +24501,7 @@
           <p:cNvPr id="7" name="">
             <a:extLst xmlns:a="http://schemas.openxmlformats.org/drawingml/2006/main">
               <a:ext uri="{FF2B5EF4-FFF2-40B4-BE49-F238E27FC236}">
-                <a16:creationId xmlns:a16="http://schemas.microsoft.com/office/drawing/2014/main" id="{5976CEB2-0E81-4A23-831B-16F7294B79B5}"/>
+                <a16:creationId xmlns:a16="http://schemas.microsoft.com/office/drawing/2014/main" id="{9678E90D-7D73-4507-813D-96588920A33A}"/>
               </a:ext>
             </a:extLst>
           </p:cNvPr>
@@ -24501,7 +24622,7 @@
           <p:cNvPr id="8" name="">
             <a:extLst xmlns:a="http://schemas.openxmlformats.org/drawingml/2006/main">
               <a:ext uri="{FF2B5EF4-FFF2-40B4-BE49-F238E27FC236}">
-                <a16:creationId xmlns:a16="http://schemas.microsoft.com/office/drawing/2014/main" id="{AE016F50-94E5-4898-837C-2EF1A3247542}"/>
+                <a16:creationId xmlns:a16="http://schemas.microsoft.com/office/drawing/2014/main" id="{0C1E2C44-1FA9-4EA9-BDF3-EAD5DEF2020B}"/>
               </a:ext>
             </a:extLst>
           </p:cNvPr>
@@ -24622,7 +24743,7 @@
           <p:cNvPr id="9" name="">
             <a:extLst xmlns:a="http://schemas.openxmlformats.org/drawingml/2006/main">
               <a:ext uri="{FF2B5EF4-FFF2-40B4-BE49-F238E27FC236}">
-                <a16:creationId xmlns:a16="http://schemas.microsoft.com/office/drawing/2014/main" id="{23DD098D-DBD2-490B-AB14-1AB4D4192FD4}"/>
+                <a16:creationId xmlns:a16="http://schemas.microsoft.com/office/drawing/2014/main" id="{26B01A9D-FBD7-4F87-86DD-283F3B863952}"/>
               </a:ext>
             </a:extLst>
           </p:cNvPr>
@@ -24743,7 +24864,7 @@
           <p:cNvPr id="10" name="">
             <a:extLst xmlns:a="http://schemas.openxmlformats.org/drawingml/2006/main">
               <a:ext uri="{FF2B5EF4-FFF2-40B4-BE49-F238E27FC236}">
-                <a16:creationId xmlns:a16="http://schemas.microsoft.com/office/drawing/2014/main" id="{5A7E6F0F-A3DC-48E3-BBE0-D4E899E64227}"/>
+                <a16:creationId xmlns:a16="http://schemas.microsoft.com/office/drawing/2014/main" id="{809A38E4-EEEE-42AF-AF8A-D5F539816C47}"/>
               </a:ext>
             </a:extLst>
           </p:cNvPr>
@@ -24864,7 +24985,7 @@
           <p:cNvPr id="11" name="">
             <a:extLst xmlns:a="http://schemas.openxmlformats.org/drawingml/2006/main">
               <a:ext uri="{FF2B5EF4-FFF2-40B4-BE49-F238E27FC236}">
-                <a16:creationId xmlns:a16="http://schemas.microsoft.com/office/drawing/2014/main" id="{1F4B8A3A-A133-48B1-8B91-8FA79B280236}"/>
+                <a16:creationId xmlns:a16="http://schemas.microsoft.com/office/drawing/2014/main" id="{510AE902-0020-4EB6-B295-9DC2A892A784}"/>
               </a:ext>
             </a:extLst>
           </p:cNvPr>
@@ -24985,7 +25106,7 @@
           <p:cNvPr id="12" name="">
             <a:extLst xmlns:a="http://schemas.openxmlformats.org/drawingml/2006/main">
               <a:ext uri="{FF2B5EF4-FFF2-40B4-BE49-F238E27FC236}">
-                <a16:creationId xmlns:a16="http://schemas.microsoft.com/office/drawing/2014/main" id="{BFAC86C2-77CB-4581-810A-8B1BB68BD892}"/>
+                <a16:creationId xmlns:a16="http://schemas.microsoft.com/office/drawing/2014/main" id="{D1633423-68B9-4D07-AF2B-4540104378D5}"/>
               </a:ext>
             </a:extLst>
           </p:cNvPr>
@@ -25104,7 +25225,7 @@
     </p:spTree>
     <p:extLst>
       <p:ext uri="{BB962C8B-B14F-4D97-AF65-F5344CB8AC3E}">
-        <p14:creationId xmlns:p14="http://schemas.microsoft.com/office/powerpoint/2010/main" val="129244155"/>
+        <p14:creationId xmlns:p14="http://schemas.microsoft.com/office/powerpoint/2010/main" val="1200632992"/>
       </p:ext>
     </p:extLst>
   </p:cSld>
@@ -25135,7 +25256,7 @@
           <p:cNvPr id="24" name="">
             <a:extLst xmlns:a="http://schemas.openxmlformats.org/drawingml/2006/main">
               <a:ext uri="{FF2B5EF4-FFF2-40B4-BE49-F238E27FC236}">
-                <a16:creationId xmlns:a16="http://schemas.microsoft.com/office/drawing/2014/main" id="{DB99ECC2-E94A-43F9-A75F-72107C34560C}"/>
+                <a16:creationId xmlns:a16="http://schemas.microsoft.com/office/drawing/2014/main" id="{B904DFC0-B40D-4F6A-AC07-0F09929EB8C8}"/>
               </a:ext>
             </a:extLst>
           </p:cNvPr>
@@ -25256,7 +25377,7 @@
           <p:cNvPr id="2" name="">
             <a:extLst xmlns:a="http://schemas.openxmlformats.org/drawingml/2006/main">
               <a:ext uri="{FF2B5EF4-FFF2-40B4-BE49-F238E27FC236}">
-                <a16:creationId xmlns:a16="http://schemas.microsoft.com/office/drawing/2014/main" id="{840FC12B-005B-454E-BEC1-7DBF1CCFD86A}"/>
+                <a16:creationId xmlns:a16="http://schemas.microsoft.com/office/drawing/2014/main" id="{5B10D99F-E62A-4087-B2B6-99957150C66F}"/>
               </a:ext>
             </a:extLst>
           </p:cNvPr>
@@ -25377,7 +25498,7 @@
           <p:cNvPr id="3" name="">
             <a:extLst xmlns:a="http://schemas.openxmlformats.org/drawingml/2006/main">
               <a:ext uri="{FF2B5EF4-FFF2-40B4-BE49-F238E27FC236}">
-                <a16:creationId xmlns:a16="http://schemas.microsoft.com/office/drawing/2014/main" id="{3152F1E0-B7A6-4F83-B141-26042D6AB60B}"/>
+                <a16:creationId xmlns:a16="http://schemas.microsoft.com/office/drawing/2014/main" id="{03F75FCE-2B02-49FF-BB8C-F5DB2136ED7A}"/>
               </a:ext>
             </a:extLst>
           </p:cNvPr>
@@ -25498,7 +25619,7 @@
           <p:cNvPr id="4" name="">
             <a:extLst xmlns:a="http://schemas.openxmlformats.org/drawingml/2006/main">
               <a:ext uri="{FF2B5EF4-FFF2-40B4-BE49-F238E27FC236}">
-                <a16:creationId xmlns:a16="http://schemas.microsoft.com/office/drawing/2014/main" id="{92F98986-EDE4-4248-B8EF-39C658D3E83C}"/>
+                <a16:creationId xmlns:a16="http://schemas.microsoft.com/office/drawing/2014/main" id="{38CA8260-8C30-4C80-8A7E-894E2701D8D3}"/>
               </a:ext>
             </a:extLst>
           </p:cNvPr>
@@ -25619,7 +25740,7 @@
           <p:cNvPr id="5" name="">
             <a:extLst xmlns:a="http://schemas.openxmlformats.org/drawingml/2006/main">
               <a:ext uri="{FF2B5EF4-FFF2-40B4-BE49-F238E27FC236}">
-                <a16:creationId xmlns:a16="http://schemas.microsoft.com/office/drawing/2014/main" id="{4BFE675C-467B-4B36-8220-E025BD0D334A}"/>
+                <a16:creationId xmlns:a16="http://schemas.microsoft.com/office/drawing/2014/main" id="{003B2757-715E-4DA0-9E62-CB6A9F6DCF69}"/>
               </a:ext>
             </a:extLst>
           </p:cNvPr>
@@ -25740,7 +25861,7 @@
           <p:cNvPr id="6" name="">
             <a:extLst xmlns:a="http://schemas.openxmlformats.org/drawingml/2006/main">
               <a:ext uri="{FF2B5EF4-FFF2-40B4-BE49-F238E27FC236}">
-                <a16:creationId xmlns:a16="http://schemas.microsoft.com/office/drawing/2014/main" id="{549F1A09-5E27-4CF0-86DB-8980DA7E4E2F}"/>
+                <a16:creationId xmlns:a16="http://schemas.microsoft.com/office/drawing/2014/main" id="{2A7A31D4-AEB7-414C-AE50-06A67F30CE7D}"/>
               </a:ext>
             </a:extLst>
           </p:cNvPr>
@@ -25861,7 +25982,7 @@
           <p:cNvPr id="7" name="">
             <a:extLst xmlns:a="http://schemas.openxmlformats.org/drawingml/2006/main">
               <a:ext uri="{FF2B5EF4-FFF2-40B4-BE49-F238E27FC236}">
-                <a16:creationId xmlns:a16="http://schemas.microsoft.com/office/drawing/2014/main" id="{2EB5E895-D66E-4562-8BC7-B03E3C21A157}"/>
+                <a16:creationId xmlns:a16="http://schemas.microsoft.com/office/drawing/2014/main" id="{BD86F368-D46C-44A4-933F-426BD0B4DCCF}"/>
               </a:ext>
             </a:extLst>
           </p:cNvPr>
@@ -25982,7 +26103,7 @@
           <p:cNvPr id="8" name="">
             <a:extLst xmlns:a="http://schemas.openxmlformats.org/drawingml/2006/main">
               <a:ext uri="{FF2B5EF4-FFF2-40B4-BE49-F238E27FC236}">
-                <a16:creationId xmlns:a16="http://schemas.microsoft.com/office/drawing/2014/main" id="{79D70A58-2252-4CB0-A432-F38E691E93EE}"/>
+                <a16:creationId xmlns:a16="http://schemas.microsoft.com/office/drawing/2014/main" id="{5BB46607-DEF9-4646-A71F-7F86FD5D23B8}"/>
               </a:ext>
             </a:extLst>
           </p:cNvPr>
@@ -26103,7 +26224,7 @@
           <p:cNvPr id="9" name="">
             <a:extLst xmlns:a="http://schemas.openxmlformats.org/drawingml/2006/main">
               <a:ext uri="{FF2B5EF4-FFF2-40B4-BE49-F238E27FC236}">
-                <a16:creationId xmlns:a16="http://schemas.microsoft.com/office/drawing/2014/main" id="{11439526-53C3-43AC-8281-39755CFD199C}"/>
+                <a16:creationId xmlns:a16="http://schemas.microsoft.com/office/drawing/2014/main" id="{493782C7-6799-471E-B6A5-A39E7D16AA95}"/>
               </a:ext>
             </a:extLst>
           </p:cNvPr>
@@ -26224,7 +26345,7 @@
           <p:cNvPr id="10" name="">
             <a:extLst xmlns:a="http://schemas.openxmlformats.org/drawingml/2006/main">
               <a:ext uri="{FF2B5EF4-FFF2-40B4-BE49-F238E27FC236}">
-                <a16:creationId xmlns:a16="http://schemas.microsoft.com/office/drawing/2014/main" id="{539D315A-8954-4D62-899F-E77C0B885BB9}"/>
+                <a16:creationId xmlns:a16="http://schemas.microsoft.com/office/drawing/2014/main" id="{BE5C7B83-8626-4C0A-ADE2-FE3F8730420C}"/>
               </a:ext>
             </a:extLst>
           </p:cNvPr>
@@ -26345,7 +26466,7 @@
           <p:cNvPr id="11" name="">
             <a:extLst xmlns:a="http://schemas.openxmlformats.org/drawingml/2006/main">
               <a:ext uri="{FF2B5EF4-FFF2-40B4-BE49-F238E27FC236}">
-                <a16:creationId xmlns:a16="http://schemas.microsoft.com/office/drawing/2014/main" id="{E6D7CE4A-0AEB-4B78-A71A-92D53CEFE299}"/>
+                <a16:creationId xmlns:a16="http://schemas.microsoft.com/office/drawing/2014/main" id="{F8621962-8469-4022-8A2A-2505E63B7C3D}"/>
               </a:ext>
             </a:extLst>
           </p:cNvPr>
@@ -26466,7 +26587,7 @@
           <p:cNvPr id="12" name="">
             <a:extLst xmlns:a="http://schemas.openxmlformats.org/drawingml/2006/main">
               <a:ext uri="{FF2B5EF4-FFF2-40B4-BE49-F238E27FC236}">
-                <a16:creationId xmlns:a16="http://schemas.microsoft.com/office/drawing/2014/main" id="{7221450A-EB78-439B-8AF8-BF6FC509BA7B}"/>
+                <a16:creationId xmlns:a16="http://schemas.microsoft.com/office/drawing/2014/main" id="{8E9D3994-0767-4FCD-A9D0-F799BAE086BF}"/>
               </a:ext>
             </a:extLst>
           </p:cNvPr>
@@ -26587,7 +26708,7 @@
           <p:cNvPr id="13" name="">
             <a:extLst xmlns:a="http://schemas.openxmlformats.org/drawingml/2006/main">
               <a:ext uri="{FF2B5EF4-FFF2-40B4-BE49-F238E27FC236}">
-                <a16:creationId xmlns:a16="http://schemas.microsoft.com/office/drawing/2014/main" id="{0846C580-9C92-4529-979E-739D992E2F35}"/>
+                <a16:creationId xmlns:a16="http://schemas.microsoft.com/office/drawing/2014/main" id="{FDEDC2CD-FBFB-48A2-91BA-8A8AC75B315F}"/>
               </a:ext>
             </a:extLst>
           </p:cNvPr>
@@ -26708,7 +26829,7 @@
           <p:cNvPr id="14" name="">
             <a:extLst xmlns:a="http://schemas.openxmlformats.org/drawingml/2006/main">
               <a:ext uri="{FF2B5EF4-FFF2-40B4-BE49-F238E27FC236}">
-                <a16:creationId xmlns:a16="http://schemas.microsoft.com/office/drawing/2014/main" id="{4C07545B-FBCE-47BC-96D6-845B2AE34503}"/>
+                <a16:creationId xmlns:a16="http://schemas.microsoft.com/office/drawing/2014/main" id="{4EF30EFF-C194-4B71-9F25-927CA9CFEC28}"/>
               </a:ext>
             </a:extLst>
           </p:cNvPr>
@@ -26829,7 +26950,7 @@
           <p:cNvPr id="15" name="">
             <a:extLst xmlns:a="http://schemas.openxmlformats.org/drawingml/2006/main">
               <a:ext uri="{FF2B5EF4-FFF2-40B4-BE49-F238E27FC236}">
-                <a16:creationId xmlns:a16="http://schemas.microsoft.com/office/drawing/2014/main" id="{4E4D8AEE-AEF4-447B-8577-A057C9E0DE67}"/>
+                <a16:creationId xmlns:a16="http://schemas.microsoft.com/office/drawing/2014/main" id="{B5346DDB-F7A7-427B-8ECD-D109C1F05646}"/>
               </a:ext>
             </a:extLst>
           </p:cNvPr>
@@ -26950,7 +27071,7 @@
           <p:cNvPr id="16" name="">
             <a:extLst xmlns:a="http://schemas.openxmlformats.org/drawingml/2006/main">
               <a:ext uri="{FF2B5EF4-FFF2-40B4-BE49-F238E27FC236}">
-                <a16:creationId xmlns:a16="http://schemas.microsoft.com/office/drawing/2014/main" id="{805F8EA1-3D51-428E-A4AC-61DA645F2D86}"/>
+                <a16:creationId xmlns:a16="http://schemas.microsoft.com/office/drawing/2014/main" id="{2884A5F9-E5A6-498D-AACD-AABD025DB6C5}"/>
               </a:ext>
             </a:extLst>
           </p:cNvPr>
@@ -27071,7 +27192,7 @@
           <p:cNvPr id="17" name="">
             <a:extLst xmlns:a="http://schemas.openxmlformats.org/drawingml/2006/main">
               <a:ext uri="{FF2B5EF4-FFF2-40B4-BE49-F238E27FC236}">
-                <a16:creationId xmlns:a16="http://schemas.microsoft.com/office/drawing/2014/main" id="{501513A0-F7CF-4BEE-853B-2197D9B22CD7}"/>
+                <a16:creationId xmlns:a16="http://schemas.microsoft.com/office/drawing/2014/main" id="{2E2DFCB5-A68E-442A-BCEF-20F4A0E4705C}"/>
               </a:ext>
             </a:extLst>
           </p:cNvPr>
@@ -27192,7 +27313,7 @@
           <p:cNvPr id="18" name="">
             <a:extLst xmlns:a="http://schemas.openxmlformats.org/drawingml/2006/main">
               <a:ext uri="{FF2B5EF4-FFF2-40B4-BE49-F238E27FC236}">
-                <a16:creationId xmlns:a16="http://schemas.microsoft.com/office/drawing/2014/main" id="{4475C7AB-4225-4BDB-B5E4-7D5317E8C369}"/>
+                <a16:creationId xmlns:a16="http://schemas.microsoft.com/office/drawing/2014/main" id="{FAB3F08C-6913-4509-8C5B-B26FF5520C12}"/>
               </a:ext>
             </a:extLst>
           </p:cNvPr>
@@ -27313,7 +27434,7 @@
           <p:cNvPr id="19" name="">
             <a:extLst xmlns:a="http://schemas.openxmlformats.org/drawingml/2006/main">
               <a:ext uri="{FF2B5EF4-FFF2-40B4-BE49-F238E27FC236}">
-                <a16:creationId xmlns:a16="http://schemas.microsoft.com/office/drawing/2014/main" id="{4283008F-7254-439A-A24A-A6B19CECEE4F}"/>
+                <a16:creationId xmlns:a16="http://schemas.microsoft.com/office/drawing/2014/main" id="{74700A69-837F-463C-9769-D94BAAE09392}"/>
               </a:ext>
             </a:extLst>
           </p:cNvPr>
@@ -27434,7 +27555,7 @@
           <p:cNvPr id="20" name="">
             <a:extLst xmlns:a="http://schemas.openxmlformats.org/drawingml/2006/main">
               <a:ext uri="{FF2B5EF4-FFF2-40B4-BE49-F238E27FC236}">
-                <a16:creationId xmlns:a16="http://schemas.microsoft.com/office/drawing/2014/main" id="{F7175E10-F2E1-414A-B0B1-F6DB5E4C3ECA}"/>
+                <a16:creationId xmlns:a16="http://schemas.microsoft.com/office/drawing/2014/main" id="{04F06DDA-6ABB-43D0-A0E5-0EB6E4214B6E}"/>
               </a:ext>
             </a:extLst>
           </p:cNvPr>
@@ -27555,7 +27676,7 @@
           <p:cNvPr id="21" name="">
             <a:extLst xmlns:a="http://schemas.openxmlformats.org/drawingml/2006/main">
               <a:ext uri="{FF2B5EF4-FFF2-40B4-BE49-F238E27FC236}">
-                <a16:creationId xmlns:a16="http://schemas.microsoft.com/office/drawing/2014/main" id="{19ED32CB-11E4-457C-AC07-91DD8889C77C}"/>
+                <a16:creationId xmlns:a16="http://schemas.microsoft.com/office/drawing/2014/main" id="{B0C72AC6-373E-4AD7-B032-1A9563D73D08}"/>
               </a:ext>
             </a:extLst>
           </p:cNvPr>
@@ -27676,7 +27797,7 @@
           <p:cNvPr id="22" name="">
             <a:extLst xmlns:a="http://schemas.openxmlformats.org/drawingml/2006/main">
               <a:ext uri="{FF2B5EF4-FFF2-40B4-BE49-F238E27FC236}">
-                <a16:creationId xmlns:a16="http://schemas.microsoft.com/office/drawing/2014/main" id="{F062DE1A-1EA3-4A91-ACBB-233400017593}"/>
+                <a16:creationId xmlns:a16="http://schemas.microsoft.com/office/drawing/2014/main" id="{AE78A233-0A3F-4DC9-A7F2-F21B8B62FEBC}"/>
               </a:ext>
             </a:extLst>
           </p:cNvPr>
@@ -27797,7 +27918,7 @@
           <p:cNvPr id="23" name="">
             <a:extLst xmlns:a="http://schemas.openxmlformats.org/drawingml/2006/main">
               <a:ext uri="{FF2B5EF4-FFF2-40B4-BE49-F238E27FC236}">
-                <a16:creationId xmlns:a16="http://schemas.microsoft.com/office/drawing/2014/main" id="{59046CDD-DCF3-4864-B616-2BC9FC3AD4E5}"/>
+                <a16:creationId xmlns:a16="http://schemas.microsoft.com/office/drawing/2014/main" id="{C8AC7667-2384-44AE-8752-F524D81144B0}"/>
               </a:ext>
             </a:extLst>
           </p:cNvPr>
@@ -27916,7 +28037,7 @@
     </p:spTree>
     <p:extLst>
       <p:ext uri="{BB962C8B-B14F-4D97-AF65-F5344CB8AC3E}">
-        <p14:creationId xmlns:p14="http://schemas.microsoft.com/office/powerpoint/2010/main" val="182734440"/>
+        <p14:creationId xmlns:p14="http://schemas.microsoft.com/office/powerpoint/2010/main" val="816209890"/>
       </p:ext>
     </p:extLst>
   </p:cSld>

</xml_diff>